<commit_message>
style(r1.0): unify deck helpers, mono flag runs, diagram scale, code auto-fit across 101 and 201
</commit_message>
<xml_diff>
--- a/presentation/helm-201/Helm-201-r1.0.pptx
+++ b/presentation/helm-201/Helm-201-r1.0.pptx
@@ -5280,12 +5280,6 @@
               <a:t># Stage 1: static checks, no cluster, every push
 </a:t>
             </a:r>
-            <a:pPr algn="l" indent="0" marL="0">
-              <a:lnSpc>
-                <a:spcPct val="110000"/>
-              </a:lnSpc>
-              <a:buNone/>
-            </a:pPr>
             <a:r>
               <a:rPr lang="en-US" sz="1800" dirty="0">
                 <a:solidFill>
@@ -5298,12 +5292,6 @@
               <a:t>helm lint --strict charts/shipping-service
 </a:t>
             </a:r>
-            <a:pPr algn="l" indent="0" marL="0">
-              <a:lnSpc>
-                <a:spcPct val="110000"/>
-              </a:lnSpc>
-              <a:buNone/>
-            </a:pPr>
             <a:r>
               <a:rPr lang="en-US" sz="1800" dirty="0">
                 <a:solidFill>
@@ -5316,12 +5304,6 @@
               <a:t>helm unittest charts/shipping-service
 </a:t>
             </a:r>
-            <a:pPr algn="l" indent="0" marL="0">
-              <a:lnSpc>
-                <a:spcPct val="110000"/>
-              </a:lnSpc>
-              <a:buNone/>
-            </a:pPr>
             <a:r>
               <a:rPr lang="en-US" sz="1800" dirty="0">
                 <a:solidFill>
@@ -5334,12 +5316,6 @@
               <a:t>helm template shipping charts/shipping-service \
 </a:t>
             </a:r>
-            <a:pPr algn="l" indent="0" marL="0">
-              <a:lnSpc>
-                <a:spcPct val="110000"/>
-              </a:lnSpc>
-              <a:buNone/>
-            </a:pPr>
             <a:r>
               <a:rPr lang="en-US" sz="1800" dirty="0">
                 <a:solidFill>
@@ -5352,12 +5328,6 @@
               <a:t>  -f charts/shipping-service/ci/ci-values.yaml \
 </a:t>
             </a:r>
-            <a:pPr algn="l" indent="0" marL="0">
-              <a:lnSpc>
-                <a:spcPct val="110000"/>
-              </a:lnSpc>
-              <a:buNone/>
-            </a:pPr>
             <a:r>
               <a:rPr lang="en-US" sz="1800" dirty="0">
                 <a:solidFill>
@@ -5370,12 +5340,6 @@
               <a:t>  | kubeconform -strict -summary
 </a:t>
             </a:r>
-            <a:pPr algn="l" indent="0" marL="0">
-              <a:lnSpc>
-                <a:spcPct val="110000"/>
-              </a:lnSpc>
-              <a:buNone/>
-            </a:pPr>
             <a:r>
               <a:rPr lang="en-US" sz="1800" dirty="0">
                 <a:solidFill>
@@ -5388,12 +5352,6 @@
               <a:t>ct lint --config ct.yaml --all
 </a:t>
             </a:r>
-            <a:pPr algn="l" indent="0" marL="0">
-              <a:lnSpc>
-                <a:spcPct val="110000"/>
-              </a:lnSpc>
-              <a:buNone/>
-            </a:pPr>
             <a:r>
               <a:rPr lang="en-US" sz="1800" dirty="0">
                 <a:solidFill>
@@ -5406,12 +5364,6 @@
               <a:t># Stage 2: install test on a throwaway cluster
 </a:t>
             </a:r>
-            <a:pPr algn="l" indent="0" marL="0">
-              <a:lnSpc>
-                <a:spcPct val="110000"/>
-              </a:lnSpc>
-              <a:buNone/>
-            </a:pPr>
             <a:r>
               <a:rPr lang="en-US" sz="1800" dirty="0">
                 <a:solidFill>
@@ -5424,12 +5376,6 @@
               <a:t>ct install --charts charts/shipping-service \
 </a:t>
             </a:r>
-            <a:pPr algn="l" indent="0" marL="0">
-              <a:lnSpc>
-                <a:spcPct val="110000"/>
-              </a:lnSpc>
-              <a:buNone/>
-            </a:pPr>
             <a:r>
               <a:rPr lang="en-US" sz="1800" dirty="0">
                 <a:solidFill>
@@ -5442,12 +5388,6 @@
               <a:t>  --helm-extra-args '--timeout 3m'
 </a:t>
             </a:r>
-            <a:pPr algn="l" indent="0" marL="0">
-              <a:lnSpc>
-                <a:spcPct val="110000"/>
-              </a:lnSpc>
-              <a:buNone/>
-            </a:pPr>
             <a:r>
               <a:rPr lang="en-US" sz="1800" dirty="0">
                 <a:solidFill>
@@ -5460,12 +5400,6 @@
               <a:t># Stage 3: publish on a version tag
 </a:t>
             </a:r>
-            <a:pPr algn="l" indent="0" marL="0">
-              <a:lnSpc>
-                <a:spcPct val="110000"/>
-              </a:lnSpc>
-              <a:buNone/>
-            </a:pPr>
             <a:r>
               <a:rPr lang="en-US" sz="1800" dirty="0">
                 <a:solidFill>
@@ -5478,12 +5412,6 @@
               <a:t>helm package charts/shipping-service --dependency-update -d dist
 </a:t>
             </a:r>
-            <a:pPr algn="l" indent="0" marL="0">
-              <a:lnSpc>
-                <a:spcPct val="110000"/>
-              </a:lnSpc>
-              <a:buNone/>
-            </a:pPr>
             <a:r>
               <a:rPr lang="en-US" sz="1800" dirty="0">
                 <a:solidFill>
@@ -5496,12 +5424,6 @@
               <a:t>helm push dist/shipping-service-1.0.0.tgz \
 </a:t>
             </a:r>
-            <a:pPr algn="l" indent="0" marL="0">
-              <a:lnSpc>
-                <a:spcPct val="110000"/>
-              </a:lnSpc>
-              <a:buNone/>
-            </a:pPr>
             <a:r>
               <a:rPr lang="en-US" sz="1800" dirty="0">
                 <a:solidFill>
@@ -5551,7 +5473,29 @@
                 <a:ea typeface="Red Hat Text" pitchFamily="34" charset="-122"/>
                 <a:cs typeface="Red Hat Text" pitchFamily="34" charset="-120"/>
               </a:rPr>
-              <a:t>Run from examples/14-chart‑testing. Three stages: static checks on every push, an install test, and publication on a tag.</a:t>
+              <a:t>Run from examples/14-</a:t>
+            </a:r>
+            <a:r>
+              <a:rPr lang="en-US" sz="1200" i="1" dirty="0">
+                <a:solidFill>
+                  <a:srgbClr val="151515"/>
+                </a:solidFill>
+                <a:latin typeface="Red Hat Mono" pitchFamily="34" charset="0"/>
+                <a:ea typeface="Red Hat Mono" pitchFamily="34" charset="-122"/>
+                <a:cs typeface="Red Hat Mono" pitchFamily="34" charset="-120"/>
+              </a:rPr>
+              <a:t>chart-testing</a:t>
+            </a:r>
+            <a:r>
+              <a:rPr lang="en-US" sz="1300" i="1" dirty="0">
+                <a:solidFill>
+                  <a:srgbClr val="5A5A5A"/>
+                </a:solidFill>
+                <a:latin typeface="Red Hat Text" pitchFamily="34" charset="0"/>
+                <a:ea typeface="Red Hat Text" pitchFamily="34" charset="-122"/>
+                <a:cs typeface="Red Hat Text" pitchFamily="34" charset="-120"/>
+              </a:rPr>
+              <a:t>. Three stages: static checks on every push, an install test, and publication on a tag.</a:t>
             </a:r>
             <a:endParaRPr lang="en-US" sz="1300" dirty="0"/>
           </a:p>
@@ -5968,7 +5912,7 @@
         <p:spPr>
           <a:xfrm>
             <a:off x="566928" y="1417320"/>
-            <a:ext cx="11055096" cy="4434840"/>
+            <a:ext cx="11055096" cy="4301566"/>
           </a:xfrm>
           <a:prstGeom prst="rect">
             <a:avLst/>
@@ -5993,7 +5937,7 @@
         <p:spPr>
           <a:xfrm>
             <a:off x="749808" y="1508760"/>
-            <a:ext cx="10689336" cy="4251960"/>
+            <a:ext cx="10689336" cy="4118686"/>
           </a:xfrm>
           <a:prstGeom prst="rect">
             <a:avLst/>
@@ -6012,7 +5956,7 @@
               <a:buNone/>
             </a:pPr>
             <a:r>
-              <a:rPr lang="en-US" sz="1400" dirty="0">
+              <a:rPr lang="en-US" sz="1950" dirty="0">
                 <a:solidFill>
                   <a:srgbClr val="8FB98F"/>
                 </a:solidFill>
@@ -6023,14 +5967,8 @@
               <a:t># charts/shipping-kafka: the chart declares the Kafka custom resource
 </a:t>
             </a:r>
-            <a:pPr algn="l" indent="0" marL="0">
-              <a:lnSpc>
-                <a:spcPct val="110000"/>
-              </a:lnSpc>
-              <a:buNone/>
-            </a:pPr>
-            <a:r>
-              <a:rPr lang="en-US" sz="1400" dirty="0">
+            <a:r>
+              <a:rPr lang="en-US" sz="1950" dirty="0">
                 <a:solidFill>
                   <a:srgbClr val="E6E6E6"/>
                 </a:solidFill>
@@ -6041,14 +5979,8 @@
               <a:t>spec:
 </a:t>
             </a:r>
-            <a:pPr algn="l" indent="0" marL="0">
-              <a:lnSpc>
-                <a:spcPct val="110000"/>
-              </a:lnSpc>
-              <a:buNone/>
-            </a:pPr>
-            <a:r>
-              <a:rPr lang="en-US" sz="1400" dirty="0">
+            <a:r>
+              <a:rPr lang="en-US" sz="1950" dirty="0">
                 <a:solidFill>
                   <a:srgbClr val="E6E6E6"/>
                 </a:solidFill>
@@ -6059,14 +5991,8 @@
               <a:t>  kafka:
 </a:t>
             </a:r>
-            <a:pPr algn="l" indent="0" marL="0">
-              <a:lnSpc>
-                <a:spcPct val="110000"/>
-              </a:lnSpc>
-              <a:buNone/>
-            </a:pPr>
-            <a:r>
-              <a:rPr lang="en-US" sz="1400" dirty="0">
+            <a:r>
+              <a:rPr lang="en-US" sz="1950" dirty="0">
                 <a:solidFill>
                   <a:srgbClr val="E6E6E6"/>
                 </a:solidFill>
@@ -6077,14 +6003,8 @@
               <a:t>    listeners:
 </a:t>
             </a:r>
-            <a:pPr algn="l" indent="0" marL="0">
-              <a:lnSpc>
-                <a:spcPct val="110000"/>
-              </a:lnSpc>
-              <a:buNone/>
-            </a:pPr>
-            <a:r>
-              <a:rPr lang="en-US" sz="1400" dirty="0">
+            <a:r>
+              <a:rPr lang="en-US" sz="1950" dirty="0">
                 <a:solidFill>
                   <a:srgbClr val="E6E6E6"/>
                 </a:solidFill>
@@ -6095,14 +6015,8 @@
               <a:t>      - name: plain
 </a:t>
             </a:r>
-            <a:pPr algn="l" indent="0" marL="0">
-              <a:lnSpc>
-                <a:spcPct val="110000"/>
-              </a:lnSpc>
-              <a:buNone/>
-            </a:pPr>
-            <a:r>
-              <a:rPr lang="en-US" sz="1400" dirty="0">
+            <a:r>
+              <a:rPr lang="en-US" sz="1950" dirty="0">
                 <a:solidFill>
                   <a:srgbClr val="E6E6E6"/>
                 </a:solidFill>
@@ -6113,14 +6027,8 @@
               <a:t>        port: 9092
 </a:t>
             </a:r>
-            <a:pPr algn="l" indent="0" marL="0">
-              <a:lnSpc>
-                <a:spcPct val="110000"/>
-              </a:lnSpc>
-              <a:buNone/>
-            </a:pPr>
-            <a:r>
-              <a:rPr lang="en-US" sz="1400" dirty="0">
+            <a:r>
+              <a:rPr lang="en-US" sz="1950" dirty="0">
                 <a:solidFill>
                   <a:srgbClr val="E6E6E6"/>
                 </a:solidFill>
@@ -6131,14 +6039,8 @@
               <a:t>        type: internal
 </a:t>
             </a:r>
-            <a:pPr algn="l" indent="0" marL="0">
-              <a:lnSpc>
-                <a:spcPct val="110000"/>
-              </a:lnSpc>
-              <a:buNone/>
-            </a:pPr>
-            <a:r>
-              <a:rPr lang="en-US" sz="1400" dirty="0">
+            <a:r>
+              <a:rPr lang="en-US" sz="1950" dirty="0">
                 <a:solidFill>
                   <a:srgbClr val="E6E6E6"/>
                 </a:solidFill>
@@ -6149,32 +6051,20 @@
               <a:t>        tls: false
 </a:t>
             </a:r>
-            <a:pPr algn="l" indent="0" marL="0">
-              <a:lnSpc>
-                <a:spcPct val="110000"/>
-              </a:lnSpc>
-              <a:buNone/>
-            </a:pPr>
-            <a:r>
-              <a:rPr lang="en-US" sz="1400" dirty="0">
-                <a:solidFill>
-                  <a:srgbClr val="E6E6E6"/>
+            <a:r>
+              <a:rPr lang="en-US" sz="1950" dirty="0">
+                <a:solidFill>
+                  <a:srgbClr val="8FB98F"/>
                 </a:solidFill>
                 <a:latin typeface="Red Hat Mono" pitchFamily="34" charset="0"/>
                 <a:ea typeface="Red Hat Mono" pitchFamily="34" charset="-122"/>
                 <a:cs typeface="Red Hat Mono" pitchFamily="34" charset="-120"/>
               </a:rPr>
-              <a:t>    config:
+              <a:t># values.yaml: the contract other charts import
 </a:t>
             </a:r>
-            <a:pPr algn="l" indent="0" marL="0">
-              <a:lnSpc>
-                <a:spcPct val="110000"/>
-              </a:lnSpc>
-              <a:buNone/>
-            </a:pPr>
-            <a:r>
-              <a:rPr lang="en-US" sz="1400" dirty="0">
+            <a:r>
+              <a:rPr lang="en-US" sz="1950" dirty="0">
                 <a:solidFill>
                   <a:srgbClr val="E6E6E6"/>
                 </a:solidFill>
@@ -6182,17 +6072,11 @@
                 <a:ea typeface="Red Hat Mono" pitchFamily="34" charset="-122"/>
                 <a:cs typeface="Red Hat Mono" pitchFamily="34" charset="-120"/>
               </a:rPr>
-              <a:t>      offsets.topic.replication.factor: 1
+              <a:t>exports:
 </a:t>
             </a:r>
-            <a:pPr algn="l" indent="0" marL="0">
-              <a:lnSpc>
-                <a:spcPct val="110000"/>
-              </a:lnSpc>
-              <a:buNone/>
-            </a:pPr>
-            <a:r>
-              <a:rPr lang="en-US" sz="1400" dirty="0">
+            <a:r>
+              <a:rPr lang="en-US" sz="1950" dirty="0">
                 <a:solidFill>
                   <a:srgbClr val="E6E6E6"/>
                 </a:solidFill>
@@ -6200,17 +6084,11 @@
                 <a:ea typeface="Red Hat Mono" pitchFamily="34" charset="-122"/>
                 <a:cs typeface="Red Hat Mono" pitchFamily="34" charset="-120"/>
               </a:rPr>
-              <a:t>      min.insync.replicas: 1
+              <a:t>  kafka:
 </a:t>
             </a:r>
-            <a:pPr algn="l" indent="0" marL="0">
-              <a:lnSpc>
-                <a:spcPct val="110000"/>
-              </a:lnSpc>
-              <a:buNone/>
-            </a:pPr>
-            <a:r>
-              <a:rPr lang="en-US" sz="1400" dirty="0">
+            <a:r>
+              <a:rPr lang="en-US" sz="1950" dirty="0">
                 <a:solidFill>
                   <a:srgbClr val="E6E6E6"/>
                 </a:solidFill>
@@ -6218,118 +6096,10 @@
                 <a:ea typeface="Red Hat Mono" pitchFamily="34" charset="-122"/>
                 <a:cs typeface="Red Hat Mono" pitchFamily="34" charset="-120"/>
               </a:rPr>
-              <a:t>  entityOperator:
-</a:t>
-            </a:r>
-            <a:pPr algn="l" indent="0" marL="0">
-              <a:lnSpc>
-                <a:spcPct val="110000"/>
-              </a:lnSpc>
-              <a:buNone/>
-            </a:pPr>
-            <a:r>
-              <a:rPr lang="en-US" sz="1400" dirty="0">
-                <a:solidFill>
-                  <a:srgbClr val="E6E6E6"/>
-                </a:solidFill>
-                <a:latin typeface="Red Hat Mono" pitchFamily="34" charset="0"/>
-                <a:ea typeface="Red Hat Mono" pitchFamily="34" charset="-122"/>
-                <a:cs typeface="Red Hat Mono" pitchFamily="34" charset="-120"/>
-              </a:rPr>
-              <a:t>    topicOperator: {}
-</a:t>
-            </a:r>
-            <a:pPr algn="l" indent="0" marL="0">
-              <a:lnSpc>
-                <a:spcPct val="110000"/>
-              </a:lnSpc>
-              <a:buNone/>
-            </a:pPr>
-            <a:r>
-              <a:rPr lang="en-US" sz="1400" dirty="0">
-                <a:solidFill>
-                  <a:srgbClr val="E6E6E6"/>
-                </a:solidFill>
-                <a:latin typeface="Red Hat Mono" pitchFamily="34" charset="0"/>
-                <a:ea typeface="Red Hat Mono" pitchFamily="34" charset="-122"/>
-                <a:cs typeface="Red Hat Mono" pitchFamily="34" charset="-120"/>
-              </a:rPr>
-              <a:t>    userOperator: {}
-</a:t>
-            </a:r>
-            <a:pPr algn="l" indent="0" marL="0">
-              <a:lnSpc>
-                <a:spcPct val="110000"/>
-              </a:lnSpc>
-              <a:buNone/>
-            </a:pPr>
-            <a:r>
-              <a:rPr lang="en-US" sz="1400" dirty="0">
-                <a:solidFill>
-                  <a:srgbClr val="8FB98F"/>
-                </a:solidFill>
-                <a:latin typeface="Red Hat Mono" pitchFamily="34" charset="0"/>
-                <a:ea typeface="Red Hat Mono" pitchFamily="34" charset="-122"/>
-                <a:cs typeface="Red Hat Mono" pitchFamily="34" charset="-120"/>
-              </a:rPr>
-              <a:t># values.yaml: the contract other charts import
-</a:t>
-            </a:r>
-            <a:pPr algn="l" indent="0" marL="0">
-              <a:lnSpc>
-                <a:spcPct val="110000"/>
-              </a:lnSpc>
-              <a:buNone/>
-            </a:pPr>
-            <a:r>
-              <a:rPr lang="en-US" sz="1400" dirty="0">
-                <a:solidFill>
-                  <a:srgbClr val="E6E6E6"/>
-                </a:solidFill>
-                <a:latin typeface="Red Hat Mono" pitchFamily="34" charset="0"/>
-                <a:ea typeface="Red Hat Mono" pitchFamily="34" charset="-122"/>
-                <a:cs typeface="Red Hat Mono" pitchFamily="34" charset="-120"/>
-              </a:rPr>
-              <a:t>exports:
-</a:t>
-            </a:r>
-            <a:pPr algn="l" indent="0" marL="0">
-              <a:lnSpc>
-                <a:spcPct val="110000"/>
-              </a:lnSpc>
-              <a:buNone/>
-            </a:pPr>
-            <a:r>
-              <a:rPr lang="en-US" sz="1400" dirty="0">
-                <a:solidFill>
-                  <a:srgbClr val="E6E6E6"/>
-                </a:solidFill>
-                <a:latin typeface="Red Hat Mono" pitchFamily="34" charset="0"/>
-                <a:ea typeface="Red Hat Mono" pitchFamily="34" charset="-122"/>
-                <a:cs typeface="Red Hat Mono" pitchFamily="34" charset="-120"/>
-              </a:rPr>
-              <a:t>  kafka:
-</a:t>
-            </a:r>
-            <a:pPr algn="l" indent="0" marL="0">
-              <a:lnSpc>
-                <a:spcPct val="110000"/>
-              </a:lnSpc>
-              <a:buNone/>
-            </a:pPr>
-            <a:r>
-              <a:rPr lang="en-US" sz="1400" dirty="0">
-                <a:solidFill>
-                  <a:srgbClr val="E6E6E6"/>
-                </a:solidFill>
-                <a:latin typeface="Red Hat Mono" pitchFamily="34" charset="0"/>
-                <a:ea typeface="Red Hat Mono" pitchFamily="34" charset="-122"/>
-                <a:cs typeface="Red Hat Mono" pitchFamily="34" charset="-120"/>
-              </a:rPr>
               <a:t>    bootstrap: shipping-kafka-kafka-bootstrap:9092
 </a:t>
             </a:r>
-            <a:endParaRPr lang="en-US" sz="1400" dirty="0"/>
+            <a:endParaRPr lang="en-US" sz="1950" dirty="0"/>
           </a:p>
         </p:txBody>
       </p:sp>
@@ -6341,7 +6111,7 @@
         </p:nvSpPr>
         <p:spPr>
           <a:xfrm>
-            <a:off x="566928" y="5943600"/>
+            <a:off x="566928" y="5810326"/>
             <a:ext cx="11055096" cy="310896"/>
           </a:xfrm>
           <a:prstGeom prst="rect">
@@ -6553,8 +6323,8 @@
         </p:blipFill>
         <p:spPr>
           <a:xfrm>
-            <a:off x="886968" y="1645920"/>
-            <a:ext cx="10424160" cy="4251960"/>
+            <a:off x="566928" y="1417320"/>
+            <a:ext cx="11055096" cy="4480560"/>
           </a:xfrm>
           <a:prstGeom prst="rect">
             <a:avLst/>
@@ -6858,7 +6628,7 @@
               <a:buNone/>
             </a:pPr>
             <a:r>
-              <a:rPr lang="en-US" sz="1400" dirty="0">
+              <a:rPr lang="en-US" sz="1950" dirty="0">
                 <a:solidFill>
                   <a:srgbClr val="E6E6E6"/>
                 </a:solidFill>
@@ -6869,14 +6639,8 @@
               <a:t>dependencies:
 </a:t>
             </a:r>
-            <a:pPr algn="l" indent="0" marL="0">
-              <a:lnSpc>
-                <a:spcPct val="110000"/>
-              </a:lnSpc>
-              <a:buNone/>
-            </a:pPr>
-            <a:r>
-              <a:rPr lang="en-US" sz="1400" dirty="0">
+            <a:r>
+              <a:rPr lang="en-US" sz="1950" dirty="0">
                 <a:solidFill>
                   <a:srgbClr val="E6E6E6"/>
                 </a:solidFill>
@@ -6887,14 +6651,8 @@
               <a:t>  - name: shipping-service
 </a:t>
             </a:r>
-            <a:pPr algn="l" indent="0" marL="0">
-              <a:lnSpc>
-                <a:spcPct val="110000"/>
-              </a:lnSpc>
-              <a:buNone/>
-            </a:pPr>
-            <a:r>
-              <a:rPr lang="en-US" sz="1400" dirty="0">
+            <a:r>
+              <a:rPr lang="en-US" sz="1950" dirty="0">
                 <a:solidFill>
                   <a:srgbClr val="E6E6E6"/>
                 </a:solidFill>
@@ -6905,14 +6663,8 @@
               <a:t>    alias: shipping
 </a:t>
             </a:r>
-            <a:pPr algn="l" indent="0" marL="0">
-              <a:lnSpc>
-                <a:spcPct val="110000"/>
-              </a:lnSpc>
-              <a:buNone/>
-            </a:pPr>
-            <a:r>
-              <a:rPr lang="en-US" sz="1400" dirty="0">
+            <a:r>
+              <a:rPr lang="en-US" sz="1950" dirty="0">
                 <a:solidFill>
                   <a:srgbClr val="E6E6E6"/>
                 </a:solidFill>
@@ -6920,17 +6672,11 @@
                 <a:ea typeface="Red Hat Mono" pitchFamily="34" charset="-122"/>
                 <a:cs typeface="Red Hat Mono" pitchFamily="34" charset="-120"/>
               </a:rPr>
-              <a:t>    version: 0.16.0
+              <a:t>    condition: shipping.enabled
 </a:t>
             </a:r>
-            <a:pPr algn="l" indent="0" marL="0">
-              <a:lnSpc>
-                <a:spcPct val="110000"/>
-              </a:lnSpc>
-              <a:buNone/>
-            </a:pPr>
-            <a:r>
-              <a:rPr lang="en-US" sz="1400" dirty="0">
+            <a:r>
+              <a:rPr lang="en-US" sz="1950" dirty="0">
                 <a:solidFill>
                   <a:srgbClr val="E6E6E6"/>
                 </a:solidFill>
@@ -6938,17 +6684,11 @@
                 <a:ea typeface="Red Hat Mono" pitchFamily="34" charset="-122"/>
                 <a:cs typeface="Red Hat Mono" pitchFamily="34" charset="-120"/>
               </a:rPr>
-              <a:t>    repository: file://../shipping-service
+              <a:t>  - name: notification-service
 </a:t>
             </a:r>
-            <a:pPr algn="l" indent="0" marL="0">
-              <a:lnSpc>
-                <a:spcPct val="110000"/>
-              </a:lnSpc>
-              <a:buNone/>
-            </a:pPr>
-            <a:r>
-              <a:rPr lang="en-US" sz="1400" dirty="0">
+            <a:r>
+              <a:rPr lang="en-US" sz="1950" dirty="0">
                 <a:solidFill>
                   <a:srgbClr val="E6E6E6"/>
                 </a:solidFill>
@@ -6956,17 +6696,11 @@
                 <a:ea typeface="Red Hat Mono" pitchFamily="34" charset="-122"/>
                 <a:cs typeface="Red Hat Mono" pitchFamily="34" charset="-120"/>
               </a:rPr>
-              <a:t>    condition: shipping.enabled
+              <a:t>    alias: notification
 </a:t>
             </a:r>
-            <a:pPr algn="l" indent="0" marL="0">
-              <a:lnSpc>
-                <a:spcPct val="110000"/>
-              </a:lnSpc>
-              <a:buNone/>
-            </a:pPr>
-            <a:r>
-              <a:rPr lang="en-US" sz="1400" dirty="0">
+            <a:r>
+              <a:rPr lang="en-US" sz="1950" dirty="0">
                 <a:solidFill>
                   <a:srgbClr val="E6E6E6"/>
                 </a:solidFill>
@@ -6974,17 +6708,11 @@
                 <a:ea typeface="Red Hat Mono" pitchFamily="34" charset="-122"/>
                 <a:cs typeface="Red Hat Mono" pitchFamily="34" charset="-120"/>
               </a:rPr>
-              <a:t>  - name: notification-service
+              <a:t>    tags: [messaging]
 </a:t>
             </a:r>
-            <a:pPr algn="l" indent="0" marL="0">
-              <a:lnSpc>
-                <a:spcPct val="110000"/>
-              </a:lnSpc>
-              <a:buNone/>
-            </a:pPr>
-            <a:r>
-              <a:rPr lang="en-US" sz="1400" dirty="0">
+            <a:r>
+              <a:rPr lang="en-US" sz="1950" dirty="0">
                 <a:solidFill>
                   <a:srgbClr val="E6E6E6"/>
                 </a:solidFill>
@@ -6992,17 +6720,11 @@
                 <a:ea typeface="Red Hat Mono" pitchFamily="34" charset="-122"/>
                 <a:cs typeface="Red Hat Mono" pitchFamily="34" charset="-120"/>
               </a:rPr>
-              <a:t>    alias: notification
+              <a:t>  - name: shipping-postgres
 </a:t>
             </a:r>
-            <a:pPr algn="l" indent="0" marL="0">
-              <a:lnSpc>
-                <a:spcPct val="110000"/>
-              </a:lnSpc>
-              <a:buNone/>
-            </a:pPr>
-            <a:r>
-              <a:rPr lang="en-US" sz="1400" dirty="0">
+            <a:r>
+              <a:rPr lang="en-US" sz="1950" dirty="0">
                 <a:solidFill>
                   <a:srgbClr val="E6E6E6"/>
                 </a:solidFill>
@@ -7010,17 +6732,11 @@
                 <a:ea typeface="Red Hat Mono" pitchFamily="34" charset="-122"/>
                 <a:cs typeface="Red Hat Mono" pitchFamily="34" charset="-120"/>
               </a:rPr>
-              <a:t>    tags: [messaging]
+              <a:t>    alias: db
 </a:t>
             </a:r>
-            <a:pPr algn="l" indent="0" marL="0">
-              <a:lnSpc>
-                <a:spcPct val="110000"/>
-              </a:lnSpc>
-              <a:buNone/>
-            </a:pPr>
-            <a:r>
-              <a:rPr lang="en-US" sz="1400" dirty="0">
+            <a:r>
+              <a:rPr lang="en-US" sz="1950" dirty="0">
                 <a:solidFill>
                   <a:srgbClr val="E6E6E6"/>
                 </a:solidFill>
@@ -7028,17 +6744,11 @@
                 <a:ea typeface="Red Hat Mono" pitchFamily="34" charset="-122"/>
                 <a:cs typeface="Red Hat Mono" pitchFamily="34" charset="-120"/>
               </a:rPr>
-              <a:t>  - name: shipping-postgres
+              <a:t>    condition: db.enabled
 </a:t>
             </a:r>
-            <a:pPr algn="l" indent="0" marL="0">
-              <a:lnSpc>
-                <a:spcPct val="110000"/>
-              </a:lnSpc>
-              <a:buNone/>
-            </a:pPr>
-            <a:r>
-              <a:rPr lang="en-US" sz="1400" dirty="0">
+            <a:r>
+              <a:rPr lang="en-US" sz="1950" dirty="0">
                 <a:solidFill>
                   <a:srgbClr val="E6E6E6"/>
                 </a:solidFill>
@@ -7046,17 +6756,11 @@
                 <a:ea typeface="Red Hat Mono" pitchFamily="34" charset="-122"/>
                 <a:cs typeface="Red Hat Mono" pitchFamily="34" charset="-120"/>
               </a:rPr>
-              <a:t>    alias: db
+              <a:t>  - name: shipping-kafka
 </a:t>
             </a:r>
-            <a:pPr algn="l" indent="0" marL="0">
-              <a:lnSpc>
-                <a:spcPct val="110000"/>
-              </a:lnSpc>
-              <a:buNone/>
-            </a:pPr>
-            <a:r>
-              <a:rPr lang="en-US" sz="1400" dirty="0">
+            <a:r>
+              <a:rPr lang="en-US" sz="1950" dirty="0">
                 <a:solidFill>
                   <a:srgbClr val="E6E6E6"/>
                 </a:solidFill>
@@ -7064,17 +6768,11 @@
                 <a:ea typeface="Red Hat Mono" pitchFamily="34" charset="-122"/>
                 <a:cs typeface="Red Hat Mono" pitchFamily="34" charset="-120"/>
               </a:rPr>
-              <a:t>    condition: db.enabled
+              <a:t>    alias: kafka
 </a:t>
             </a:r>
-            <a:pPr algn="l" indent="0" marL="0">
-              <a:lnSpc>
-                <a:spcPct val="110000"/>
-              </a:lnSpc>
-              <a:buNone/>
-            </a:pPr>
-            <a:r>
-              <a:rPr lang="en-US" sz="1400" dirty="0">
+            <a:r>
+              <a:rPr lang="en-US" sz="1950" dirty="0">
                 <a:solidFill>
                   <a:srgbClr val="E6E6E6"/>
                 </a:solidFill>
@@ -7082,100 +6780,10 @@
                 <a:ea typeface="Red Hat Mono" pitchFamily="34" charset="-122"/>
                 <a:cs typeface="Red Hat Mono" pitchFamily="34" charset="-120"/>
               </a:rPr>
-              <a:t>    import-values:
-</a:t>
-            </a:r>
-            <a:pPr algn="l" indent="0" marL="0">
-              <a:lnSpc>
-                <a:spcPct val="110000"/>
-              </a:lnSpc>
-              <a:buNone/>
-            </a:pPr>
-            <a:r>
-              <a:rPr lang="en-US" sz="1400" dirty="0">
-                <a:solidFill>
-                  <a:srgbClr val="E6E6E6"/>
-                </a:solidFill>
-                <a:latin typeface="Red Hat Mono" pitchFamily="34" charset="0"/>
-                <a:ea typeface="Red Hat Mono" pitchFamily="34" charset="-122"/>
-                <a:cs typeface="Red Hat Mono" pitchFamily="34" charset="-120"/>
-              </a:rPr>
-              <a:t>      - child: exports.postgres
-</a:t>
-            </a:r>
-            <a:pPr algn="l" indent="0" marL="0">
-              <a:lnSpc>
-                <a:spcPct val="110000"/>
-              </a:lnSpc>
-              <a:buNone/>
-            </a:pPr>
-            <a:r>
-              <a:rPr lang="en-US" sz="1400" dirty="0">
-                <a:solidFill>
-                  <a:srgbClr val="E6E6E6"/>
-                </a:solidFill>
-                <a:latin typeface="Red Hat Mono" pitchFamily="34" charset="0"/>
-                <a:ea typeface="Red Hat Mono" pitchFamily="34" charset="-122"/>
-                <a:cs typeface="Red Hat Mono" pitchFamily="34" charset="-120"/>
-              </a:rPr>
-              <a:t>        parent: shipping.postgres
-</a:t>
-            </a:r>
-            <a:pPr algn="l" indent="0" marL="0">
-              <a:lnSpc>
-                <a:spcPct val="110000"/>
-              </a:lnSpc>
-              <a:buNone/>
-            </a:pPr>
-            <a:r>
-              <a:rPr lang="en-US" sz="1400" dirty="0">
-                <a:solidFill>
-                  <a:srgbClr val="E6E6E6"/>
-                </a:solidFill>
-                <a:latin typeface="Red Hat Mono" pitchFamily="34" charset="0"/>
-                <a:ea typeface="Red Hat Mono" pitchFamily="34" charset="-122"/>
-                <a:cs typeface="Red Hat Mono" pitchFamily="34" charset="-120"/>
-              </a:rPr>
-              <a:t>  - name: shipping-kafka
-</a:t>
-            </a:r>
-            <a:pPr algn="l" indent="0" marL="0">
-              <a:lnSpc>
-                <a:spcPct val="110000"/>
-              </a:lnSpc>
-              <a:buNone/>
-            </a:pPr>
-            <a:r>
-              <a:rPr lang="en-US" sz="1400" dirty="0">
-                <a:solidFill>
-                  <a:srgbClr val="E6E6E6"/>
-                </a:solidFill>
-                <a:latin typeface="Red Hat Mono" pitchFamily="34" charset="0"/>
-                <a:ea typeface="Red Hat Mono" pitchFamily="34" charset="-122"/>
-                <a:cs typeface="Red Hat Mono" pitchFamily="34" charset="-120"/>
-              </a:rPr>
-              <a:t>    alias: kafka
-</a:t>
-            </a:r>
-            <a:pPr algn="l" indent="0" marL="0">
-              <a:lnSpc>
-                <a:spcPct val="110000"/>
-              </a:lnSpc>
-              <a:buNone/>
-            </a:pPr>
-            <a:r>
-              <a:rPr lang="en-US" sz="1400" dirty="0">
-                <a:solidFill>
-                  <a:srgbClr val="E6E6E6"/>
-                </a:solidFill>
-                <a:latin typeface="Red Hat Mono" pitchFamily="34" charset="0"/>
-                <a:ea typeface="Red Hat Mono" pitchFamily="34" charset="-122"/>
-                <a:cs typeface="Red Hat Mono" pitchFamily="34" charset="-120"/>
-              </a:rPr>
               <a:t>    tags: [messaging]
 </a:t>
             </a:r>
-            <a:endParaRPr lang="en-US" sz="1400" dirty="0"/>
+            <a:endParaRPr lang="en-US" sz="1950" dirty="0"/>
           </a:p>
         </p:txBody>
       </p:sp>
@@ -7405,7 +7013,7 @@
           <a:bodyPr wrap="square" lIns="0" tIns="0" rIns="0" bIns="0" rtlCol="0" anchor="t"/>
           <a:lstStyle/>
           <a:p>
-            <a:pPr marL="228600" indent="-228600">
+            <a:pPr marL="304800" indent="-304800">
               <a:lnSpc>
                 <a:spcPct val="112000"/>
               </a:lnSpc>
@@ -7429,12 +7037,6 @@
               </a:rPr>
               <a:t>global</a:t>
             </a:r>
-            <a:pPr indent="0" marL="0">
-              <a:lnSpc>
-                <a:spcPct val="112000"/>
-              </a:lnSpc>
-              <a:buNone/>
-            </a:pPr>
             <a:r>
               <a:rPr lang="en-US" sz="2000" dirty="0">
                 <a:solidFill>
@@ -7449,7 +7051,7 @@
             <a:endParaRPr lang="en-US" sz="2000" dirty="0"/>
           </a:p>
           <a:p>
-            <a:pPr marL="228600" indent="-228600">
+            <a:pPr marL="304800" indent="-304800">
               <a:lnSpc>
                 <a:spcPct val="112000"/>
               </a:lnSpc>
@@ -7473,12 +7075,6 @@
               </a:rPr>
               <a:t>import-values</a:t>
             </a:r>
-            <a:pPr indent="0" marL="0">
-              <a:lnSpc>
-                <a:spcPct val="112000"/>
-              </a:lnSpc>
-              <a:buNone/>
-            </a:pPr>
             <a:r>
               <a:rPr lang="en-US" sz="2000" dirty="0">
                 <a:solidFill>
@@ -7493,7 +7089,7 @@
             <a:endParaRPr lang="en-US" sz="2000" dirty="0"/>
           </a:p>
           <a:p>
-            <a:pPr marL="228600" indent="-228600">
+            <a:pPr marL="304800" indent="-304800">
               <a:lnSpc>
                 <a:spcPct val="112000"/>
               </a:lnSpc>
@@ -7517,12 +7113,6 @@
               </a:rPr>
               <a:t>Static exports</a:t>
             </a:r>
-            <a:pPr indent="0" marL="0">
-              <a:lnSpc>
-                <a:spcPct val="112000"/>
-              </a:lnSpc>
-              <a:buNone/>
-            </a:pPr>
             <a:r>
               <a:rPr lang="en-US" sz="2000" dirty="0">
                 <a:solidFill>
@@ -7537,7 +7127,7 @@
             <a:endParaRPr lang="en-US" sz="2000" dirty="0"/>
           </a:p>
           <a:p>
-            <a:pPr marL="228600" indent="-228600">
+            <a:pPr marL="304800" indent="-304800">
               <a:lnSpc>
                 <a:spcPct val="112000"/>
               </a:lnSpc>
@@ -7561,12 +7151,6 @@
               </a:rPr>
               <a:t>Override trap</a:t>
             </a:r>
-            <a:pPr indent="0" marL="0">
-              <a:lnSpc>
-                <a:spcPct val="112000"/>
-              </a:lnSpc>
-              <a:buNone/>
-            </a:pPr>
             <a:r>
               <a:rPr lang="en-US" sz="2000" dirty="0">
                 <a:solidFill>
@@ -8836,12 +8420,6 @@
               <a:t>{{- if and .Values.requireOperator
 </a:t>
             </a:r>
-            <a:pPr algn="l" indent="0" marL="0">
-              <a:lnSpc>
-                <a:spcPct val="110000"/>
-              </a:lnSpc>
-              <a:buNone/>
-            </a:pPr>
             <a:r>
               <a:rPr lang="en-US" sz="1700" dirty="0">
                 <a:solidFill>
@@ -8854,12 +8432,6 @@
               <a:t>      (not (.Capabilities.APIVersions.Has "postgresql.cnpg.io/v1")) }}
 </a:t>
             </a:r>
-            <a:pPr algn="l" indent="0" marL="0">
-              <a:lnSpc>
-                <a:spcPct val="110000"/>
-              </a:lnSpc>
-              <a:buNone/>
-            </a:pPr>
             <a:r>
               <a:rPr lang="en-US" sz="1700" dirty="0">
                 <a:solidFill>
@@ -8872,12 +8444,6 @@
               <a:t>{{- fail "shipping-postgres needs the CloudNativePG operator: ..." }}
 </a:t>
             </a:r>
-            <a:pPr algn="l" indent="0" marL="0">
-              <a:lnSpc>
-                <a:spcPct val="110000"/>
-              </a:lnSpc>
-              <a:buNone/>
-            </a:pPr>
             <a:r>
               <a:rPr lang="en-US" sz="1700" dirty="0">
                 <a:solidFill>
@@ -8890,12 +8456,6 @@
               <a:t>{{- end }}
 </a:t>
             </a:r>
-            <a:pPr algn="l" indent="0" marL="0">
-              <a:lnSpc>
-                <a:spcPct val="110000"/>
-              </a:lnSpc>
-              <a:buNone/>
-            </a:pPr>
             <a:r>
               <a:rPr lang="en-US" sz="1700" dirty="0">
                 <a:solidFill>
@@ -8908,12 +8468,6 @@
               <a:t>
 </a:t>
             </a:r>
-            <a:pPr algn="l" indent="0" marL="0">
-              <a:lnSpc>
-                <a:spcPct val="110000"/>
-              </a:lnSpc>
-              <a:buNone/>
-            </a:pPr>
             <a:r>
               <a:rPr lang="en-US" sz="1700" dirty="0">
                 <a:solidFill>
@@ -8926,12 +8480,6 @@
               <a:t># templates/route.yaml renders only where the API exists
 </a:t>
             </a:r>
-            <a:pPr algn="l" indent="0" marL="0">
-              <a:lnSpc>
-                <a:spcPct val="110000"/>
-              </a:lnSpc>
-              <a:buNone/>
-            </a:pPr>
             <a:r>
               <a:rPr lang="en-US" sz="1700" dirty="0">
                 <a:solidFill>
@@ -8944,12 +8492,6 @@
               <a:t>{{- if and .Values.route.enabled
 </a:t>
             </a:r>
-            <a:pPr algn="l" indent="0" marL="0">
-              <a:lnSpc>
-                <a:spcPct val="110000"/>
-              </a:lnSpc>
-              <a:buNone/>
-            </a:pPr>
             <a:r>
               <a:rPr lang="en-US" sz="1700" dirty="0">
                 <a:solidFill>
@@ -8962,12 +8504,6 @@
               <a:t>      (.Capabilities.APIVersions.Has "route.openshift.io/v1") }}
 </a:t>
             </a:r>
-            <a:pPr algn="l" indent="0" marL="0">
-              <a:lnSpc>
-                <a:spcPct val="110000"/>
-              </a:lnSpc>
-              <a:buNone/>
-            </a:pPr>
             <a:r>
               <a:rPr lang="en-US" sz="1700" dirty="0">
                 <a:solidFill>
@@ -8980,12 +8516,6 @@
               <a:t>...
 </a:t>
             </a:r>
-            <a:pPr algn="l" indent="0" marL="0">
-              <a:lnSpc>
-                <a:spcPct val="110000"/>
-              </a:lnSpc>
-              <a:buNone/>
-            </a:pPr>
             <a:r>
               <a:rPr lang="en-US" sz="1700" dirty="0">
                 <a:solidFill>
@@ -8998,12 +8528,6 @@
               <a:t>{{- end }}
 </a:t>
             </a:r>
-            <a:pPr algn="l" indent="0" marL="0">
-              <a:lnSpc>
-                <a:spcPct val="110000"/>
-              </a:lnSpc>
-              <a:buNone/>
-            </a:pPr>
             <a:r>
               <a:rPr lang="en-US" sz="1700" dirty="0">
                 <a:solidFill>
@@ -9016,12 +8540,6 @@
               <a:t>
 </a:t>
             </a:r>
-            <a:pPr algn="l" indent="0" marL="0">
-              <a:lnSpc>
-                <a:spcPct val="110000"/>
-              </a:lnSpc>
-              <a:buNone/>
-            </a:pPr>
             <a:r>
               <a:rPr lang="en-US" sz="1700" dirty="0">
                 <a:solidFill>
@@ -9034,12 +8552,6 @@
               <a:t># Offline there is no cluster to ask: supply the API yourself
 </a:t>
             </a:r>
-            <a:pPr algn="l" indent="0" marL="0">
-              <a:lnSpc>
-                <a:spcPct val="110000"/>
-              </a:lnSpc>
-              <a:buNone/>
-            </a:pPr>
             <a:r>
               <a:rPr lang="en-US" sz="1700" dirty="0">
                 <a:solidFill>
@@ -9052,12 +8564,6 @@
               <a:t>helm template platform charts/shipping-platform -n hfd-ocp \
 </a:t>
             </a:r>
-            <a:pPr algn="l" indent="0" marL="0">
-              <a:lnSpc>
-                <a:spcPct val="110000"/>
-              </a:lnSpc>
-              <a:buNone/>
-            </a:pPr>
             <a:r>
               <a:rPr lang="en-US" sz="1700" dirty="0">
                 <a:solidFill>
@@ -9070,12 +8576,6 @@
               <a:t>  --api-versions route.openshift.io/v1
 </a:t>
             </a:r>
-            <a:pPr algn="l" indent="0" marL="0">
-              <a:lnSpc>
-                <a:spcPct val="110000"/>
-              </a:lnSpc>
-              <a:buNone/>
-            </a:pPr>
             <a:r>
               <a:rPr lang="en-US" sz="1700" dirty="0">
                 <a:solidFill>
@@ -9125,7 +8625,29 @@
                 <a:ea typeface="Red Hat Text" pitchFamily="34" charset="-122"/>
                 <a:cs typeface="Red Hat Text" pitchFamily="34" charset="-120"/>
               </a:rPr>
-              <a:t>Has asks the cluster at install time; helm template needs ‑‑api‑versions (examples/27-openshift-crc).</a:t>
+              <a:t>Has asks the cluster at install time; helm template needs </a:t>
+            </a:r>
+            <a:r>
+              <a:rPr lang="en-US" sz="1200" i="1" dirty="0">
+                <a:solidFill>
+                  <a:srgbClr val="151515"/>
+                </a:solidFill>
+                <a:latin typeface="Red Hat Mono" pitchFamily="34" charset="0"/>
+                <a:ea typeface="Red Hat Mono" pitchFamily="34" charset="-122"/>
+                <a:cs typeface="Red Hat Mono" pitchFamily="34" charset="-120"/>
+              </a:rPr>
+              <a:t>--api-versions</a:t>
+            </a:r>
+            <a:r>
+              <a:rPr lang="en-US" sz="1300" i="1" dirty="0">
+                <a:solidFill>
+                  <a:srgbClr val="5A5A5A"/>
+                </a:solidFill>
+                <a:latin typeface="Red Hat Text" pitchFamily="34" charset="0"/>
+                <a:ea typeface="Red Hat Text" pitchFamily="34" charset="-122"/>
+                <a:cs typeface="Red Hat Text" pitchFamily="34" charset="-120"/>
+              </a:rPr>
+              <a:t> (examples/27-openshift-crc).</a:t>
             </a:r>
             <a:endParaRPr lang="en-US" sz="1300" dirty="0"/>
           </a:p>
@@ -9312,8 +8834,8 @@
         </p:blipFill>
         <p:spPr>
           <a:xfrm>
-            <a:off x="886968" y="1645920"/>
-            <a:ext cx="10424160" cy="4251960"/>
+            <a:off x="566928" y="1417320"/>
+            <a:ext cx="11055096" cy="4480560"/>
           </a:xfrm>
           <a:prstGeom prst="rect">
             <a:avLst/>
@@ -9628,12 +9150,6 @@
               <a:t># A starter is a chart directory; &lt;CHARTNAME&gt; becomes the new name
 </a:t>
             </a:r>
-            <a:pPr algn="l" indent="0" marL="0">
-              <a:lnSpc>
-                <a:spcPct val="110000"/>
-              </a:lnSpc>
-              <a:buNone/>
-            </a:pPr>
             <a:r>
               <a:rPr lang="en-US" sz="2000" dirty="0">
                 <a:solidFill>
@@ -9646,12 +9162,6 @@
               <a:t>helm create --starter pc-fastapi charts/inventory-service
 </a:t>
             </a:r>
-            <a:pPr algn="l" indent="0" marL="0">
-              <a:lnSpc>
-                <a:spcPct val="110000"/>
-              </a:lnSpc>
-              <a:buNone/>
-            </a:pPr>
             <a:r>
               <a:rPr lang="en-US" sz="2000" dirty="0">
                 <a:solidFill>
@@ -9664,12 +9174,6 @@
               <a:t>helm dependency build charts/inventory-service
 </a:t>
             </a:r>
-            <a:pPr algn="l" indent="0" marL="0">
-              <a:lnSpc>
-                <a:spcPct val="110000"/>
-              </a:lnSpc>
-              <a:buNone/>
-            </a:pPr>
             <a:r>
               <a:rPr lang="en-US" sz="2000" dirty="0">
                 <a:solidFill>
@@ -9682,12 +9186,6 @@
               <a:t>helm lint --strict charts/inventory-service
 </a:t>
             </a:r>
-            <a:pPr algn="l" indent="0" marL="0">
-              <a:lnSpc>
-                <a:spcPct val="110000"/>
-              </a:lnSpc>
-              <a:buNone/>
-            </a:pPr>
             <a:r>
               <a:rPr lang="en-US" sz="2000" dirty="0">
                 <a:solidFill>
@@ -9700,12 +9198,6 @@
               <a:t>helm template inventory charts/inventory-service \
 </a:t>
             </a:r>
-            <a:pPr algn="l" indent="0" marL="0">
-              <a:lnSpc>
-                <a:spcPct val="110000"/>
-              </a:lnSpc>
-              <a:buNone/>
-            </a:pPr>
             <a:r>
               <a:rPr lang="en-US" sz="2000" dirty="0">
                 <a:solidFill>
@@ -9718,12 +9210,6 @@
               <a:t>  | kubeconform -strict -summary
 </a:t>
             </a:r>
-            <a:pPr algn="l" indent="0" marL="0">
-              <a:lnSpc>
-                <a:spcPct val="110000"/>
-              </a:lnSpc>
-              <a:buNone/>
-            </a:pPr>
             <a:r>
               <a:rPr lang="en-US" sz="2000" dirty="0">
                 <a:solidFill>
@@ -9736,12 +9222,6 @@
               <a:t>helm upgrade --install inventory charts/inventory-service \
 </a:t>
             </a:r>
-            <a:pPr algn="l" indent="0" marL="0">
-              <a:lnSpc>
-                <a:spcPct val="110000"/>
-              </a:lnSpc>
-              <a:buNone/>
-            </a:pPr>
             <a:r>
               <a:rPr lang="en-US" sz="2000" dirty="0">
                 <a:solidFill>
@@ -9754,12 +9234,6 @@
               <a:t>  -n hfd-18 --create-namespace
 </a:t>
             </a:r>
-            <a:pPr algn="l" indent="0" marL="0">
-              <a:lnSpc>
-                <a:spcPct val="110000"/>
-              </a:lnSpc>
-              <a:buNone/>
-            </a:pPr>
             <a:r>
               <a:rPr lang="en-US" sz="2000" dirty="0">
                 <a:solidFill>
@@ -9772,12 +9246,6 @@
               <a:t>helm test inventory -n hfd-18
 </a:t>
             </a:r>
-            <a:pPr algn="l" indent="0" marL="0">
-              <a:lnSpc>
-                <a:spcPct val="110000"/>
-              </a:lnSpc>
-              <a:buNone/>
-            </a:pPr>
             <a:r>
               <a:rPr lang="en-US" sz="2000" dirty="0">
                 <a:solidFill>
@@ -10039,7 +9507,40 @@
                 <a:ea typeface="Red Hat Text" pitchFamily="34" charset="-122"/>
                 <a:cs typeface="Red Hat Text" pitchFamily="34" charset="-120"/>
               </a:rPr>
-              <a:t>Testing and debugging: the debug ladder, helm‑unittest, chart‑testing</a:t>
+              <a:t>Testing and debugging: the debug ladder, </a:t>
+            </a:r>
+            <a:r>
+              <a:rPr lang="en-US" sz="1900" dirty="0">
+                <a:solidFill>
+                  <a:srgbClr val="151515"/>
+                </a:solidFill>
+                <a:latin typeface="Red Hat Mono" pitchFamily="34" charset="0"/>
+                <a:ea typeface="Red Hat Mono" pitchFamily="34" charset="-122"/>
+                <a:cs typeface="Red Hat Mono" pitchFamily="34" charset="-120"/>
+              </a:rPr>
+              <a:t>helm-unittest</a:t>
+            </a:r>
+            <a:r>
+              <a:rPr lang="en-US" sz="2000" dirty="0">
+                <a:solidFill>
+                  <a:srgbClr val="242424"/>
+                </a:solidFill>
+                <a:latin typeface="Red Hat Text" pitchFamily="34" charset="0"/>
+                <a:ea typeface="Red Hat Text" pitchFamily="34" charset="-122"/>
+                <a:cs typeface="Red Hat Text" pitchFamily="34" charset="-120"/>
+              </a:rPr>
+              <a:t>, </a:t>
+            </a:r>
+            <a:r>
+              <a:rPr lang="en-US" sz="1900" dirty="0">
+                <a:solidFill>
+                  <a:srgbClr val="151515"/>
+                </a:solidFill>
+                <a:latin typeface="Red Hat Mono" pitchFamily="34" charset="0"/>
+                <a:ea typeface="Red Hat Mono" pitchFamily="34" charset="-122"/>
+                <a:cs typeface="Red Hat Mono" pitchFamily="34" charset="-120"/>
+              </a:rPr>
+              <a:t>chart-testing</a:t>
             </a:r>
             <a:endParaRPr lang="en-US" sz="2000" dirty="0"/>
           </a:p>
@@ -10133,7 +9634,7 @@
                 <a:ea typeface="Red Hat Text" pitchFamily="34" charset="-122"/>
                 <a:cs typeface="Red Hat Text" pitchFamily="34" charset="-120"/>
               </a:rPr>
-              <a:t>Extending Helm: plugin types, Wasm, post‑renderer plugins</a:t>
+              <a:t>Extending Helm: plugin types, Wasm, post-renderer plugins</a:t>
             </a:r>
             <a:endParaRPr lang="en-US" sz="2000" dirty="0"/>
           </a:p>
@@ -10653,12 +10154,6 @@
               <a:t>version: 1.0.0        # the chart: templates, values keys, dependencies
 </a:t>
             </a:r>
-            <a:pPr algn="l" indent="0" marL="0">
-              <a:lnSpc>
-                <a:spcPct val="110000"/>
-              </a:lnSpc>
-              <a:buNone/>
-            </a:pPr>
             <a:r>
               <a:rPr lang="en-US" sz="1750" dirty="0">
                 <a:solidFill>
@@ -10671,12 +10166,6 @@
               <a:t>appVersion: "0.1.0"   # the application the chart deploys; default image tag
 </a:t>
             </a:r>
-            <a:pPr algn="l" indent="0" marL="0">
-              <a:lnSpc>
-                <a:spcPct val="110000"/>
-              </a:lnSpc>
-              <a:buNone/>
-            </a:pPr>
             <a:r>
               <a:rPr lang="en-US" sz="1750" dirty="0">
                 <a:solidFill>
@@ -10689,12 +10178,6 @@
               <a:t>
 </a:t>
             </a:r>
-            <a:pPr algn="l" indent="0" marL="0">
-              <a:lnSpc>
-                <a:spcPct val="110000"/>
-              </a:lnSpc>
-              <a:buNone/>
-            </a:pPr>
             <a:r>
               <a:rPr lang="en-US" sz="1750" dirty="0">
                 <a:solidFill>
@@ -10707,12 +10190,6 @@
               <a:t># CI stamps both without editing the file
 </a:t>
             </a:r>
-            <a:pPr algn="l" indent="0" marL="0">
-              <a:lnSpc>
-                <a:spcPct val="110000"/>
-              </a:lnSpc>
-              <a:buNone/>
-            </a:pPr>
             <a:r>
               <a:rPr lang="en-US" sz="1750" dirty="0">
                 <a:solidFill>
@@ -10725,12 +10202,6 @@
               <a:t>helm package charts/shipping-service \
 </a:t>
             </a:r>
-            <a:pPr algn="l" indent="0" marL="0">
-              <a:lnSpc>
-                <a:spcPct val="110000"/>
-              </a:lnSpc>
-              <a:buNone/>
-            </a:pPr>
             <a:r>
               <a:rPr lang="en-US" sz="1750" dirty="0">
                 <a:solidFill>
@@ -10743,12 +10214,6 @@
               <a:t>  --version 1.0.1 --app-version 0.1.1 -d .work/repo
 </a:t>
             </a:r>
-            <a:pPr algn="l" indent="0" marL="0">
-              <a:lnSpc>
-                <a:spcPct val="110000"/>
-              </a:lnSpc>
-              <a:buNone/>
-            </a:pPr>
             <a:r>
               <a:rPr lang="en-US" sz="1750" dirty="0">
                 <a:solidFill>
@@ -10761,12 +10226,6 @@
               <a:t># Pre-releases are valid SemVer and hidden from search until --devel
 </a:t>
             </a:r>
-            <a:pPr algn="l" indent="0" marL="0">
-              <a:lnSpc>
-                <a:spcPct val="110000"/>
-              </a:lnSpc>
-              <a:buNone/>
-            </a:pPr>
             <a:r>
               <a:rPr lang="en-US" sz="1750" dirty="0">
                 <a:solidFill>
@@ -10779,12 +10238,6 @@
               <a:t>helm package charts/shipping-service --version 1.1.0-rc.1 -d .work/repo
 </a:t>
             </a:r>
-            <a:pPr algn="l" indent="0" marL="0">
-              <a:lnSpc>
-                <a:spcPct val="110000"/>
-              </a:lnSpc>
-              <a:buNone/>
-            </a:pPr>
             <a:r>
               <a:rPr lang="en-US" sz="1750" dirty="0">
                 <a:solidFill>
@@ -12203,8 +11656,8 @@
         </p:blipFill>
         <p:spPr>
           <a:xfrm>
-            <a:off x="886968" y="1645920"/>
-            <a:ext cx="10424160" cy="4251960"/>
+            <a:off x="566928" y="1417320"/>
+            <a:ext cx="11055096" cy="4480560"/>
           </a:xfrm>
           <a:prstGeom prst="rect">
             <a:avLst/>
@@ -12519,12 +11972,6 @@
               <a:t># Sign at package time; the key must come from a secret keyring file
 </a:t>
             </a:r>
-            <a:pPr algn="l" indent="0" marL="0">
-              <a:lnSpc>
-                <a:spcPct val="110000"/>
-              </a:lnSpc>
-              <a:buNone/>
-            </a:pPr>
             <a:r>
               <a:rPr lang="en-US" sz="2000" dirty="0">
                 <a:solidFill>
@@ -12537,12 +11984,6 @@
               <a:t>helm package charts/shipping-service --dependency-update --sign \
 </a:t>
             </a:r>
-            <a:pPr algn="l" indent="0" marL="0">
-              <a:lnSpc>
-                <a:spcPct val="110000"/>
-              </a:lnSpc>
-              <a:buNone/>
-            </a:pPr>
             <a:r>
               <a:rPr lang="en-US" sz="2000" dirty="0">
                 <a:solidFill>
@@ -12555,12 +11996,6 @@
               <a:t>  --key "HFD Throwaway Signer" --keyring .work/keys/secring.gpg \
 </a:t>
             </a:r>
-            <a:pPr algn="l" indent="0" marL="0">
-              <a:lnSpc>
-                <a:spcPct val="110000"/>
-              </a:lnSpc>
-              <a:buNone/>
-            </a:pPr>
             <a:r>
               <a:rPr lang="en-US" sz="2000" dirty="0">
                 <a:solidFill>
@@ -12573,12 +12008,6 @@
               <a:t>  -d .work/signed
 </a:t>
             </a:r>
-            <a:pPr algn="l" indent="0" marL="0">
-              <a:lnSpc>
-                <a:spcPct val="110000"/>
-              </a:lnSpc>
-              <a:buNone/>
-            </a:pPr>
             <a:r>
               <a:rPr lang="en-US" sz="2000" dirty="0">
                 <a:solidFill>
@@ -12591,12 +12020,6 @@
               <a:t># Verify the tarball against its .prov file
 </a:t>
             </a:r>
-            <a:pPr algn="l" indent="0" marL="0">
-              <a:lnSpc>
-                <a:spcPct val="110000"/>
-              </a:lnSpc>
-              <a:buNone/>
-            </a:pPr>
             <a:r>
               <a:rPr lang="en-US" sz="2000" dirty="0">
                 <a:solidFill>
@@ -12609,12 +12032,6 @@
               <a:t>helm verify .work/signed/shipping-service-1.0.0.tgz
 </a:t>
             </a:r>
-            <a:pPr algn="l" indent="0" marL="0">
-              <a:lnSpc>
-                <a:spcPct val="110000"/>
-              </a:lnSpc>
-              <a:buNone/>
-            </a:pPr>
             <a:r>
               <a:rPr lang="en-US" sz="2000" dirty="0">
                 <a:solidFill>
@@ -12627,12 +12044,6 @@
               <a:t># Verify while pulling from an OCI registry
 </a:t>
             </a:r>
-            <a:pPr algn="l" indent="0" marL="0">
-              <a:lnSpc>
-                <a:spcPct val="110000"/>
-              </a:lnSpc>
-              <a:buNone/>
-            </a:pPr>
             <a:r>
               <a:rPr lang="en-US" sz="2000" dirty="0">
                 <a:solidFill>
@@ -12645,12 +12056,6 @@
               <a:t>helm pull oci://127.0.0.1:5001/signed/shipping-service \
 </a:t>
             </a:r>
-            <a:pPr algn="l" indent="0" marL="0">
-              <a:lnSpc>
-                <a:spcPct val="110000"/>
-              </a:lnSpc>
-              <a:buNone/>
-            </a:pPr>
             <a:r>
               <a:rPr lang="en-US" sz="2000" dirty="0">
                 <a:solidFill>
@@ -12975,12 +12380,6 @@
               <a:t># A second mechanism: sign the OCI manifest digest, not the tarball
 </a:t>
             </a:r>
-            <a:pPr algn="l" indent="0" marL="0">
-              <a:lnSpc>
-                <a:spcPct val="110000"/>
-              </a:lnSpc>
-              <a:buNone/>
-            </a:pPr>
             <a:r>
               <a:rPr lang="en-US" sz="1850" dirty="0">
                 <a:solidFill>
@@ -12993,12 +12392,6 @@
               <a:t>cosign sign --key .work/cosign/cosign.key --yes --allow-http-registry \
 </a:t>
             </a:r>
-            <a:pPr algn="l" indent="0" marL="0">
-              <a:lnSpc>
-                <a:spcPct val="110000"/>
-              </a:lnSpc>
-              <a:buNone/>
-            </a:pPr>
             <a:r>
               <a:rPr lang="en-US" sz="1850" dirty="0">
                 <a:solidFill>
@@ -13011,12 +12404,6 @@
               <a:t>  --use-signing-config=false --tlog-upload=false \
 </a:t>
             </a:r>
-            <a:pPr algn="l" indent="0" marL="0">
-              <a:lnSpc>
-                <a:spcPct val="110000"/>
-              </a:lnSpc>
-              <a:buNone/>
-            </a:pPr>
             <a:r>
               <a:rPr lang="en-US" sz="1850" dirty="0">
                 <a:solidFill>
@@ -13029,12 +12416,6 @@
               <a:t>  127.0.0.1:5001/signed/shipping-service@sha256:&lt;digest&gt;
 </a:t>
             </a:r>
-            <a:pPr algn="l" indent="0" marL="0">
-              <a:lnSpc>
-                <a:spcPct val="110000"/>
-              </a:lnSpc>
-              <a:buNone/>
-            </a:pPr>
             <a:r>
               <a:rPr lang="en-US" sz="1850" dirty="0">
                 <a:solidFill>
@@ -13047,12 +12428,6 @@
               <a:t>cosign verify --key .work/cosign/cosign.pub --allow-http-registry \
 </a:t>
             </a:r>
-            <a:pPr algn="l" indent="0" marL="0">
-              <a:lnSpc>
-                <a:spcPct val="110000"/>
-              </a:lnSpc>
-              <a:buNone/>
-            </a:pPr>
             <a:r>
               <a:rPr lang="en-US" sz="1850" dirty="0">
                 <a:solidFill>
@@ -13065,12 +12440,6 @@
               <a:t>  --insecure-ignore-tlog \
 </a:t>
             </a:r>
-            <a:pPr algn="l" indent="0" marL="0">
-              <a:lnSpc>
-                <a:spcPct val="110000"/>
-              </a:lnSpc>
-              <a:buNone/>
-            </a:pPr>
             <a:r>
               <a:rPr lang="en-US" sz="1850" dirty="0">
                 <a:solidFill>
@@ -13083,12 +12452,6 @@
               <a:t>  127.0.0.1:5001/signed/shipping-service@sha256:&lt;digest&gt;
 </a:t>
             </a:r>
-            <a:pPr algn="l" indent="0" marL="0">
-              <a:lnSpc>
-                <a:spcPct val="110000"/>
-              </a:lnSpc>
-              <a:buNone/>
-            </a:pPr>
             <a:r>
               <a:rPr lang="en-US" sz="1850" dirty="0">
                 <a:solidFill>
@@ -13101,12 +12464,6 @@
               <a:t># Keyless signing and the transparency log are the default in production:
 </a:t>
             </a:r>
-            <a:pPr algn="l" indent="0" marL="0">
-              <a:lnSpc>
-                <a:spcPct val="110000"/>
-              </a:lnSpc>
-              <a:buNone/>
-            </a:pPr>
             <a:r>
               <a:rPr lang="en-US" sz="1850" dirty="0">
                 <a:solidFill>
@@ -13329,7 +12686,7 @@
                 <a:ea typeface="Red Hat Text" pitchFamily="34" charset="-122"/>
                 <a:cs typeface="Red Hat Text" pitchFamily="34" charset="-120"/>
               </a:rPr>
-              <a:t>Plugins in Helm 4: types, runtimes and post‑renderers.</a:t>
+              <a:t>Plugins in Helm 4: types, runtimes and post-renderers.</a:t>
             </a:r>
             <a:endParaRPr lang="en-US" sz="1600" dirty="0"/>
           </a:p>
@@ -14094,7 +13451,39 @@
                           <a:ea typeface="Red Hat Text" pitchFamily="34" charset="-122"/>
                           <a:cs typeface="Red Hat Text" pitchFamily="34" charset="-120"/>
                         </a:rPr>
-                        <a:t>Rewrites rendered manifests; selected with ‑‑post‑renderer NAME.</a:t>
+                        <a:t>Rewrites rendered manifests; selected with </a:t>
+                      </a:r>
+                      <a:endParaRPr lang="en-US" sz="1500" dirty="0">
+                        <a:latin typeface="Red Hat Text" charset="0"/>
+                        <a:ea typeface="Red Hat Text" charset="0"/>
+                        <a:cs typeface="Red Hat Text" charset="0"/>
+                      </a:endParaRPr>
+                    </a:p>
+                    <a:p>
+                      <a:pPr algn="l" indent="0" marL="0">
+                        <a:buNone/>
+                      </a:pPr>
+                      <a:r>
+                        <a:rPr lang="en-US" sz="1400" dirty="0">
+                          <a:solidFill>
+                            <a:srgbClr val="151515"/>
+                          </a:solidFill>
+                          <a:latin typeface="Red Hat Mono" pitchFamily="34" charset="0"/>
+                          <a:ea typeface="Red Hat Mono" pitchFamily="34" charset="-122"/>
+                          <a:cs typeface="Red Hat Mono" pitchFamily="34" charset="-120"/>
+                        </a:rPr>
+                        <a:t>--post-renderer</a:t>
+                      </a:r>
+                      <a:r>
+                        <a:rPr lang="en-US" sz="1500" dirty="0">
+                          <a:solidFill>
+                            <a:srgbClr val="242424"/>
+                          </a:solidFill>
+                          <a:latin typeface="Red Hat Text" pitchFamily="34" charset="0"/>
+                          <a:ea typeface="Red Hat Text" pitchFamily="34" charset="-122"/>
+                          <a:cs typeface="Red Hat Text" pitchFamily="34" charset="-120"/>
+                        </a:rPr>
+                        <a:t> NAME.</a:t>
                       </a:r>
                       <a:endParaRPr lang="en-US" sz="1500" dirty="0">
                         <a:latin typeface="Red Hat Text" charset="0"/>
@@ -14810,12 +14199,6 @@
               <a:t>apiVersion: v1
 </a:t>
             </a:r>
-            <a:pPr algn="l" indent="0" marL="0">
-              <a:lnSpc>
-                <a:spcPct val="110000"/>
-              </a:lnSpc>
-              <a:buNone/>
-            </a:pPr>
             <a:r>
               <a:rPr lang="en-US" sz="2000" dirty="0">
                 <a:solidFill>
@@ -14828,12 +14211,6 @@
               <a:t>type: cli/v1
 </a:t>
             </a:r>
-            <a:pPr algn="l" indent="0" marL="0">
-              <a:lnSpc>
-                <a:spcPct val="110000"/>
-              </a:lnSpc>
-              <a:buNone/>
-            </a:pPr>
             <a:r>
               <a:rPr lang="en-US" sz="2000" dirty="0">
                 <a:solidFill>
@@ -14846,12 +14223,6 @@
               <a:t>name: wasm-hello
 </a:t>
             </a:r>
-            <a:pPr algn="l" indent="0" marL="0">
-              <a:lnSpc>
-                <a:spcPct val="110000"/>
-              </a:lnSpc>
-              <a:buNone/>
-            </a:pPr>
             <a:r>
               <a:rPr lang="en-US" sz="2000" dirty="0">
                 <a:solidFill>
@@ -14864,12 +14235,6 @@
               <a:t>version: 0.1.0
 </a:t>
             </a:r>
-            <a:pPr algn="l" indent="0" marL="0">
-              <a:lnSpc>
-                <a:spcPct val="110000"/>
-              </a:lnSpc>
-              <a:buNone/>
-            </a:pPr>
             <a:r>
               <a:rPr lang="en-US" sz="2000" dirty="0">
                 <a:solidFill>
@@ -14882,12 +14247,6 @@
               <a:t>runtime: extism/v1
 </a:t>
             </a:r>
-            <a:pPr algn="l" indent="0" marL="0">
-              <a:lnSpc>
-                <a:spcPct val="110000"/>
-              </a:lnSpc>
-              <a:buNone/>
-            </a:pPr>
             <a:r>
               <a:rPr lang="en-US" sz="2000" dirty="0">
                 <a:solidFill>
@@ -14900,12 +14259,6 @@
               <a:t>runtimeConfig:
 </a:t>
             </a:r>
-            <a:pPr algn="l" indent="0" marL="0">
-              <a:lnSpc>
-                <a:spcPct val="110000"/>
-              </a:lnSpc>
-              <a:buNone/>
-            </a:pPr>
             <a:r>
               <a:rPr lang="en-US" sz="2000" dirty="0">
                 <a:solidFill>
@@ -14918,12 +14271,6 @@
               <a:t>  memory:
 </a:t>
             </a:r>
-            <a:pPr algn="l" indent="0" marL="0">
-              <a:lnSpc>
-                <a:spcPct val="110000"/>
-              </a:lnSpc>
-              <a:buNone/>
-            </a:pPr>
             <a:r>
               <a:rPr lang="en-US" sz="2000" dirty="0">
                 <a:solidFill>
@@ -14936,12 +14283,6 @@
               <a:t>    maxPages: 256
 </a:t>
             </a:r>
-            <a:pPr algn="l" indent="0" marL="0">
-              <a:lnSpc>
-                <a:spcPct val="110000"/>
-              </a:lnSpc>
-              <a:buNone/>
-            </a:pPr>
             <a:r>
               <a:rPr lang="en-US" sz="2000" dirty="0">
                 <a:solidFill>
@@ -15266,12 +14607,6 @@
               <a:t>// main.go: the exported entry point
 </a:t>
             </a:r>
-            <a:pPr algn="l" indent="0" marL="0">
-              <a:lnSpc>
-                <a:spcPct val="110000"/>
-              </a:lnSpc>
-              <a:buNone/>
-            </a:pPr>
             <a:r>
               <a:rPr lang="en-US" sz="2000" dirty="0">
                 <a:solidFill>
@@ -15284,12 +14619,6 @@
               <a:t>//go:wasmexport helm_plugin_main
 </a:t>
             </a:r>
-            <a:pPr algn="l" indent="0" marL="0">
-              <a:lnSpc>
-                <a:spcPct val="110000"/>
-              </a:lnSpc>
-              <a:buNone/>
-            </a:pPr>
             <a:r>
               <a:rPr lang="en-US" sz="2000" dirty="0">
                 <a:solidFill>
@@ -15302,12 +14631,6 @@
               <a:t>func helmPluginMain() uint32 { ...; return 0 }
 </a:t>
             </a:r>
-            <a:pPr algn="l" indent="0" marL="0">
-              <a:lnSpc>
-                <a:spcPct val="110000"/>
-              </a:lnSpc>
-              <a:buNone/>
-            </a:pPr>
             <a:r>
               <a:rPr lang="en-US" sz="2000" dirty="0">
                 <a:solidFill>
@@ -15320,12 +14643,6 @@
               <a:t>
 </a:t>
             </a:r>
-            <a:pPr algn="l" indent="0" marL="0">
-              <a:lnSpc>
-                <a:spcPct val="110000"/>
-              </a:lnSpc>
-              <a:buNone/>
-            </a:pPr>
             <a:r>
               <a:rPr lang="en-US" sz="2000" dirty="0">
                 <a:solidFill>
@@ -15338,12 +14655,6 @@
               <a:t># build the module Helm loads as plugin.wasm
 </a:t>
             </a:r>
-            <a:pPr algn="l" indent="0" marL="0">
-              <a:lnSpc>
-                <a:spcPct val="110000"/>
-              </a:lnSpc>
-              <a:buNone/>
-            </a:pPr>
             <a:r>
               <a:rPr lang="en-US" sz="2000" dirty="0">
                 <a:solidFill>
@@ -15356,12 +14667,6 @@
               <a:t>GOOS=wasip1 GOARCH=wasm go build \
 </a:t>
             </a:r>
-            <a:pPr algn="l" indent="0" marL="0">
-              <a:lnSpc>
-                <a:spcPct val="110000"/>
-              </a:lnSpc>
-              <a:buNone/>
-            </a:pPr>
             <a:r>
               <a:rPr lang="en-US" sz="2000" dirty="0">
                 <a:solidFill>
@@ -15374,12 +14679,6 @@
               <a:t>  -buildmode=c-shared -o plugin.wasm .
 </a:t>
             </a:r>
-            <a:pPr algn="l" indent="0" marL="0">
-              <a:lnSpc>
-                <a:spcPct val="110000"/>
-              </a:lnSpc>
-              <a:buNone/>
-            </a:pPr>
             <a:r>
               <a:rPr lang="en-US" sz="2000" dirty="0">
                 <a:solidFill>
@@ -15392,12 +14691,6 @@
               <a:t>
 </a:t>
             </a:r>
-            <a:pPr algn="l" indent="0" marL="0">
-              <a:lnSpc>
-                <a:spcPct val="110000"/>
-              </a:lnSpc>
-              <a:buNone/>
-            </a:pPr>
             <a:r>
               <a:rPr lang="en-US" sz="2000" dirty="0">
                 <a:solidFill>
@@ -15640,7 +14933,7 @@
           <a:bodyPr wrap="square" lIns="0" tIns="0" rIns="0" bIns="0" rtlCol="0" anchor="t"/>
           <a:lstStyle/>
           <a:p>
-            <a:pPr marL="228600" indent="-228600">
+            <a:pPr marL="304800" indent="-304800">
               <a:lnSpc>
                 <a:spcPct val="112000"/>
               </a:lnSpc>
@@ -15664,12 +14957,6 @@
               </a:rPr>
               <a:t>Chart and release</a:t>
             </a:r>
-            <a:pPr indent="0" marL="0">
-              <a:lnSpc>
-                <a:spcPct val="112000"/>
-              </a:lnSpc>
-              <a:buNone/>
-            </a:pPr>
             <a:r>
               <a:rPr lang="en-US" sz="2000" dirty="0">
                 <a:solidFill>
@@ -15684,7 +14971,7 @@
             <a:endParaRPr lang="en-US" sz="2000" dirty="0"/>
           </a:p>
           <a:p>
-            <a:pPr marL="228600" indent="-228600">
+            <a:pPr marL="304800" indent="-304800">
               <a:lnSpc>
                 <a:spcPct val="112000"/>
               </a:lnSpc>
@@ -15708,12 +14995,6 @@
               </a:rPr>
               <a:t>Values</a:t>
             </a:r>
-            <a:pPr indent="0" marL="0">
-              <a:lnSpc>
-                <a:spcPct val="112000"/>
-              </a:lnSpc>
-              <a:buNone/>
-            </a:pPr>
             <a:r>
               <a:rPr lang="en-US" sz="2000" dirty="0">
                 <a:solidFill>
@@ -15723,12 +15004,100 @@
                 <a:ea typeface="Red Hat Text" pitchFamily="34" charset="-122"/>
                 <a:cs typeface="Red Hat Text" pitchFamily="34" charset="-120"/>
               </a:rPr>
-              <a:t> — chart defaults, then ‑f files in order, then ‑‑set, ‑‑set‑json and ‑‑set‑file; a values.schema.json rejects bad input before rendering.</a:t>
+              <a:t> — chart defaults, then </a:t>
+            </a:r>
+            <a:r>
+              <a:rPr lang="en-US" sz="1900" dirty="0">
+                <a:solidFill>
+                  <a:srgbClr val="151515"/>
+                </a:solidFill>
+                <a:latin typeface="Red Hat Mono" pitchFamily="34" charset="0"/>
+                <a:ea typeface="Red Hat Mono" pitchFamily="34" charset="-122"/>
+                <a:cs typeface="Red Hat Mono" pitchFamily="34" charset="-120"/>
+              </a:rPr>
+              <a:t>-f</a:t>
+            </a:r>
+            <a:r>
+              <a:rPr lang="en-US" sz="2000" dirty="0">
+                <a:solidFill>
+                  <a:srgbClr val="242424"/>
+                </a:solidFill>
+                <a:latin typeface="Red Hat Text" pitchFamily="34" charset="0"/>
+                <a:ea typeface="Red Hat Text" pitchFamily="34" charset="-122"/>
+                <a:cs typeface="Red Hat Text" pitchFamily="34" charset="-120"/>
+              </a:rPr>
+              <a:t> files in order, then </a:t>
+            </a:r>
+            <a:r>
+              <a:rPr lang="en-US" sz="1900" dirty="0">
+                <a:solidFill>
+                  <a:srgbClr val="151515"/>
+                </a:solidFill>
+                <a:latin typeface="Red Hat Mono" pitchFamily="34" charset="0"/>
+                <a:ea typeface="Red Hat Mono" pitchFamily="34" charset="-122"/>
+                <a:cs typeface="Red Hat Mono" pitchFamily="34" charset="-120"/>
+              </a:rPr>
+              <a:t>--set</a:t>
+            </a:r>
+            <a:r>
+              <a:rPr lang="en-US" sz="2000" dirty="0">
+                <a:solidFill>
+                  <a:srgbClr val="242424"/>
+                </a:solidFill>
+                <a:latin typeface="Red Hat Text" pitchFamily="34" charset="0"/>
+                <a:ea typeface="Red Hat Text" pitchFamily="34" charset="-122"/>
+                <a:cs typeface="Red Hat Text" pitchFamily="34" charset="-120"/>
+              </a:rPr>
+              <a:t>, </a:t>
+            </a:r>
+            <a:r>
+              <a:rPr lang="en-US" sz="1900" dirty="0">
+                <a:solidFill>
+                  <a:srgbClr val="151515"/>
+                </a:solidFill>
+                <a:latin typeface="Red Hat Mono" pitchFamily="34" charset="0"/>
+                <a:ea typeface="Red Hat Mono" pitchFamily="34" charset="-122"/>
+                <a:cs typeface="Red Hat Mono" pitchFamily="34" charset="-120"/>
+              </a:rPr>
+              <a:t>--set-json</a:t>
+            </a:r>
+            <a:r>
+              <a:rPr lang="en-US" sz="2000" dirty="0">
+                <a:solidFill>
+                  <a:srgbClr val="242424"/>
+                </a:solidFill>
+                <a:latin typeface="Red Hat Text" pitchFamily="34" charset="0"/>
+                <a:ea typeface="Red Hat Text" pitchFamily="34" charset="-122"/>
+                <a:cs typeface="Red Hat Text" pitchFamily="34" charset="-120"/>
+              </a:rPr>
+              <a:t> and </a:t>
+            </a:r>
+            <a:r>
+              <a:rPr lang="en-US" sz="1900" dirty="0">
+                <a:solidFill>
+                  <a:srgbClr val="151515"/>
+                </a:solidFill>
+                <a:latin typeface="Red Hat Mono" pitchFamily="34" charset="0"/>
+                <a:ea typeface="Red Hat Mono" pitchFamily="34" charset="-122"/>
+                <a:cs typeface="Red Hat Mono" pitchFamily="34" charset="-120"/>
+              </a:rPr>
+              <a:t>--set-file</a:t>
+            </a:r>
+            <a:r>
+              <a:rPr lang="en-US" sz="2000" dirty="0">
+                <a:solidFill>
+                  <a:srgbClr val="242424"/>
+                </a:solidFill>
+                <a:latin typeface="Red Hat Text" pitchFamily="34" charset="0"/>
+                <a:ea typeface="Red Hat Text" pitchFamily="34" charset="-122"/>
+                <a:cs typeface="Red Hat Text" pitchFamily="34" charset="-120"/>
+              </a:rPr>
+              <a:t>; a values.schema.json rejects bad input before rendering.</a:t>
             </a:r>
             <a:endParaRPr lang="en-US" sz="2000" dirty="0"/>
           </a:p>
           <a:p>
-            <a:pPr marL="228600" indent="-228600">
+            <a:pPr marL="304800" indent="-304800">
               <a:lnSpc>
                 <a:spcPct val="112000"/>
               </a:lnSpc>
@@ -15752,12 +15121,6 @@
               </a:rPr>
               <a:t>Templates</a:t>
             </a:r>
-            <a:pPr indent="0" marL="0">
-              <a:lnSpc>
-                <a:spcPct val="112000"/>
-              </a:lnSpc>
-              <a:buNone/>
-            </a:pPr>
             <a:r>
               <a:rPr lang="en-US" sz="2000" dirty="0">
                 <a:solidFill>
@@ -15772,7 +15135,7 @@
             <a:endParaRPr lang="en-US" sz="2000" dirty="0"/>
           </a:p>
           <a:p>
-            <a:pPr marL="228600" indent="-228600">
+            <a:pPr marL="304800" indent="-304800">
               <a:lnSpc>
                 <a:spcPct val="112000"/>
               </a:lnSpc>
@@ -15796,12 +15159,6 @@
               </a:rPr>
               <a:t>Safe releases</a:t>
             </a:r>
-            <a:pPr indent="0" marL="0">
-              <a:lnSpc>
-                <a:spcPct val="112000"/>
-              </a:lnSpc>
-              <a:buNone/>
-            </a:pPr>
             <a:r>
               <a:rPr lang="en-US" sz="2000" dirty="0">
                 <a:solidFill>
@@ -15811,7 +15168,51 @@
                 <a:ea typeface="Red Hat Text" pitchFamily="34" charset="-122"/>
                 <a:cs typeface="Red Hat Text" pitchFamily="34" charset="-120"/>
               </a:rPr>
-              <a:t> — ‑‑wait with the kstatus watcher, ‑‑rollback‑on‑failure, server‑side apply by default for new releases.</a:t>
+              <a:t> — </a:t>
+            </a:r>
+            <a:r>
+              <a:rPr lang="en-US" sz="1900" dirty="0">
+                <a:solidFill>
+                  <a:srgbClr val="151515"/>
+                </a:solidFill>
+                <a:latin typeface="Red Hat Mono" pitchFamily="34" charset="0"/>
+                <a:ea typeface="Red Hat Mono" pitchFamily="34" charset="-122"/>
+                <a:cs typeface="Red Hat Mono" pitchFamily="34" charset="-120"/>
+              </a:rPr>
+              <a:t>--wait</a:t>
+            </a:r>
+            <a:r>
+              <a:rPr lang="en-US" sz="2000" dirty="0">
+                <a:solidFill>
+                  <a:srgbClr val="242424"/>
+                </a:solidFill>
+                <a:latin typeface="Red Hat Text" pitchFamily="34" charset="0"/>
+                <a:ea typeface="Red Hat Text" pitchFamily="34" charset="-122"/>
+                <a:cs typeface="Red Hat Text" pitchFamily="34" charset="-120"/>
+              </a:rPr>
+              <a:t> with the kstatus watcher, </a:t>
+            </a:r>
+            <a:r>
+              <a:rPr lang="en-US" sz="1900" dirty="0">
+                <a:solidFill>
+                  <a:srgbClr val="151515"/>
+                </a:solidFill>
+                <a:latin typeface="Red Hat Mono" pitchFamily="34" charset="0"/>
+                <a:ea typeface="Red Hat Mono" pitchFamily="34" charset="-122"/>
+                <a:cs typeface="Red Hat Mono" pitchFamily="34" charset="-120"/>
+              </a:rPr>
+              <a:t>--rollback-on-failure</a:t>
+            </a:r>
+            <a:r>
+              <a:rPr lang="en-US" sz="2000" dirty="0">
+                <a:solidFill>
+                  <a:srgbClr val="242424"/>
+                </a:solidFill>
+                <a:latin typeface="Red Hat Text" pitchFamily="34" charset="0"/>
+                <a:ea typeface="Red Hat Text" pitchFamily="34" charset="-122"/>
+                <a:cs typeface="Red Hat Text" pitchFamily="34" charset="-120"/>
+              </a:rPr>
+              <a:t>, server-side apply by default for new releases.</a:t>
             </a:r>
             <a:endParaRPr lang="en-US" sz="2000" dirty="0"/>
           </a:p>
@@ -15998,8 +15399,8 @@
         </p:blipFill>
         <p:spPr>
           <a:xfrm>
-            <a:off x="886968" y="1645920"/>
-            <a:ext cx="10424160" cy="4251960"/>
+            <a:off x="566928" y="1417320"/>
+            <a:ext cx="11055096" cy="4480560"/>
           </a:xfrm>
           <a:prstGeom prst="rect">
             <a:avLst/>
@@ -16423,8 +15824,8 @@
         </p:blipFill>
         <p:spPr>
           <a:xfrm>
-            <a:off x="886968" y="1645920"/>
-            <a:ext cx="10424160" cy="4251960"/>
+            <a:off x="566928" y="1417320"/>
+            <a:ext cx="11055096" cy="4480560"/>
           </a:xfrm>
           <a:prstGeom prst="rect">
             <a:avLst/>
@@ -16739,12 +16140,6 @@
               <a:t>helmDefaults:
 </a:t>
             </a:r>
-            <a:pPr algn="l" indent="0" marL="0">
-              <a:lnSpc>
-                <a:spcPct val="110000"/>
-              </a:lnSpc>
-              <a:buNone/>
-            </a:pPr>
             <a:r>
               <a:rPr lang="en-US" sz="1650" dirty="0">
                 <a:solidFill>
@@ -16757,12 +16152,6 @@
               <a:t>  wait: true
 </a:t>
             </a:r>
-            <a:pPr algn="l" indent="0" marL="0">
-              <a:lnSpc>
-                <a:spcPct val="110000"/>
-              </a:lnSpc>
-              <a:buNone/>
-            </a:pPr>
             <a:r>
               <a:rPr lang="en-US" sz="1650" dirty="0">
                 <a:solidFill>
@@ -16775,12 +16164,6 @@
               <a:t>  timeout: 600
 </a:t>
             </a:r>
-            <a:pPr algn="l" indent="0" marL="0">
-              <a:lnSpc>
-                <a:spcPct val="110000"/>
-              </a:lnSpc>
-              <a:buNone/>
-            </a:pPr>
             <a:r>
               <a:rPr lang="en-US" sz="1650" dirty="0">
                 <a:solidFill>
@@ -16793,12 +16176,6 @@
               <a:t>  createNamespace: true
 </a:t>
             </a:r>
-            <a:pPr algn="l" indent="0" marL="0">
-              <a:lnSpc>
-                <a:spcPct val="110000"/>
-              </a:lnSpc>
-              <a:buNone/>
-            </a:pPr>
             <a:r>
               <a:rPr lang="en-US" sz="1650" dirty="0">
                 <a:solidFill>
@@ -16811,12 +16188,6 @@
               <a:t>  rollbackOnFailure: true      # Helm 4 flag
 </a:t>
             </a:r>
-            <a:pPr algn="l" indent="0" marL="0">
-              <a:lnSpc>
-                <a:spcPct val="110000"/>
-              </a:lnSpc>
-              <a:buNone/>
-            </a:pPr>
             <a:r>
               <a:rPr lang="en-US" sz="1650" dirty="0">
                 <a:solidFill>
@@ -16829,12 +16200,6 @@
               <a:t>releases:
 </a:t>
             </a:r>
-            <a:pPr algn="l" indent="0" marL="0">
-              <a:lnSpc>
-                <a:spcPct val="110000"/>
-              </a:lnSpc>
-              <a:buNone/>
-            </a:pPr>
             <a:r>
               <a:rPr lang="en-US" sz="1650" dirty="0">
                 <a:solidFill>
@@ -16847,12 +16212,6 @@
               <a:t>  - name: platform
 </a:t>
             </a:r>
-            <a:pPr algn="l" indent="0" marL="0">
-              <a:lnSpc>
-                <a:spcPct val="110000"/>
-              </a:lnSpc>
-              <a:buNone/>
-            </a:pPr>
             <a:r>
               <a:rPr lang="en-US" sz="1650" dirty="0">
                 <a:solidFill>
@@ -16865,12 +16224,6 @@
               <a:t>    namespace: hfd-24-prod
 </a:t>
             </a:r>
-            <a:pPr algn="l" indent="0" marL="0">
-              <a:lnSpc>
-                <a:spcPct val="110000"/>
-              </a:lnSpc>
-              <a:buNone/>
-            </a:pPr>
             <a:r>
               <a:rPr lang="en-US" sz="1650" dirty="0">
                 <a:solidFill>
@@ -16883,12 +16236,6 @@
               <a:t>    chart: ./charts/shipping-platform
 </a:t>
             </a:r>
-            <a:pPr algn="l" indent="0" marL="0">
-              <a:lnSpc>
-                <a:spcPct val="110000"/>
-              </a:lnSpc>
-              <a:buNone/>
-            </a:pPr>
             <a:r>
               <a:rPr lang="en-US" sz="1650" dirty="0">
                 <a:solidFill>
@@ -16901,12 +16248,6 @@
               <a:t>    version: 1.0.0             # the chart pin: one reviewed line per environment
 </a:t>
             </a:r>
-            <a:pPr algn="l" indent="0" marL="0">
-              <a:lnSpc>
-                <a:spcPct val="110000"/>
-              </a:lnSpc>
-              <a:buNone/>
-            </a:pPr>
             <a:r>
               <a:rPr lang="en-US" sz="1650" dirty="0">
                 <a:solidFill>
@@ -16919,12 +16260,6 @@
               <a:t>    labels:
 </a:t>
             </a:r>
-            <a:pPr algn="l" indent="0" marL="0">
-              <a:lnSpc>
-                <a:spcPct val="110000"/>
-              </a:lnSpc>
-              <a:buNone/>
-            </a:pPr>
             <a:r>
               <a:rPr lang="en-US" sz="1650" dirty="0">
                 <a:solidFill>
@@ -16937,12 +16272,6 @@
               <a:t>      env: prod
 </a:t>
             </a:r>
-            <a:pPr algn="l" indent="0" marL="0">
-              <a:lnSpc>
-                <a:spcPct val="110000"/>
-              </a:lnSpc>
-              <a:buNone/>
-            </a:pPr>
             <a:r>
               <a:rPr lang="en-US" sz="1650" dirty="0">
                 <a:solidFill>
@@ -16955,12 +16284,6 @@
               <a:t>    values:
 </a:t>
             </a:r>
-            <a:pPr algn="l" indent="0" marL="0">
-              <a:lnSpc>
-                <a:spcPct val="110000"/>
-              </a:lnSpc>
-              <a:buNone/>
-            </a:pPr>
             <a:r>
               <a:rPr lang="en-US" sz="1650" dirty="0">
                 <a:solidFill>
@@ -16973,12 +16296,6 @@
               <a:t>      - charts/shipping-platform/values-prod.yaml
 </a:t>
             </a:r>
-            <a:pPr algn="l" indent="0" marL="0">
-              <a:lnSpc>
-                <a:spcPct val="110000"/>
-              </a:lnSpc>
-              <a:buNone/>
-            </a:pPr>
             <a:r>
               <a:rPr lang="en-US" sz="1650" dirty="0">
                 <a:solidFill>
@@ -17028,7 +16345,51 @@
                 <a:ea typeface="Red Hat Text" pitchFamily="34" charset="-122"/>
                 <a:cs typeface="Red Hat Text" pitchFamily="34" charset="-120"/>
               </a:rPr>
-              <a:t>helmfile ‑l env=prod template ‑‑skip‑deps renders one environment; Helmfile adds no new Helm flags.</a:t>
+              <a:t>helmfile </a:t>
+            </a:r>
+            <a:r>
+              <a:rPr lang="en-US" sz="1200" i="1" dirty="0">
+                <a:solidFill>
+                  <a:srgbClr val="151515"/>
+                </a:solidFill>
+                <a:latin typeface="Red Hat Mono" pitchFamily="34" charset="0"/>
+                <a:ea typeface="Red Hat Mono" pitchFamily="34" charset="-122"/>
+                <a:cs typeface="Red Hat Mono" pitchFamily="34" charset="-120"/>
+              </a:rPr>
+              <a:t>-l</a:t>
+            </a:r>
+            <a:r>
+              <a:rPr lang="en-US" sz="1300" i="1" dirty="0">
+                <a:solidFill>
+                  <a:srgbClr val="5A5A5A"/>
+                </a:solidFill>
+                <a:latin typeface="Red Hat Text" pitchFamily="34" charset="0"/>
+                <a:ea typeface="Red Hat Text" pitchFamily="34" charset="-122"/>
+                <a:cs typeface="Red Hat Text" pitchFamily="34" charset="-120"/>
+              </a:rPr>
+              <a:t> env=prod template </a:t>
+            </a:r>
+            <a:r>
+              <a:rPr lang="en-US" sz="1200" i="1" dirty="0">
+                <a:solidFill>
+                  <a:srgbClr val="151515"/>
+                </a:solidFill>
+                <a:latin typeface="Red Hat Mono" pitchFamily="34" charset="0"/>
+                <a:ea typeface="Red Hat Mono" pitchFamily="34" charset="-122"/>
+                <a:cs typeface="Red Hat Mono" pitchFamily="34" charset="-120"/>
+              </a:rPr>
+              <a:t>--skip-deps</a:t>
+            </a:r>
+            <a:r>
+              <a:rPr lang="en-US" sz="1300" i="1" dirty="0">
+                <a:solidFill>
+                  <a:srgbClr val="5A5A5A"/>
+                </a:solidFill>
+                <a:latin typeface="Red Hat Text" pitchFamily="34" charset="0"/>
+                <a:ea typeface="Red Hat Text" pitchFamily="34" charset="-122"/>
+                <a:cs typeface="Red Hat Text" pitchFamily="34" charset="-120"/>
+              </a:rPr>
+              <a:t> renders one environment; Helmfile adds no new Helm flags.</a:t>
             </a:r>
             <a:endParaRPr lang="en-US" sz="1300" dirty="0"/>
           </a:p>
@@ -17215,8 +16576,8 @@
         </p:blipFill>
         <p:spPr>
           <a:xfrm>
-            <a:off x="886968" y="1645920"/>
-            <a:ext cx="10424160" cy="4251960"/>
+            <a:off x="566928" y="1417320"/>
+            <a:ext cx="11055096" cy="4480560"/>
           </a:xfrm>
           <a:prstGeom prst="rect">
             <a:avLst/>
@@ -18658,7 +18019,7 @@
         <p:spPr>
           <a:xfrm>
             <a:off x="566928" y="1417320"/>
-            <a:ext cx="11055096" cy="4434840"/>
+            <a:ext cx="11055096" cy="3603346"/>
           </a:xfrm>
           <a:prstGeom prst="rect">
             <a:avLst/>
@@ -18683,7 +18044,7 @@
         <p:spPr>
           <a:xfrm>
             <a:off x="749808" y="1508760"/>
-            <a:ext cx="10689336" cy="4251960"/>
+            <a:ext cx="10689336" cy="3420466"/>
           </a:xfrm>
           <a:prstGeom prst="rect">
             <a:avLst/>
@@ -18702,7 +18063,7 @@
               <a:buNone/>
             </a:pPr>
             <a:r>
-              <a:rPr lang="en-US" sz="1550" dirty="0">
+              <a:rPr lang="en-US" sz="1600" dirty="0">
                 <a:solidFill>
                   <a:srgbClr val="E6E6E6"/>
                 </a:solidFill>
@@ -18713,14 +18074,8 @@
               <a:t>{{- define "pc-lib.otelEnv" -}}
 </a:t>
             </a:r>
-            <a:pPr algn="l" indent="0" marL="0">
-              <a:lnSpc>
-                <a:spcPct val="110000"/>
-              </a:lnSpc>
-              <a:buNone/>
-            </a:pPr>
-            <a:r>
-              <a:rPr lang="en-US" sz="1550" dirty="0">
+            <a:r>
+              <a:rPr lang="en-US" sz="1600" dirty="0">
                 <a:solidFill>
                   <a:srgbClr val="E6E6E6"/>
                 </a:solidFill>
@@ -18731,14 +18086,8 @@
               <a:t>{{- $global := default (dict) .Values.global -}}
 </a:t>
             </a:r>
-            <a:pPr algn="l" indent="0" marL="0">
-              <a:lnSpc>
-                <a:spcPct val="110000"/>
-              </a:lnSpc>
-              <a:buNone/>
-            </a:pPr>
-            <a:r>
-              <a:rPr lang="en-US" sz="1550" dirty="0">
+            <a:r>
+              <a:rPr lang="en-US" sz="1600" dirty="0">
                 <a:solidFill>
                   <a:srgbClr val="E6E6E6"/>
                 </a:solidFill>
@@ -18749,14 +18098,8 @@
               <a:t>{{- $endpoint := default (default "" $global.otlpEndpoint) .Values.otel.endpoint -}}
 </a:t>
             </a:r>
-            <a:pPr algn="l" indent="0" marL="0">
-              <a:lnSpc>
-                <a:spcPct val="110000"/>
-              </a:lnSpc>
-              <a:buNone/>
-            </a:pPr>
-            <a:r>
-              <a:rPr lang="en-US" sz="1550" dirty="0">
+            <a:r>
+              <a:rPr lang="en-US" sz="1600" dirty="0">
                 <a:solidFill>
                   <a:srgbClr val="E6E6E6"/>
                 </a:solidFill>
@@ -18764,17 +18107,11 @@
                 <a:ea typeface="Red Hat Mono" pitchFamily="34" charset="-122"/>
                 <a:cs typeface="Red Hat Mono" pitchFamily="34" charset="-120"/>
               </a:rPr>
-              <a:t>{{- $svc := default (include "pc-lib.fullname" .) .Values.otel.serviceName -}}
+              <a:t>- name: OTEL_SDK_DISABLED
 </a:t>
             </a:r>
-            <a:pPr algn="l" indent="0" marL="0">
-              <a:lnSpc>
-                <a:spcPct val="110000"/>
-              </a:lnSpc>
-              <a:buNone/>
-            </a:pPr>
-            <a:r>
-              <a:rPr lang="en-US" sz="1550" dirty="0">
+            <a:r>
+              <a:rPr lang="en-US" sz="1600" dirty="0">
                 <a:solidFill>
                   <a:srgbClr val="E6E6E6"/>
                 </a:solidFill>
@@ -18782,17 +18119,11 @@
                 <a:ea typeface="Red Hat Mono" pitchFamily="34" charset="-122"/>
                 <a:cs typeface="Red Hat Mono" pitchFamily="34" charset="-120"/>
               </a:rPr>
-              <a:t>- name: OTEL_SDK_DISABLED
+              <a:t>  value: {{ if $endpoint }}"false"{{ else }}"true"{{ end }}
 </a:t>
             </a:r>
-            <a:pPr algn="l" indent="0" marL="0">
-              <a:lnSpc>
-                <a:spcPct val="110000"/>
-              </a:lnSpc>
-              <a:buNone/>
-            </a:pPr>
-            <a:r>
-              <a:rPr lang="en-US" sz="1550" dirty="0">
+            <a:r>
+              <a:rPr lang="en-US" sz="1600" dirty="0">
                 <a:solidFill>
                   <a:srgbClr val="E6E6E6"/>
                 </a:solidFill>
@@ -18800,17 +18131,11 @@
                 <a:ea typeface="Red Hat Mono" pitchFamily="34" charset="-122"/>
                 <a:cs typeface="Red Hat Mono" pitchFamily="34" charset="-120"/>
               </a:rPr>
-              <a:t>  value: {{ if $endpoint }}"false"{{ else }}"true"{{ end }}
+              <a:t>{{- if $endpoint }}
 </a:t>
             </a:r>
-            <a:pPr algn="l" indent="0" marL="0">
-              <a:lnSpc>
-                <a:spcPct val="110000"/>
-              </a:lnSpc>
-              <a:buNone/>
-            </a:pPr>
-            <a:r>
-              <a:rPr lang="en-US" sz="1550" dirty="0">
+            <a:r>
+              <a:rPr lang="en-US" sz="1600" dirty="0">
                 <a:solidFill>
                   <a:srgbClr val="E6E6E6"/>
                 </a:solidFill>
@@ -18818,17 +18143,11 @@
                 <a:ea typeface="Red Hat Mono" pitchFamily="34" charset="-122"/>
                 <a:cs typeface="Red Hat Mono" pitchFamily="34" charset="-120"/>
               </a:rPr>
-              <a:t>{{- if $endpoint }}
+              <a:t>- name: OTEL_EXPORTER_OTLP_ENDPOINT
 </a:t>
             </a:r>
-            <a:pPr algn="l" indent="0" marL="0">
-              <a:lnSpc>
-                <a:spcPct val="110000"/>
-              </a:lnSpc>
-              <a:buNone/>
-            </a:pPr>
-            <a:r>
-              <a:rPr lang="en-US" sz="1550" dirty="0">
+            <a:r>
+              <a:rPr lang="en-US" sz="1600" dirty="0">
                 <a:solidFill>
                   <a:srgbClr val="E6E6E6"/>
                 </a:solidFill>
@@ -18836,17 +18155,11 @@
                 <a:ea typeface="Red Hat Mono" pitchFamily="34" charset="-122"/>
                 <a:cs typeface="Red Hat Mono" pitchFamily="34" charset="-120"/>
               </a:rPr>
-              <a:t>- name: OTEL_EXPORTER_OTLP_ENDPOINT
+              <a:t>  value: {{ $endpoint | quote }}
 </a:t>
             </a:r>
-            <a:pPr algn="l" indent="0" marL="0">
-              <a:lnSpc>
-                <a:spcPct val="110000"/>
-              </a:lnSpc>
-              <a:buNone/>
-            </a:pPr>
-            <a:r>
-              <a:rPr lang="en-US" sz="1550" dirty="0">
+            <a:r>
+              <a:rPr lang="en-US" sz="1600" dirty="0">
                 <a:solidFill>
                   <a:srgbClr val="E6E6E6"/>
                 </a:solidFill>
@@ -18854,35 +18167,23 @@
                 <a:ea typeface="Red Hat Mono" pitchFamily="34" charset="-122"/>
                 <a:cs typeface="Red Hat Mono" pitchFamily="34" charset="-120"/>
               </a:rPr>
-              <a:t>  value: {{ $endpoint | quote }}
+              <a:t>{{- end }}
 </a:t>
             </a:r>
-            <a:pPr algn="l" indent="0" marL="0">
-              <a:lnSpc>
-                <a:spcPct val="110000"/>
-              </a:lnSpc>
-              <a:buNone/>
-            </a:pPr>
-            <a:r>
-              <a:rPr lang="en-US" sz="1550" dirty="0">
-                <a:solidFill>
-                  <a:srgbClr val="E6E6E6"/>
+            <a:r>
+              <a:rPr lang="en-US" sz="1600" dirty="0">
+                <a:solidFill>
+                  <a:srgbClr val="8FB98F"/>
                 </a:solidFill>
                 <a:latin typeface="Red Hat Mono" pitchFamily="34" charset="0"/>
                 <a:ea typeface="Red Hat Mono" pitchFamily="34" charset="-122"/>
                 <a:cs typeface="Red Hat Mono" pitchFamily="34" charset="-120"/>
               </a:rPr>
-              <a:t>{{- end }}
+              <a:t># umbrella values.yaml
 </a:t>
             </a:r>
-            <a:pPr algn="l" indent="0" marL="0">
-              <a:lnSpc>
-                <a:spcPct val="110000"/>
-              </a:lnSpc>
-              <a:buNone/>
-            </a:pPr>
-            <a:r>
-              <a:rPr lang="en-US" sz="1550" dirty="0">
+            <a:r>
+              <a:rPr lang="en-US" sz="1600" dirty="0">
                 <a:solidFill>
                   <a:srgbClr val="E6E6E6"/>
                 </a:solidFill>
@@ -18890,17 +18191,11 @@
                 <a:ea typeface="Red Hat Mono" pitchFamily="34" charset="-122"/>
                 <a:cs typeface="Red Hat Mono" pitchFamily="34" charset="-120"/>
               </a:rPr>
-              <a:t>- name: OTEL_SERVICE_NAME
+              <a:t>global:
 </a:t>
             </a:r>
-            <a:pPr algn="l" indent="0" marL="0">
-              <a:lnSpc>
-                <a:spcPct val="110000"/>
-              </a:lnSpc>
-              <a:buNone/>
-            </a:pPr>
-            <a:r>
-              <a:rPr lang="en-US" sz="1550" dirty="0">
+            <a:r>
+              <a:rPr lang="en-US" sz="1600" dirty="0">
                 <a:solidFill>
                   <a:srgbClr val="E6E6E6"/>
                 </a:solidFill>
@@ -18908,82 +18203,10 @@
                 <a:ea typeface="Red Hat Mono" pitchFamily="34" charset="-122"/>
                 <a:cs typeface="Red Hat Mono" pitchFamily="34" charset="-120"/>
               </a:rPr>
-              <a:t>  value: {{ $svc | quote }}
-</a:t>
-            </a:r>
-            <a:pPr algn="l" indent="0" marL="0">
-              <a:lnSpc>
-                <a:spcPct val="110000"/>
-              </a:lnSpc>
-              <a:buNone/>
-            </a:pPr>
-            <a:r>
-              <a:rPr lang="en-US" sz="1550" dirty="0">
-                <a:solidFill>
-                  <a:srgbClr val="8FB98F"/>
-                </a:solidFill>
-                <a:latin typeface="Red Hat Mono" pitchFamily="34" charset="0"/>
-                <a:ea typeface="Red Hat Mono" pitchFamily="34" charset="-122"/>
-                <a:cs typeface="Red Hat Mono" pitchFamily="34" charset="-120"/>
-              </a:rPr>
-              <a:t># umbrella values.yaml
-</a:t>
-            </a:r>
-            <a:pPr algn="l" indent="0" marL="0">
-              <a:lnSpc>
-                <a:spcPct val="110000"/>
-              </a:lnSpc>
-              <a:buNone/>
-            </a:pPr>
-            <a:r>
-              <a:rPr lang="en-US" sz="1550" dirty="0">
-                <a:solidFill>
-                  <a:srgbClr val="E6E6E6"/>
-                </a:solidFill>
-                <a:latin typeface="Red Hat Mono" pitchFamily="34" charset="0"/>
-                <a:ea typeface="Red Hat Mono" pitchFamily="34" charset="-122"/>
-                <a:cs typeface="Red Hat Mono" pitchFamily="34" charset="-120"/>
-              </a:rPr>
-              <a:t>global:
-</a:t>
-            </a:r>
-            <a:pPr algn="l" indent="0" marL="0">
-              <a:lnSpc>
-                <a:spcPct val="110000"/>
-              </a:lnSpc>
-              <a:buNone/>
-            </a:pPr>
-            <a:r>
-              <a:rPr lang="en-US" sz="1550" dirty="0">
-                <a:solidFill>
-                  <a:srgbClr val="E6E6E6"/>
-                </a:solidFill>
-                <a:latin typeface="Red Hat Mono" pitchFamily="34" charset="0"/>
-                <a:ea typeface="Red Hat Mono" pitchFamily="34" charset="-122"/>
-                <a:cs typeface="Red Hat Mono" pitchFamily="34" charset="-120"/>
-              </a:rPr>
-              <a:t>  environment: dev
-</a:t>
-            </a:r>
-            <a:pPr algn="l" indent="0" marL="0">
-              <a:lnSpc>
-                <a:spcPct val="110000"/>
-              </a:lnSpc>
-              <a:buNone/>
-            </a:pPr>
-            <a:r>
-              <a:rPr lang="en-US" sz="1550" dirty="0">
-                <a:solidFill>
-                  <a:srgbClr val="E6E6E6"/>
-                </a:solidFill>
-                <a:latin typeface="Red Hat Mono" pitchFamily="34" charset="0"/>
-                <a:ea typeface="Red Hat Mono" pitchFamily="34" charset="-122"/>
-                <a:cs typeface="Red Hat Mono" pitchFamily="34" charset="-120"/>
-              </a:rPr>
               <a:t>  otlpEndpoint: http://otel-collector.observability.svc.cluster.local:4318
 </a:t>
             </a:r>
-            <a:endParaRPr lang="en-US" sz="1550" dirty="0"/>
+            <a:endParaRPr lang="en-US" sz="1600" dirty="0"/>
           </a:p>
         </p:txBody>
       </p:sp>
@@ -18995,7 +18218,7 @@
         </p:nvSpPr>
         <p:spPr>
           <a:xfrm>
-            <a:off x="566928" y="5943600"/>
+            <a:off x="566928" y="5112106"/>
             <a:ext cx="11055096" cy="310896"/>
           </a:xfrm>
           <a:prstGeom prst="rect">
@@ -19207,8 +18430,8 @@
         </p:blipFill>
         <p:spPr>
           <a:xfrm>
-            <a:off x="886968" y="1645920"/>
-            <a:ext cx="10424160" cy="4251960"/>
+            <a:off x="566928" y="1417320"/>
+            <a:ext cx="11055096" cy="4480560"/>
           </a:xfrm>
           <a:prstGeom prst="rect">
             <a:avLst/>
@@ -19638,7 +18861,7 @@
           <a:bodyPr wrap="square" lIns="0" tIns="0" rIns="0" bIns="0" rtlCol="0" anchor="t"/>
           <a:lstStyle/>
           <a:p>
-            <a:pPr marL="228600" indent="-228600">
+            <a:pPr marL="304800" indent="-304800">
               <a:lnSpc>
                 <a:spcPct val="112000"/>
               </a:lnSpc>
@@ -19662,12 +18885,6 @@
               </a:rPr>
               <a:t>restricted-v2</a:t>
             </a:r>
-            <a:pPr indent="0" marL="0">
-              <a:lnSpc>
-                <a:spcPct val="112000"/>
-              </a:lnSpc>
-              <a:buNone/>
-            </a:pPr>
             <a:r>
               <a:rPr lang="en-US" sz="2000" dirty="0">
                 <a:solidFill>
@@ -19682,7 +18899,7 @@
             <a:endParaRPr lang="en-US" sz="2000" dirty="0"/>
           </a:p>
           <a:p>
-            <a:pPr marL="228600" indent="-228600">
+            <a:pPr marL="304800" indent="-304800">
               <a:lnSpc>
                 <a:spcPct val="112000"/>
               </a:lnSpc>
@@ -19706,12 +18923,6 @@
               </a:rPr>
               <a:t>runAsUser fails</a:t>
             </a:r>
-            <a:pPr indent="0" marL="0">
-              <a:lnSpc>
-                <a:spcPct val="112000"/>
-              </a:lnSpc>
-              <a:buNone/>
-            </a:pPr>
             <a:r>
               <a:rPr lang="en-US" sz="2000" dirty="0">
                 <a:solidFill>
@@ -19726,7 +18937,7 @@
             <a:endParaRPr lang="en-US" sz="2000" dirty="0"/>
           </a:p>
           <a:p>
-            <a:pPr marL="228600" indent="-228600">
+            <a:pPr marL="304800" indent="-304800">
               <a:lnSpc>
                 <a:spcPct val="112000"/>
               </a:lnSpc>
@@ -19750,12 +18961,6 @@
               </a:rPr>
               <a:t>pc-lib avoids it</a:t>
             </a:r>
-            <a:pPr indent="0" marL="0">
-              <a:lnSpc>
-                <a:spcPct val="112000"/>
-              </a:lnSpc>
-              <a:buNone/>
-            </a:pPr>
             <a:r>
               <a:rPr lang="en-US" sz="2000" dirty="0">
                 <a:solidFill>
@@ -19770,7 +18975,7 @@
             <a:endParaRPr lang="en-US" sz="2000" dirty="0"/>
           </a:p>
           <a:p>
-            <a:pPr marL="228600" indent="-228600">
+            <a:pPr marL="304800" indent="-304800">
               <a:lnSpc>
                 <a:spcPct val="112000"/>
               </a:lnSpc>
@@ -19794,12 +18999,6 @@
               </a:rPr>
               <a:t>Group-0 files</a:t>
             </a:r>
-            <a:pPr indent="0" marL="0">
-              <a:lnSpc>
-                <a:spcPct val="112000"/>
-              </a:lnSpc>
-              <a:buNone/>
-            </a:pPr>
             <a:r>
               <a:rPr lang="en-US" sz="2000" dirty="0">
                 <a:solidFill>
@@ -19809,7 +19008,7 @@
                 <a:ea typeface="Red Hat Text" pitchFamily="34" charset="-122"/>
                 <a:cs typeface="Red Hat Text" pitchFamily="34" charset="-120"/>
               </a:rPr>
-              <a:t> — the image makes its files group‑0 readable, so the assigned UID, near 1000650000, still runs the container.</a:t>
+              <a:t> — the image makes its files group-0 readable, so the assigned UID, near 1000650000, still runs the container.</a:t>
             </a:r>
             <a:endParaRPr lang="en-US" sz="2000" dirty="0"/>
           </a:p>
@@ -20281,12 +19480,6 @@
               <a:t># Same chart as minikube, with the OpenShift overrides
 </a:t>
             </a:r>
-            <a:pPr algn="l" indent="0" marL="0">
-              <a:lnSpc>
-                <a:spcPct val="110000"/>
-              </a:lnSpc>
-              <a:buNone/>
-            </a:pPr>
             <a:r>
               <a:rPr lang="en-US" sz="1850" dirty="0">
                 <a:solidFill>
@@ -20299,12 +19492,6 @@
               <a:t>helm upgrade --install platform charts/shipping-platform -n hfd-ocp \
 </a:t>
             </a:r>
-            <a:pPr algn="l" indent="0" marL="0">
-              <a:lnSpc>
-                <a:spcPct val="110000"/>
-              </a:lnSpc>
-              <a:buNone/>
-            </a:pPr>
             <a:r>
               <a:rPr lang="en-US" sz="1850" dirty="0">
                 <a:solidFill>
@@ -20317,12 +19504,6 @@
               <a:t>  -f values-openshift.yaml -f values-openshift-minimal.yaml \
 </a:t>
             </a:r>
-            <a:pPr algn="l" indent="0" marL="0">
-              <a:lnSpc>
-                <a:spcPct val="110000"/>
-              </a:lnSpc>
-              <a:buNone/>
-            </a:pPr>
             <a:r>
               <a:rPr lang="en-US" sz="1850" dirty="0">
                 <a:solidFill>
@@ -20335,12 +19516,6 @@
               <a:t>  --wait --rollback-on-failure
 </a:t>
             </a:r>
-            <a:pPr algn="l" indent="0" marL="0">
-              <a:lnSpc>
-                <a:spcPct val="110000"/>
-              </a:lnSpc>
-              <a:buNone/>
-            </a:pPr>
             <a:r>
               <a:rPr lang="en-US" sz="1850" dirty="0">
                 <a:solidFill>
@@ -20353,12 +19528,6 @@
               <a:t># values-openshift.yaml
 </a:t>
             </a:r>
-            <a:pPr algn="l" indent="0" marL="0">
-              <a:lnSpc>
-                <a:spcPct val="110000"/>
-              </a:lnSpc>
-              <a:buNone/>
-            </a:pPr>
             <a:r>
               <a:rPr lang="en-US" sz="1850" dirty="0">
                 <a:solidFill>
@@ -20371,12 +19540,6 @@
               <a:t>global:
 </a:t>
             </a:r>
-            <a:pPr algn="l" indent="0" marL="0">
-              <a:lnSpc>
-                <a:spcPct val="110000"/>
-              </a:lnSpc>
-              <a:buNone/>
-            </a:pPr>
             <a:r>
               <a:rPr lang="en-US" sz="1850" dirty="0">
                 <a:solidFill>
@@ -20389,12 +19552,6 @@
               <a:t>  environment: openshift
 </a:t>
             </a:r>
-            <a:pPr algn="l" indent="0" marL="0">
-              <a:lnSpc>
-                <a:spcPct val="110000"/>
-              </a:lnSpc>
-              <a:buNone/>
-            </a:pPr>
             <a:r>
               <a:rPr lang="en-US" sz="1850" dirty="0">
                 <a:solidFill>
@@ -20407,12 +19564,6 @@
               <a:t>  imageRegistry: image-registry.openshift-image-registry.svc:5000/hfd-ocp
 </a:t>
             </a:r>
-            <a:pPr algn="l" indent="0" marL="0">
-              <a:lnSpc>
-                <a:spcPct val="110000"/>
-              </a:lnSpc>
-              <a:buNone/>
-            </a:pPr>
             <a:r>
               <a:rPr lang="en-US" sz="1850" dirty="0">
                 <a:solidFill>
@@ -20425,12 +19576,6 @@
               <a:t>shipping:
 </a:t>
             </a:r>
-            <a:pPr algn="l" indent="0" marL="0">
-              <a:lnSpc>
-                <a:spcPct val="110000"/>
-              </a:lnSpc>
-              <a:buNone/>
-            </a:pPr>
             <a:r>
               <a:rPr lang="en-US" sz="1850" dirty="0">
                 <a:solidFill>
@@ -20443,12 +19588,6 @@
               <a:t>  service:
 </a:t>
             </a:r>
-            <a:pPr algn="l" indent="0" marL="0">
-              <a:lnSpc>
-                <a:spcPct val="110000"/>
-              </a:lnSpc>
-              <a:buNone/>
-            </a:pPr>
             <a:r>
               <a:rPr lang="en-US" sz="1850" dirty="0">
                 <a:solidFill>
@@ -20773,12 +19912,6 @@
               <a:t># Developer console: expose a chart repository to one project
 </a:t>
             </a:r>
-            <a:pPr algn="l" indent="0" marL="0">
-              <a:lnSpc>
-                <a:spcPct val="110000"/>
-              </a:lnSpc>
-              <a:buNone/>
-            </a:pPr>
             <a:r>
               <a:rPr lang="en-US" sz="2000" dirty="0">
                 <a:solidFill>
@@ -20791,12 +19924,6 @@
               <a:t>apiVersion: helm.openshift.io/v1beta1
 </a:t>
             </a:r>
-            <a:pPr algn="l" indent="0" marL="0">
-              <a:lnSpc>
-                <a:spcPct val="110000"/>
-              </a:lnSpc>
-              <a:buNone/>
-            </a:pPr>
             <a:r>
               <a:rPr lang="en-US" sz="2000" dirty="0">
                 <a:solidFill>
@@ -20809,12 +19936,6 @@
               <a:t>kind: ProjectHelmChartRepository
 </a:t>
             </a:r>
-            <a:pPr algn="l" indent="0" marL="0">
-              <a:lnSpc>
-                <a:spcPct val="110000"/>
-              </a:lnSpc>
-              <a:buNone/>
-            </a:pPr>
             <a:r>
               <a:rPr lang="en-US" sz="2000" dirty="0">
                 <a:solidFill>
@@ -20827,12 +19948,6 @@
               <a:t>metadata:
 </a:t>
             </a:r>
-            <a:pPr algn="l" indent="0" marL="0">
-              <a:lnSpc>
-                <a:spcPct val="110000"/>
-              </a:lnSpc>
-              <a:buNone/>
-            </a:pPr>
             <a:r>
               <a:rPr lang="en-US" sz="2000" dirty="0">
                 <a:solidFill>
@@ -20845,12 +19960,6 @@
               <a:t>  name: hfd-charts
 </a:t>
             </a:r>
-            <a:pPr algn="l" indent="0" marL="0">
-              <a:lnSpc>
-                <a:spcPct val="110000"/>
-              </a:lnSpc>
-              <a:buNone/>
-            </a:pPr>
             <a:r>
               <a:rPr lang="en-US" sz="2000" dirty="0">
                 <a:solidFill>
@@ -20863,12 +19972,6 @@
               <a:t>  namespace: hfd-ocp
 </a:t>
             </a:r>
-            <a:pPr algn="l" indent="0" marL="0">
-              <a:lnSpc>
-                <a:spcPct val="110000"/>
-              </a:lnSpc>
-              <a:buNone/>
-            </a:pPr>
             <a:r>
               <a:rPr lang="en-US" sz="2000" dirty="0">
                 <a:solidFill>
@@ -20881,12 +19984,6 @@
               <a:t>spec:
 </a:t>
             </a:r>
-            <a:pPr algn="l" indent="0" marL="0">
-              <a:lnSpc>
-                <a:spcPct val="110000"/>
-              </a:lnSpc>
-              <a:buNone/>
-            </a:pPr>
             <a:r>
               <a:rPr lang="en-US" sz="2000" dirty="0">
                 <a:solidFill>
@@ -20899,12 +19996,6 @@
               <a:t>  connectionConfig:
 </a:t>
             </a:r>
-            <a:pPr algn="l" indent="0" marL="0">
-              <a:lnSpc>
-                <a:spcPct val="110000"/>
-              </a:lnSpc>
-              <a:buNone/>
-            </a:pPr>
             <a:r>
               <a:rPr lang="en-US" sz="2000" dirty="0">
                 <a:solidFill>
@@ -21147,7 +20238,7 @@
           <a:bodyPr wrap="square" lIns="0" tIns="0" rIns="0" bIns="0" rtlCol="0" anchor="t"/>
           <a:lstStyle/>
           <a:p>
-            <a:pPr marL="228600" indent="-228600">
+            <a:pPr marL="304800" indent="-304800">
               <a:lnSpc>
                 <a:spcPct val="112000"/>
               </a:lnSpc>
@@ -21171,12 +20262,6 @@
               </a:rPr>
               <a:t>Test in layers</a:t>
             </a:r>
-            <a:pPr indent="0" marL="0">
-              <a:lnSpc>
-                <a:spcPct val="112000"/>
-              </a:lnSpc>
-              <a:buNone/>
-            </a:pPr>
             <a:r>
               <a:rPr lang="en-US" sz="1800" dirty="0">
                 <a:solidFill>
@@ -21191,7 +20276,7 @@
             <a:endParaRPr lang="en-US" sz="1800" dirty="0"/>
           </a:p>
           <a:p>
-            <a:pPr marL="228600" indent="-228600">
+            <a:pPr marL="304800" indent="-304800">
               <a:lnSpc>
                 <a:spcPct val="112000"/>
               </a:lnSpc>
@@ -21215,12 +20300,6 @@
               </a:rPr>
               <a:t>Compose with intent</a:t>
             </a:r>
-            <a:pPr indent="0" marL="0">
-              <a:lnSpc>
-                <a:spcPct val="112000"/>
-              </a:lnSpc>
-              <a:buNone/>
-            </a:pPr>
             <a:r>
               <a:rPr lang="en-US" sz="1800" dirty="0">
                 <a:solidFill>
@@ -21235,7 +20314,7 @@
             <a:endParaRPr lang="en-US" sz="1800" dirty="0"/>
           </a:p>
           <a:p>
-            <a:pPr marL="228600" indent="-228600">
+            <a:pPr marL="304800" indent="-304800">
               <a:lnSpc>
                 <a:spcPct val="112000"/>
               </a:lnSpc>
@@ -21259,12 +20338,6 @@
               </a:rPr>
               <a:t>Ship by digest</a:t>
             </a:r>
-            <a:pPr indent="0" marL="0">
-              <a:lnSpc>
-                <a:spcPct val="112000"/>
-              </a:lnSpc>
-              <a:buNone/>
-            </a:pPr>
             <a:r>
               <a:rPr lang="en-US" sz="1800" dirty="0">
                 <a:solidFill>
@@ -21279,7 +20352,7 @@
             <a:endParaRPr lang="en-US" sz="1800" dirty="0"/>
           </a:p>
           <a:p>
-            <a:pPr marL="228600" indent="-228600">
+            <a:pPr marL="304800" indent="-304800">
               <a:lnSpc>
                 <a:spcPct val="112000"/>
               </a:lnSpc>
@@ -21303,12 +20376,6 @@
               </a:rPr>
               <a:t>Extend through plugins</a:t>
             </a:r>
-            <a:pPr indent="0" marL="0">
-              <a:lnSpc>
-                <a:spcPct val="112000"/>
-              </a:lnSpc>
-              <a:buNone/>
-            </a:pPr>
             <a:r>
               <a:rPr lang="en-US" sz="1800" dirty="0">
                 <a:solidFill>
@@ -21318,12 +20385,12 @@
                 <a:ea typeface="Red Hat Text" pitchFamily="34" charset="-122"/>
                 <a:cs typeface="Red Hat Text" pitchFamily="34" charset="-120"/>
               </a:rPr>
-              <a:t> — typed plugins and Wasm in Helm 4; post‑renderers are plugins only.</a:t>
+              <a:t> — typed plugins and Wasm in Helm 4; post-renderers are plugins only.</a:t>
             </a:r>
             <a:endParaRPr lang="en-US" sz="1800" dirty="0"/>
           </a:p>
           <a:p>
-            <a:pPr marL="228600" indent="-228600">
+            <a:pPr marL="304800" indent="-304800">
               <a:lnSpc>
                 <a:spcPct val="112000"/>
               </a:lnSpc>
@@ -21347,12 +20414,6 @@
               </a:rPr>
               <a:t>Choose who runs the release</a:t>
             </a:r>
-            <a:pPr indent="0" marL="0">
-              <a:lnSpc>
-                <a:spcPct val="112000"/>
-              </a:lnSpc>
-              <a:buNone/>
-            </a:pPr>
             <a:r>
               <a:rPr lang="en-US" sz="1800" dirty="0">
                 <a:solidFill>
@@ -21906,7 +20967,39 @@
                           <a:ea typeface="Red Hat Text" pitchFamily="34" charset="-122"/>
                           <a:cs typeface="Red Hat Text" pitchFamily="34" charset="-120"/>
                         </a:rPr>
-                        <a:t>Render-only tests; ‑u refreshes snapshots.</a:t>
+                        <a:t>Render-only tests; </a:t>
+                      </a:r>
+                      <a:endParaRPr lang="en-US" sz="1400" dirty="0">
+                        <a:latin typeface="Red Hat Text" charset="0"/>
+                        <a:ea typeface="Red Hat Text" charset="0"/>
+                        <a:cs typeface="Red Hat Text" charset="0"/>
+                      </a:endParaRPr>
+                    </a:p>
+                    <a:p>
+                      <a:pPr algn="l" indent="0" marL="0">
+                        <a:buNone/>
+                      </a:pPr>
+                      <a:r>
+                        <a:rPr lang="en-US" sz="1300" dirty="0">
+                          <a:solidFill>
+                            <a:srgbClr val="151515"/>
+                          </a:solidFill>
+                          <a:latin typeface="Red Hat Mono" pitchFamily="34" charset="0"/>
+                          <a:ea typeface="Red Hat Mono" pitchFamily="34" charset="-122"/>
+                          <a:cs typeface="Red Hat Mono" pitchFamily="34" charset="-120"/>
+                        </a:rPr>
+                        <a:t>-u</a:t>
+                      </a:r>
+                      <a:r>
+                        <a:rPr lang="en-US" sz="1400" dirty="0">
+                          <a:solidFill>
+                            <a:srgbClr val="242424"/>
+                          </a:solidFill>
+                          <a:latin typeface="Red Hat Text" pitchFamily="34" charset="0"/>
+                          <a:ea typeface="Red Hat Text" pitchFamily="34" charset="-122"/>
+                          <a:cs typeface="Red Hat Text" pitchFamily="34" charset="-120"/>
+                        </a:rPr>
+                        <a:t> refreshes snapshots.</a:t>
                       </a:r>
                       <a:endParaRPr lang="en-US" sz="1400" dirty="0">
                         <a:latin typeface="Red Hat Text" charset="0"/>
@@ -22497,7 +21590,39 @@
                           <a:ea typeface="Red Hat Text" pitchFamily="34" charset="-122"/>
                           <a:cs typeface="Red Hat Text" pitchFamily="34" charset="-120"/>
                         </a:rPr>
-                        <a:t>oci:// references; add ‑‑plain‑http for a local HTTP registry.</a:t>
+                        <a:t>oci:// references; add </a:t>
+                      </a:r>
+                      <a:endParaRPr lang="en-US" sz="1400" dirty="0">
+                        <a:latin typeface="Red Hat Text" charset="0"/>
+                        <a:ea typeface="Red Hat Text" charset="0"/>
+                        <a:cs typeface="Red Hat Text" charset="0"/>
+                      </a:endParaRPr>
+                    </a:p>
+                    <a:p>
+                      <a:pPr algn="l" indent="0" marL="0">
+                        <a:buNone/>
+                      </a:pPr>
+                      <a:r>
+                        <a:rPr lang="en-US" sz="1300" dirty="0">
+                          <a:solidFill>
+                            <a:srgbClr val="151515"/>
+                          </a:solidFill>
+                          <a:latin typeface="Red Hat Mono" pitchFamily="34" charset="0"/>
+                          <a:ea typeface="Red Hat Mono" pitchFamily="34" charset="-122"/>
+                          <a:cs typeface="Red Hat Mono" pitchFamily="34" charset="-120"/>
+                        </a:rPr>
+                        <a:t>--plain-http</a:t>
+                      </a:r>
+                      <a:r>
+                        <a:rPr lang="en-US" sz="1400" dirty="0">
+                          <a:solidFill>
+                            <a:srgbClr val="242424"/>
+                          </a:solidFill>
+                          <a:latin typeface="Red Hat Text" pitchFamily="34" charset="0"/>
+                          <a:ea typeface="Red Hat Text" pitchFamily="34" charset="-122"/>
+                          <a:cs typeface="Red Hat Text" pitchFamily="34" charset="-120"/>
+                        </a:rPr>
+                        <a:t> for a local HTTP registry.</a:t>
                       </a:r>
                       <a:endParaRPr lang="en-US" sz="1400" dirty="0">
                         <a:latin typeface="Red Hat Text" charset="0"/>
@@ -22891,7 +22016,39 @@
                           <a:ea typeface="Red Hat Text" pitchFamily="34" charset="-122"/>
                           <a:cs typeface="Red Hat Text" pitchFamily="34" charset="-120"/>
                         </a:rPr>
-                        <a:t>Names a postrenderer/v1 plugin; arguments via ‑‑post‑renderer‑args.</a:t>
+                        <a:t>Names a postrenderer/v1 plugin; arguments via </a:t>
+                      </a:r>
+                      <a:endParaRPr lang="en-US" sz="1400" dirty="0">
+                        <a:latin typeface="Red Hat Text" charset="0"/>
+                        <a:ea typeface="Red Hat Text" charset="0"/>
+                        <a:cs typeface="Red Hat Text" charset="0"/>
+                      </a:endParaRPr>
+                    </a:p>
+                    <a:p>
+                      <a:pPr algn="l" indent="0" marL="0">
+                        <a:buNone/>
+                      </a:pPr>
+                      <a:r>
+                        <a:rPr lang="en-US" sz="1300" dirty="0">
+                          <a:solidFill>
+                            <a:srgbClr val="151515"/>
+                          </a:solidFill>
+                          <a:latin typeface="Red Hat Mono" pitchFamily="34" charset="0"/>
+                          <a:ea typeface="Red Hat Mono" pitchFamily="34" charset="-122"/>
+                          <a:cs typeface="Red Hat Mono" pitchFamily="34" charset="-120"/>
+                        </a:rPr>
+                        <a:t>--post-renderer-args</a:t>
+                      </a:r>
+                      <a:r>
+                        <a:rPr lang="en-US" sz="1400" dirty="0">
+                          <a:solidFill>
+                            <a:srgbClr val="242424"/>
+                          </a:solidFill>
+                          <a:latin typeface="Red Hat Text" pitchFamily="34" charset="0"/>
+                          <a:ea typeface="Red Hat Text" pitchFamily="34" charset="-122"/>
+                          <a:cs typeface="Red Hat Text" pitchFamily="34" charset="-120"/>
+                        </a:rPr>
+                        <a:t>.</a:t>
                       </a:r>
                       <a:endParaRPr lang="en-US" sz="1400" dirty="0">
                         <a:latin typeface="Red Hat Text" charset="0"/>
@@ -23866,8 +23023,8 @@
         </p:blipFill>
         <p:spPr>
           <a:xfrm>
-            <a:off x="886968" y="1645920"/>
-            <a:ext cx="10424160" cy="4251960"/>
+            <a:off x="566928" y="1417320"/>
+            <a:ext cx="11055096" cy="4480560"/>
           </a:xfrm>
           <a:prstGeom prst="rect">
             <a:avLst/>
@@ -24182,12 +23339,6 @@
               <a:t># Rung 4: compare two chart directories locally (helm-diff plugin)
 </a:t>
             </a:r>
-            <a:pPr algn="l" indent="0" marL="0">
-              <a:lnSpc>
-                <a:spcPct val="110000"/>
-              </a:lnSpc>
-              <a:buNone/>
-            </a:pPr>
             <a:r>
               <a:rPr lang="en-US" sz="2000" dirty="0">
                 <a:solidFill>
@@ -24200,12 +23351,6 @@
               <a:t>helm diff local charts/shipping-service /tmp/changed
 </a:t>
             </a:r>
-            <a:pPr algn="l" indent="0" marL="0">
-              <a:lnSpc>
-                <a:spcPct val="110000"/>
-              </a:lnSpc>
-              <a:buNone/>
-            </a:pPr>
             <a:r>
               <a:rPr lang="en-US" sz="2000" dirty="0">
                 <a:solidFill>
@@ -24218,12 +23363,6 @@
               <a:t># Rung 5: resolve kinds and run lookup against the API server
 </a:t>
             </a:r>
-            <a:pPr algn="l" indent="0" marL="0">
-              <a:lnSpc>
-                <a:spcPct val="110000"/>
-              </a:lnSpc>
-              <a:buNone/>
-            </a:pPr>
             <a:r>
               <a:rPr lang="en-US" sz="2000" dirty="0">
                 <a:solidFill>
@@ -24236,12 +23375,6 @@
               <a:t>helm upgrade shipping charts/shipping-service -n hfd-13 \
 </a:t>
             </a:r>
-            <a:pPr algn="l" indent="0" marL="0">
-              <a:lnSpc>
-                <a:spcPct val="110000"/>
-              </a:lnSpc>
-              <a:buNone/>
-            </a:pPr>
             <a:r>
               <a:rPr lang="en-US" sz="2000" dirty="0">
                 <a:solidFill>
@@ -24254,12 +23387,6 @@
               <a:t>  --dry-run=server
 </a:t>
             </a:r>
-            <a:pPr algn="l" indent="0" marL="0">
-              <a:lnSpc>
-                <a:spcPct val="110000"/>
-              </a:lnSpc>
-              <a:buNone/>
-            </a:pPr>
             <a:r>
               <a:rPr lang="en-US" sz="2000" dirty="0">
                 <a:solidFill>
@@ -24272,12 +23399,6 @@
               <a:t># Rung 6: what an upgrade would change in the live release
 </a:t>
             </a:r>
-            <a:pPr algn="l" indent="0" marL="0">
-              <a:lnSpc>
-                <a:spcPct val="110000"/>
-              </a:lnSpc>
-              <a:buNone/>
-            </a:pPr>
             <a:r>
               <a:rPr lang="en-US" sz="2000" dirty="0">
                 <a:solidFill>
@@ -24290,12 +23411,6 @@
               <a:t>helm diff upgrade shipping charts/shipping-service -n hfd-13 \
 </a:t>
             </a:r>
-            <a:pPr algn="l" indent="0" marL="0">
-              <a:lnSpc>
-                <a:spcPct val="110000"/>
-              </a:lnSpc>
-              <a:buNone/>
-            </a:pPr>
             <a:r>
               <a:rPr lang="en-US" sz="2000" dirty="0">
                 <a:solidFill>
@@ -24308,12 +23423,6 @@
               <a:t>  --set replicaCount=2
 </a:t>
             </a:r>
-            <a:pPr algn="l" indent="0" marL="0">
-              <a:lnSpc>
-                <a:spcPct val="110000"/>
-              </a:lnSpc>
-              <a:buNone/>
-            </a:pPr>
             <a:r>
               <a:rPr lang="en-US" sz="2000" dirty="0">
                 <a:solidFill>
@@ -24326,12 +23435,6 @@
               <a:t># Rung 7: the stored manifest, fed back to the schema check
 </a:t>
             </a:r>
-            <a:pPr algn="l" indent="0" marL="0">
-              <a:lnSpc>
-                <a:spcPct val="110000"/>
-              </a:lnSpc>
-              <a:buNone/>
-            </a:pPr>
             <a:r>
               <a:rPr lang="en-US" sz="2000" dirty="0">
                 <a:solidFill>
@@ -24381,7 +23484,29 @@
                 <a:ea typeface="Red Hat Text" pitchFamily="34" charset="-122"/>
                 <a:cs typeface="Red Hat Text" pitchFamily="34" charset="-120"/>
               </a:rPr>
-              <a:t>From examples/13-debugging. ‑‑dry‑run=server resolves kinds and runs lookup; it does not schema-validate fields on 4.3.0.</a:t>
+              <a:t>From examples/13-debugging. </a:t>
+            </a:r>
+            <a:r>
+              <a:rPr lang="en-US" sz="1200" i="1" dirty="0">
+                <a:solidFill>
+                  <a:srgbClr val="151515"/>
+                </a:solidFill>
+                <a:latin typeface="Red Hat Mono" pitchFamily="34" charset="0"/>
+                <a:ea typeface="Red Hat Mono" pitchFamily="34" charset="-122"/>
+                <a:cs typeface="Red Hat Mono" pitchFamily="34" charset="-120"/>
+              </a:rPr>
+              <a:t>--dry-run=server</a:t>
+            </a:r>
+            <a:r>
+              <a:rPr lang="en-US" sz="1300" i="1" dirty="0">
+                <a:solidFill>
+                  <a:srgbClr val="5A5A5A"/>
+                </a:solidFill>
+                <a:latin typeface="Red Hat Text" pitchFamily="34" charset="0"/>
+                <a:ea typeface="Red Hat Text" pitchFamily="34" charset="-122"/>
+                <a:cs typeface="Red Hat Text" pitchFamily="34" charset="-120"/>
+              </a:rPr>
+              <a:t> resolves kinds and runs lookup; it does not schema-validate fields on 4.3.0.</a:t>
             </a:r>
             <a:endParaRPr lang="en-US" sz="1300" dirty="0"/>
           </a:p>
@@ -24568,8 +23693,8 @@
         </p:blipFill>
         <p:spPr>
           <a:xfrm>
-            <a:off x="886968" y="1645920"/>
-            <a:ext cx="10424160" cy="4251960"/>
+            <a:off x="566928" y="1417320"/>
+            <a:ext cx="11055096" cy="4480560"/>
           </a:xfrm>
           <a:prstGeom prst="rect">
             <a:avLst/>
@@ -24767,6 +23892,17 @@
               <a:buNone/>
             </a:pPr>
             <a:r>
+              <a:rPr lang="en-US" sz="2900" b="1" dirty="0">
+                <a:solidFill>
+                  <a:srgbClr val="151515"/>
+                </a:solidFill>
+                <a:latin typeface="Red Hat Mono" pitchFamily="34" charset="0"/>
+                <a:ea typeface="Red Hat Mono" pitchFamily="34" charset="-122"/>
+                <a:cs typeface="Red Hat Mono" pitchFamily="34" charset="-120"/>
+              </a:rPr>
+              <a:t>helm-unittest</a:t>
+            </a:r>
+            <a:r>
               <a:rPr lang="en-US" sz="3000" b="1" dirty="0">
                 <a:solidFill>
                   <a:srgbClr val="151515"/>
@@ -24775,7 +23911,7 @@
                 <a:ea typeface="Red Hat Display" pitchFamily="34" charset="-122"/>
                 <a:cs typeface="Red Hat Display" pitchFamily="34" charset="-120"/>
               </a:rPr>
-              <a:t>helm‑unittest suites</a:t>
+              <a:t> suites</a:t>
             </a:r>
             <a:endParaRPr lang="en-US" sz="3000" dirty="0"/>
           </a:p>
@@ -24873,7 +24009,7 @@
               <a:buNone/>
             </a:pPr>
             <a:r>
-              <a:rPr lang="en-US" sz="1500" dirty="0">
+              <a:rPr lang="en-US" sz="1700" dirty="0">
                 <a:solidFill>
                   <a:srgbClr val="E6E6E6"/>
                 </a:solidFill>
@@ -24884,14 +24020,8 @@
               <a:t>suite: shipping-service deployment
 </a:t>
             </a:r>
-            <a:pPr algn="l" indent="0" marL="0">
-              <a:lnSpc>
-                <a:spcPct val="110000"/>
-              </a:lnSpc>
-              <a:buNone/>
-            </a:pPr>
-            <a:r>
-              <a:rPr lang="en-US" sz="1500" dirty="0">
+            <a:r>
+              <a:rPr lang="en-US" sz="1700" dirty="0">
                 <a:solidFill>
                   <a:srgbClr val="E6E6E6"/>
                 </a:solidFill>
@@ -24902,14 +24032,8 @@
               <a:t>templates:
 </a:t>
             </a:r>
-            <a:pPr algn="l" indent="0" marL="0">
-              <a:lnSpc>
-                <a:spcPct val="110000"/>
-              </a:lnSpc>
-              <a:buNone/>
-            </a:pPr>
-            <a:r>
-              <a:rPr lang="en-US" sz="1500" dirty="0">
+            <a:r>
+              <a:rPr lang="en-US" sz="1700" dirty="0">
                 <a:solidFill>
                   <a:srgbClr val="E6E6E6"/>
                 </a:solidFill>
@@ -24920,14 +24044,8 @@
               <a:t>  - templates/deployment.yaml
 </a:t>
             </a:r>
-            <a:pPr algn="l" indent="0" marL="0">
-              <a:lnSpc>
-                <a:spcPct val="110000"/>
-              </a:lnSpc>
-              <a:buNone/>
-            </a:pPr>
-            <a:r>
-              <a:rPr lang="en-US" sz="1500" dirty="0">
+            <a:r>
+              <a:rPr lang="en-US" sz="1700" dirty="0">
                 <a:solidFill>
                   <a:srgbClr val="E6E6E6"/>
                 </a:solidFill>
@@ -24938,14 +24056,8 @@
               <a:t>tests:
 </a:t>
             </a:r>
-            <a:pPr algn="l" indent="0" marL="0">
-              <a:lnSpc>
-                <a:spcPct val="110000"/>
-              </a:lnSpc>
-              <a:buNone/>
-            </a:pPr>
-            <a:r>
-              <a:rPr lang="en-US" sz="1500" dirty="0">
+            <a:r>
+              <a:rPr lang="en-US" sz="1700" dirty="0">
                 <a:solidFill>
                   <a:srgbClr val="E6E6E6"/>
                 </a:solidFill>
@@ -24956,14 +24068,8 @@
               <a:t>  - it: renders a Deployment with the default image tag from appVersion
 </a:t>
             </a:r>
-            <a:pPr algn="l" indent="0" marL="0">
-              <a:lnSpc>
-                <a:spcPct val="110000"/>
-              </a:lnSpc>
-              <a:buNone/>
-            </a:pPr>
-            <a:r>
-              <a:rPr lang="en-US" sz="1500" dirty="0">
+            <a:r>
+              <a:rPr lang="en-US" sz="1700" dirty="0">
                 <a:solidFill>
                   <a:srgbClr val="E6E6E6"/>
                 </a:solidFill>
@@ -24974,14 +24080,8 @@
               <a:t>    asserts:
 </a:t>
             </a:r>
-            <a:pPr algn="l" indent="0" marL="0">
-              <a:lnSpc>
-                <a:spcPct val="110000"/>
-              </a:lnSpc>
-              <a:buNone/>
-            </a:pPr>
-            <a:r>
-              <a:rPr lang="en-US" sz="1500" dirty="0">
+            <a:r>
+              <a:rPr lang="en-US" sz="1700" dirty="0">
                 <a:solidFill>
                   <a:srgbClr val="E6E6E6"/>
                 </a:solidFill>
@@ -24989,17 +24089,11 @@
                 <a:ea typeface="Red Hat Mono" pitchFamily="34" charset="-122"/>
                 <a:cs typeface="Red Hat Mono" pitchFamily="34" charset="-120"/>
               </a:rPr>
-              <a:t>      - isKind:
+              <a:t>      - equal:
 </a:t>
             </a:r>
-            <a:pPr algn="l" indent="0" marL="0">
-              <a:lnSpc>
-                <a:spcPct val="110000"/>
-              </a:lnSpc>
-              <a:buNone/>
-            </a:pPr>
-            <a:r>
-              <a:rPr lang="en-US" sz="1500" dirty="0">
+            <a:r>
+              <a:rPr lang="en-US" sz="1700" dirty="0">
                 <a:solidFill>
                   <a:srgbClr val="E6E6E6"/>
                 </a:solidFill>
@@ -25007,17 +24101,11 @@
                 <a:ea typeface="Red Hat Mono" pitchFamily="34" charset="-122"/>
                 <a:cs typeface="Red Hat Mono" pitchFamily="34" charset="-120"/>
               </a:rPr>
-              <a:t>          of: Deployment
+              <a:t>          path: spec.template.spec.containers[0].image
 </a:t>
             </a:r>
-            <a:pPr algn="l" indent="0" marL="0">
-              <a:lnSpc>
-                <a:spcPct val="110000"/>
-              </a:lnSpc>
-              <a:buNone/>
-            </a:pPr>
-            <a:r>
-              <a:rPr lang="en-US" sz="1500" dirty="0">
+            <a:r>
+              <a:rPr lang="en-US" sz="1700" dirty="0">
                 <a:solidFill>
                   <a:srgbClr val="E6E6E6"/>
                 </a:solidFill>
@@ -25025,17 +24113,11 @@
                 <a:ea typeface="Red Hat Mono" pitchFamily="34" charset="-122"/>
                 <a:cs typeface="Red Hat Mono" pitchFamily="34" charset="-120"/>
               </a:rPr>
-              <a:t>      - equal:
+              <a:t>          value: shipping-service:0.1.0
 </a:t>
             </a:r>
-            <a:pPr algn="l" indent="0" marL="0">
-              <a:lnSpc>
-                <a:spcPct val="110000"/>
-              </a:lnSpc>
-              <a:buNone/>
-            </a:pPr>
-            <a:r>
-              <a:rPr lang="en-US" sz="1500" dirty="0">
+            <a:r>
+              <a:rPr lang="en-US" sz="1700" dirty="0">
                 <a:solidFill>
                   <a:srgbClr val="E6E6E6"/>
                 </a:solidFill>
@@ -25043,17 +24125,11 @@
                 <a:ea typeface="Red Hat Mono" pitchFamily="34" charset="-122"/>
                 <a:cs typeface="Red Hat Mono" pitchFamily="34" charset="-120"/>
               </a:rPr>
-              <a:t>          path: spec.template.spec.containers[0].image
+              <a:t>  - it: fails when kafka is enabled without a bootstrap address
 </a:t>
             </a:r>
-            <a:pPr algn="l" indent="0" marL="0">
-              <a:lnSpc>
-                <a:spcPct val="110000"/>
-              </a:lnSpc>
-              <a:buNone/>
-            </a:pPr>
-            <a:r>
-              <a:rPr lang="en-US" sz="1500" dirty="0">
+            <a:r>
+              <a:rPr lang="en-US" sz="1700" dirty="0">
                 <a:solidFill>
                   <a:srgbClr val="E6E6E6"/>
                 </a:solidFill>
@@ -25061,17 +24137,11 @@
                 <a:ea typeface="Red Hat Mono" pitchFamily="34" charset="-122"/>
                 <a:cs typeface="Red Hat Mono" pitchFamily="34" charset="-120"/>
               </a:rPr>
-              <a:t>          value: shipping-service:0.1.0
+              <a:t>    set:
 </a:t>
             </a:r>
-            <a:pPr algn="l" indent="0" marL="0">
-              <a:lnSpc>
-                <a:spcPct val="110000"/>
-              </a:lnSpc>
-              <a:buNone/>
-            </a:pPr>
-            <a:r>
-              <a:rPr lang="en-US" sz="1500" dirty="0">
+            <a:r>
+              <a:rPr lang="en-US" sz="1700" dirty="0">
                 <a:solidFill>
                   <a:srgbClr val="E6E6E6"/>
                 </a:solidFill>
@@ -25079,17 +24149,11 @@
                 <a:ea typeface="Red Hat Mono" pitchFamily="34" charset="-122"/>
                 <a:cs typeface="Red Hat Mono" pitchFamily="34" charset="-120"/>
               </a:rPr>
-              <a:t>  - it: fails when kafka is enabled without a bootstrap address
+              <a:t>      kafka.enabled: true
 </a:t>
             </a:r>
-            <a:pPr algn="l" indent="0" marL="0">
-              <a:lnSpc>
-                <a:spcPct val="110000"/>
-              </a:lnSpc>
-              <a:buNone/>
-            </a:pPr>
-            <a:r>
-              <a:rPr lang="en-US" sz="1500" dirty="0">
+            <a:r>
+              <a:rPr lang="en-US" sz="1700" dirty="0">
                 <a:solidFill>
                   <a:srgbClr val="E6E6E6"/>
                 </a:solidFill>
@@ -25097,17 +24161,11 @@
                 <a:ea typeface="Red Hat Mono" pitchFamily="34" charset="-122"/>
                 <a:cs typeface="Red Hat Mono" pitchFamily="34" charset="-120"/>
               </a:rPr>
-              <a:t>    set:
+              <a:t>    asserts:
 </a:t>
             </a:r>
-            <a:pPr algn="l" indent="0" marL="0">
-              <a:lnSpc>
-                <a:spcPct val="110000"/>
-              </a:lnSpc>
-              <a:buNone/>
-            </a:pPr>
-            <a:r>
-              <a:rPr lang="en-US" sz="1500" dirty="0">
+            <a:r>
+              <a:rPr lang="en-US" sz="1700" dirty="0">
                 <a:solidFill>
                   <a:srgbClr val="E6E6E6"/>
                 </a:solidFill>
@@ -25115,17 +24173,11 @@
                 <a:ea typeface="Red Hat Mono" pitchFamily="34" charset="-122"/>
                 <a:cs typeface="Red Hat Mono" pitchFamily="34" charset="-120"/>
               </a:rPr>
-              <a:t>      kafka.enabled: true
+              <a:t>      - failedTemplate:
 </a:t>
             </a:r>
-            <a:pPr algn="l" indent="0" marL="0">
-              <a:lnSpc>
-                <a:spcPct val="110000"/>
-              </a:lnSpc>
-              <a:buNone/>
-            </a:pPr>
-            <a:r>
-              <a:rPr lang="en-US" sz="1500" dirty="0">
+            <a:r>
+              <a:rPr lang="en-US" sz="1700" dirty="0">
                 <a:solidFill>
                   <a:srgbClr val="E6E6E6"/>
                 </a:solidFill>
@@ -25133,73 +24185,59 @@
                 <a:ea typeface="Red Hat Mono" pitchFamily="34" charset="-122"/>
                 <a:cs typeface="Red Hat Mono" pitchFamily="34" charset="-120"/>
               </a:rPr>
-              <a:t>    asserts:
+              <a:t>          errorPattern: kafka.bootstrap is required
 </a:t>
             </a:r>
-            <a:pPr algn="l" indent="0" marL="0">
-              <a:lnSpc>
-                <a:spcPct val="110000"/>
-              </a:lnSpc>
+            <a:endParaRPr lang="en-US" sz="1700" dirty="0"/>
+          </a:p>
+        </p:txBody>
+      </p:sp>
+      <p:sp>
+        <p:nvSpPr>
+          <p:cNvPr id="9" name="Text 6"/>
+          <p:cNvSpPr/>
+          <p:nvPr/>
+        </p:nvSpPr>
+        <p:spPr>
+          <a:xfrm>
+            <a:off x="566928" y="5943600"/>
+            <a:ext cx="11055096" cy="310896"/>
+          </a:xfrm>
+          <a:prstGeom prst="rect">
+            <a:avLst/>
+          </a:prstGeom>
+          <a:noFill/>
+          <a:ln/>
+        </p:spPr>
+        <p:txBody>
+          <a:bodyPr wrap="square" rtlCol="0" anchor="ctr"/>
+          <a:lstStyle/>
+          <a:p>
+            <a:pPr algn="ctr" indent="0" marL="0">
               <a:buNone/>
             </a:pPr>
             <a:r>
-              <a:rPr lang="en-US" sz="1500" dirty="0">
-                <a:solidFill>
-                  <a:srgbClr val="E6E6E6"/>
+              <a:rPr lang="en-US" sz="1300" i="1" dirty="0">
+                <a:solidFill>
+                  <a:srgbClr val="5A5A5A"/>
+                </a:solidFill>
+                <a:latin typeface="Red Hat Text" pitchFamily="34" charset="0"/>
+                <a:ea typeface="Red Hat Text" pitchFamily="34" charset="-122"/>
+                <a:cs typeface="Red Hat Text" pitchFamily="34" charset="-120"/>
+              </a:rPr>
+              <a:t>Run helm unittest charts/shipping-service; helm unittest </a:t>
+            </a:r>
+            <a:r>
+              <a:rPr lang="en-US" sz="1200" i="1" dirty="0">
+                <a:solidFill>
+                  <a:srgbClr val="151515"/>
                 </a:solidFill>
                 <a:latin typeface="Red Hat Mono" pitchFamily="34" charset="0"/>
                 <a:ea typeface="Red Hat Mono" pitchFamily="34" charset="-122"/>
                 <a:cs typeface="Red Hat Mono" pitchFamily="34" charset="-120"/>
               </a:rPr>
-              <a:t>      - failedTemplate:
-</a:t>
-            </a:r>
-            <a:pPr algn="l" indent="0" marL="0">
-              <a:lnSpc>
-                <a:spcPct val="110000"/>
-              </a:lnSpc>
-              <a:buNone/>
-            </a:pPr>
-            <a:r>
-              <a:rPr lang="en-US" sz="1500" dirty="0">
-                <a:solidFill>
-                  <a:srgbClr val="E6E6E6"/>
-                </a:solidFill>
-                <a:latin typeface="Red Hat Mono" pitchFamily="34" charset="0"/>
-                <a:ea typeface="Red Hat Mono" pitchFamily="34" charset="-122"/>
-                <a:cs typeface="Red Hat Mono" pitchFamily="34" charset="-120"/>
-              </a:rPr>
-              <a:t>          errorPattern: kafka.bootstrap is required
-</a:t>
-            </a:r>
-            <a:endParaRPr lang="en-US" sz="1500" dirty="0"/>
-          </a:p>
-        </p:txBody>
-      </p:sp>
-      <p:sp>
-        <p:nvSpPr>
-          <p:cNvPr id="9" name="Text 6"/>
-          <p:cNvSpPr/>
-          <p:nvPr/>
-        </p:nvSpPr>
-        <p:spPr>
-          <a:xfrm>
-            <a:off x="566928" y="5943600"/>
-            <a:ext cx="11055096" cy="310896"/>
-          </a:xfrm>
-          <a:prstGeom prst="rect">
-            <a:avLst/>
-          </a:prstGeom>
-          <a:noFill/>
-          <a:ln/>
-        </p:spPr>
-        <p:txBody>
-          <a:bodyPr wrap="square" rtlCol="0" anchor="ctr"/>
-          <a:lstStyle/>
-          <a:p>
-            <a:pPr algn="ctr" indent="0" marL="0">
-              <a:buNone/>
-            </a:pPr>
+              <a:t>-u</a:t>
+            </a:r>
             <a:r>
               <a:rPr lang="en-US" sz="1300" i="1" dirty="0">
                 <a:solidFill>
@@ -25209,7 +24247,7 @@
                 <a:ea typeface="Red Hat Text" pitchFamily="34" charset="-122"/>
                 <a:cs typeface="Red Hat Text" pitchFamily="34" charset="-120"/>
               </a:rPr>
-              <a:t>Run helm unittest charts/shipping-service; helm unittest ‑u refreshes snapshot files.</a:t>
+              <a:t> refreshes snapshot files.</a:t>
             </a:r>
             <a:endParaRPr lang="en-US" sz="1300" dirty="0"/>
           </a:p>
@@ -25367,6 +24405,17 @@
               <a:buNone/>
             </a:pPr>
             <a:r>
+              <a:rPr lang="en-US" sz="2900" b="1" dirty="0">
+                <a:solidFill>
+                  <a:srgbClr val="151515"/>
+                </a:solidFill>
+                <a:latin typeface="Red Hat Mono" pitchFamily="34" charset="0"/>
+                <a:ea typeface="Red Hat Mono" pitchFamily="34" charset="-122"/>
+                <a:cs typeface="Red Hat Mono" pitchFamily="34" charset="-120"/>
+              </a:rPr>
+              <a:t>chart-testing</a:t>
+            </a:r>
+            <a:r>
               <a:rPr lang="en-US" sz="3000" b="1" dirty="0">
                 <a:solidFill>
                   <a:srgbClr val="151515"/>
@@ -25375,7 +24424,7 @@
                 <a:ea typeface="Red Hat Display" pitchFamily="34" charset="-122"/>
                 <a:cs typeface="Red Hat Display" pitchFamily="34" charset="-120"/>
               </a:rPr>
-              <a:t>chart‑testing and kubeconform</a:t>
+              <a:t> and kubeconform</a:t>
             </a:r>
             <a:endParaRPr lang="en-US" sz="3000" dirty="0"/>
           </a:p>
@@ -25556,7 +24605,39 @@
                           <a:ea typeface="Red Hat Text" pitchFamily="34" charset="-122"/>
                           <a:cs typeface="Red Hat Text" pitchFamily="34" charset="-120"/>
                         </a:rPr>
-                        <a:t>Chart.yaml schema, yamllint, and helm lint for every ci/*-values.yaml.</a:t>
+                        <a:t>Chart.yaml schema, yamllint, and helm lint for every ci/*</a:t>
+                      </a:r>
+                      <a:endParaRPr lang="en-US" sz="1500" dirty="0">
+                        <a:latin typeface="Red Hat Text" charset="0"/>
+                        <a:ea typeface="Red Hat Text" charset="0"/>
+                        <a:cs typeface="Red Hat Text" charset="0"/>
+                      </a:endParaRPr>
+                    </a:p>
+                    <a:p>
+                      <a:pPr algn="l" indent="0" marL="0">
+                        <a:buNone/>
+                      </a:pPr>
+                      <a:r>
+                        <a:rPr lang="en-US" sz="1400" dirty="0">
+                          <a:solidFill>
+                            <a:srgbClr val="151515"/>
+                          </a:solidFill>
+                          <a:latin typeface="Red Hat Mono" pitchFamily="34" charset="0"/>
+                          <a:ea typeface="Red Hat Mono" pitchFamily="34" charset="-122"/>
+                          <a:cs typeface="Red Hat Mono" pitchFamily="34" charset="-120"/>
+                        </a:rPr>
+                        <a:t>-values.yaml</a:t>
+                      </a:r>
+                      <a:r>
+                        <a:rPr lang="en-US" sz="1500" dirty="0">
+                          <a:solidFill>
+                            <a:srgbClr val="242424"/>
+                          </a:solidFill>
+                          <a:latin typeface="Red Hat Text" pitchFamily="34" charset="0"/>
+                          <a:ea typeface="Red Hat Text" pitchFamily="34" charset="-122"/>
+                          <a:cs typeface="Red Hat Text" pitchFamily="34" charset="-120"/>
+                        </a:rPr>
+                        <a:t>.</a:t>
                       </a:r>
                       <a:endParaRPr lang="en-US" sz="1500" dirty="0">
                         <a:latin typeface="Red Hat Text" charset="0"/>

</xml_diff>

<commit_message>
fix(r1.0): validation repair round: upgrade values semantics, Python 3.14 labeling, evidence alignment, diagrams, deck fixes, source credits
</commit_message>
<xml_diff>
--- a/presentation/helm-201/Helm-201-r1.0.pptx
+++ b/presentation/helm-201/Helm-201-r1.0.pptx
@@ -3695,7 +3695,7 @@
           <a:p>
             <a:r>
               <a:rPr lang="en-US" dirty="0"/>
-              <a:t>What it shows: A `ProjectHelmChartRepository` makes a chart repository visible in the Developer console's Helm catalog for one project. On OpenShift Local 2.64.0 the resource was accepted and listed by `oc get`. The console view was not opened, and the index URL returned 404 at verification time because the repository index is not published yet, so the listing could not populate.
+              <a:t>What it shows: A `ProjectHelmChartRepository` makes a chart repository visible in the Developer console's Helm catalog for one project. On OpenShift Local 2.64.0 the resource was accepted and listed by `oc get`. The console view was not opened, and the URL tried returned 404 because no index was published there, so the listing could not populate. The URL on the slide is a placeholder for your own repository.
 What to show: `oc get projecthelmchartrepository -n hfd-ocp` on a CRC host; the console view needs a published index.
 Fallback: the YAML on this slide and the chapter 27 section on the Developer console.</a:t>
             </a:r>
@@ -5289,7 +5289,7 @@
                 <a:ea typeface="Red Hat Mono" pitchFamily="34" charset="-122"/>
                 <a:cs typeface="Red Hat Mono" pitchFamily="34" charset="-120"/>
               </a:rPr>
-              <a:t>helm lint --strict charts/shipping-service
+              <a:t>[host]$ helm lint --strict charts/shipping-service
 </a:t>
             </a:r>
             <a:r>
@@ -5301,7 +5301,7 @@
                 <a:ea typeface="Red Hat Mono" pitchFamily="34" charset="-122"/>
                 <a:cs typeface="Red Hat Mono" pitchFamily="34" charset="-120"/>
               </a:rPr>
-              <a:t>helm unittest charts/shipping-service
+              <a:t>[host]$ helm unittest charts/shipping-service
 </a:t>
             </a:r>
             <a:r>
@@ -5313,7 +5313,7 @@
                 <a:ea typeface="Red Hat Mono" pitchFamily="34" charset="-122"/>
                 <a:cs typeface="Red Hat Mono" pitchFamily="34" charset="-120"/>
               </a:rPr>
-              <a:t>helm template shipping charts/shipping-service \
+              <a:t>[host]$ helm template shipping charts/shipping-service \
 </a:t>
             </a:r>
             <a:r>
@@ -5325,7 +5325,7 @@
                 <a:ea typeface="Red Hat Mono" pitchFamily="34" charset="-122"/>
                 <a:cs typeface="Red Hat Mono" pitchFamily="34" charset="-120"/>
               </a:rPr>
-              <a:t>  -f charts/shipping-service/ci/ci-values.yaml \
+              <a:t>          -f charts/shipping-service/ci/ci-values.yaml \
 </a:t>
             </a:r>
             <a:r>
@@ -5337,7 +5337,7 @@
                 <a:ea typeface="Red Hat Mono" pitchFamily="34" charset="-122"/>
                 <a:cs typeface="Red Hat Mono" pitchFamily="34" charset="-120"/>
               </a:rPr>
-              <a:t>  | kubeconform -strict -summary
+              <a:t>          | kubeconform -strict -summary
 </a:t>
             </a:r>
             <a:r>
@@ -5349,7 +5349,7 @@
                 <a:ea typeface="Red Hat Mono" pitchFamily="34" charset="-122"/>
                 <a:cs typeface="Red Hat Mono" pitchFamily="34" charset="-120"/>
               </a:rPr>
-              <a:t>ct lint --config ct.yaml --all
+              <a:t>[host]$ ct lint --config ct.yaml --all
 </a:t>
             </a:r>
             <a:r>
@@ -5373,7 +5373,7 @@
                 <a:ea typeface="Red Hat Mono" pitchFamily="34" charset="-122"/>
                 <a:cs typeface="Red Hat Mono" pitchFamily="34" charset="-120"/>
               </a:rPr>
-              <a:t>ct install --charts charts/shipping-service \
+              <a:t>[host]$ ct install --charts charts/shipping-service \
 </a:t>
             </a:r>
             <a:r>
@@ -5385,7 +5385,7 @@
                 <a:ea typeface="Red Hat Mono" pitchFamily="34" charset="-122"/>
                 <a:cs typeface="Red Hat Mono" pitchFamily="34" charset="-120"/>
               </a:rPr>
-              <a:t>  --helm-extra-args '--timeout 3m'
+              <a:t>          --helm-extra-args '--timeout 3m'
 </a:t>
             </a:r>
             <a:r>
@@ -5409,7 +5409,7 @@
                 <a:ea typeface="Red Hat Mono" pitchFamily="34" charset="-122"/>
                 <a:cs typeface="Red Hat Mono" pitchFamily="34" charset="-120"/>
               </a:rPr>
-              <a:t>helm package charts/shipping-service --dependency-update -d dist
+              <a:t>[host]$ helm package charts/shipping-service --dependency-update -d dist
 </a:t>
             </a:r>
             <a:r>
@@ -5421,7 +5421,7 @@
                 <a:ea typeface="Red Hat Mono" pitchFamily="34" charset="-122"/>
                 <a:cs typeface="Red Hat Mono" pitchFamily="34" charset="-120"/>
               </a:rPr>
-              <a:t>helm push dist/shipping-service-1.0.0.tgz \
+              <a:t>[host]$ helm push dist/shipping-service-1.0.0.tgz \
 </a:t>
             </a:r>
             <a:r>
@@ -5433,7 +5433,7 @@
                 <a:ea typeface="Red Hat Mono" pitchFamily="34" charset="-122"/>
                 <a:cs typeface="Red Hat Mono" pitchFamily="34" charset="-120"/>
               </a:rPr>
-              <a:t>  oci://registry.example.com/charts
+              <a:t>          oci://registry.example.com/charts
 </a:t>
             </a:r>
             <a:endParaRPr lang="en-US" sz="1800" dirty="0"/>
@@ -8561,7 +8561,7 @@
                 <a:ea typeface="Red Hat Mono" pitchFamily="34" charset="-122"/>
                 <a:cs typeface="Red Hat Mono" pitchFamily="34" charset="-120"/>
               </a:rPr>
-              <a:t>helm template platform charts/shipping-platform -n hfd-ocp \
+              <a:t>[host]$ helm template platform charts/shipping-platform -n hfd-ocp \
 </a:t>
             </a:r>
             <a:r>
@@ -8573,7 +8573,7 @@
                 <a:ea typeface="Red Hat Mono" pitchFamily="34" charset="-122"/>
                 <a:cs typeface="Red Hat Mono" pitchFamily="34" charset="-120"/>
               </a:rPr>
-              <a:t>  --api-versions route.openshift.io/v1
+              <a:t>          --api-versions route.openshift.io/v1
 </a:t>
             </a:r>
             <a:r>
@@ -8585,7 +8585,7 @@
                 <a:ea typeface="Red Hat Mono" pitchFamily="34" charset="-122"/>
                 <a:cs typeface="Red Hat Mono" pitchFamily="34" charset="-120"/>
               </a:rPr>
-              <a:t>helm template platform charts/shipping-platform -n hfd-ocp
+              <a:t>[host]$ helm template platform charts/shipping-platform -n hfd-ocp
 </a:t>
             </a:r>
             <a:endParaRPr lang="en-US" sz="1700" dirty="0"/>
@@ -9159,7 +9159,7 @@
                 <a:ea typeface="Red Hat Mono" pitchFamily="34" charset="-122"/>
                 <a:cs typeface="Red Hat Mono" pitchFamily="34" charset="-120"/>
               </a:rPr>
-              <a:t>helm create --starter pc-fastapi charts/inventory-service
+              <a:t>[host]$ helm create --starter pc-fastapi charts/inventory-service
 </a:t>
             </a:r>
             <a:r>
@@ -9171,7 +9171,7 @@
                 <a:ea typeface="Red Hat Mono" pitchFamily="34" charset="-122"/>
                 <a:cs typeface="Red Hat Mono" pitchFamily="34" charset="-120"/>
               </a:rPr>
-              <a:t>helm dependency build charts/inventory-service
+              <a:t>[host]$ helm dependency build charts/inventory-service
 </a:t>
             </a:r>
             <a:r>
@@ -9183,7 +9183,7 @@
                 <a:ea typeface="Red Hat Mono" pitchFamily="34" charset="-122"/>
                 <a:cs typeface="Red Hat Mono" pitchFamily="34" charset="-120"/>
               </a:rPr>
-              <a:t>helm lint --strict charts/inventory-service
+              <a:t>[host]$ helm lint --strict charts/inventory-service
 </a:t>
             </a:r>
             <a:r>
@@ -9195,7 +9195,7 @@
                 <a:ea typeface="Red Hat Mono" pitchFamily="34" charset="-122"/>
                 <a:cs typeface="Red Hat Mono" pitchFamily="34" charset="-120"/>
               </a:rPr>
-              <a:t>helm template inventory charts/inventory-service \
+              <a:t>[host]$ helm template inventory charts/inventory-service \
 </a:t>
             </a:r>
             <a:r>
@@ -9207,7 +9207,7 @@
                 <a:ea typeface="Red Hat Mono" pitchFamily="34" charset="-122"/>
                 <a:cs typeface="Red Hat Mono" pitchFamily="34" charset="-120"/>
               </a:rPr>
-              <a:t>  | kubeconform -strict -summary
+              <a:t>          | kubeconform -strict -summary
 </a:t>
             </a:r>
             <a:r>
@@ -9219,7 +9219,7 @@
                 <a:ea typeface="Red Hat Mono" pitchFamily="34" charset="-122"/>
                 <a:cs typeface="Red Hat Mono" pitchFamily="34" charset="-120"/>
               </a:rPr>
-              <a:t>helm upgrade --install inventory charts/inventory-service \
+              <a:t>[host]$ helm upgrade --install inventory charts/inventory-service \
 </a:t>
             </a:r>
             <a:r>
@@ -9231,7 +9231,7 @@
                 <a:ea typeface="Red Hat Mono" pitchFamily="34" charset="-122"/>
                 <a:cs typeface="Red Hat Mono" pitchFamily="34" charset="-120"/>
               </a:rPr>
-              <a:t>  -n hfd-18 --create-namespace
+              <a:t>          -n hfd-18 --create-namespace
 </a:t>
             </a:r>
             <a:r>
@@ -9243,7 +9243,7 @@
                 <a:ea typeface="Red Hat Mono" pitchFamily="34" charset="-122"/>
                 <a:cs typeface="Red Hat Mono" pitchFamily="34" charset="-120"/>
               </a:rPr>
-              <a:t>helm test inventory -n hfd-18
+              <a:t>[host]$ helm test inventory -n hfd-18
 </a:t>
             </a:r>
             <a:r>
@@ -10099,7 +10099,7 @@
         <p:spPr>
           <a:xfrm>
             <a:off x="566928" y="1417320"/>
-            <a:ext cx="11055096" cy="3029807"/>
+            <a:ext cx="11055096" cy="2954998"/>
           </a:xfrm>
           <a:prstGeom prst="rect">
             <a:avLst/>
@@ -10124,7 +10124,7 @@
         <p:spPr>
           <a:xfrm>
             <a:off x="749808" y="1508760"/>
-            <a:ext cx="10689336" cy="2846927"/>
+            <a:ext cx="10689336" cy="2772118"/>
           </a:xfrm>
           <a:prstGeom prst="rect">
             <a:avLst/>
@@ -10143,7 +10143,7 @@
               <a:buNone/>
             </a:pPr>
             <a:r>
-              <a:rPr lang="en-US" sz="1750" dirty="0">
+              <a:rPr lang="en-US" sz="1700" dirty="0">
                 <a:solidFill>
                   <a:srgbClr val="E6E6E6"/>
                 </a:solidFill>
@@ -10155,7 +10155,7 @@
 </a:t>
             </a:r>
             <a:r>
-              <a:rPr lang="en-US" sz="1750" dirty="0">
+              <a:rPr lang="en-US" sz="1700" dirty="0">
                 <a:solidFill>
                   <a:srgbClr val="E6E6E6"/>
                 </a:solidFill>
@@ -10167,7 +10167,7 @@
 </a:t>
             </a:r>
             <a:r>
-              <a:rPr lang="en-US" sz="1750" dirty="0">
+              <a:rPr lang="en-US" sz="1700" dirty="0">
                 <a:solidFill>
                   <a:srgbClr val="E6E6E6"/>
                 </a:solidFill>
@@ -10179,7 +10179,7 @@
 </a:t>
             </a:r>
             <a:r>
-              <a:rPr lang="en-US" sz="1750" dirty="0">
+              <a:rPr lang="en-US" sz="1700" dirty="0">
                 <a:solidFill>
                   <a:srgbClr val="8FB98F"/>
                 </a:solidFill>
@@ -10191,7 +10191,7 @@
 </a:t>
             </a:r>
             <a:r>
-              <a:rPr lang="en-US" sz="1750" dirty="0">
+              <a:rPr lang="en-US" sz="1700" dirty="0">
                 <a:solidFill>
                   <a:srgbClr val="E6E6E6"/>
                 </a:solidFill>
@@ -10199,11 +10199,11 @@
                 <a:ea typeface="Red Hat Mono" pitchFamily="34" charset="-122"/>
                 <a:cs typeface="Red Hat Mono" pitchFamily="34" charset="-120"/>
               </a:rPr>
-              <a:t>helm package charts/shipping-service \
+              <a:t>[host]$ helm package charts/shipping-service \
 </a:t>
             </a:r>
             <a:r>
-              <a:rPr lang="en-US" sz="1750" dirty="0">
+              <a:rPr lang="en-US" sz="1700" dirty="0">
                 <a:solidFill>
                   <a:srgbClr val="E6E6E6"/>
                 </a:solidFill>
@@ -10211,11 +10211,11 @@
                 <a:ea typeface="Red Hat Mono" pitchFamily="34" charset="-122"/>
                 <a:cs typeface="Red Hat Mono" pitchFamily="34" charset="-120"/>
               </a:rPr>
-              <a:t>  --version 1.0.1 --app-version 0.1.1 -d .work/repo
+              <a:t>          --version 1.0.1 --app-version 0.1.1 -d .work/repo
 </a:t>
             </a:r>
             <a:r>
-              <a:rPr lang="en-US" sz="1750" dirty="0">
+              <a:rPr lang="en-US" sz="1700" dirty="0">
                 <a:solidFill>
                   <a:srgbClr val="8FB98F"/>
                 </a:solidFill>
@@ -10227,7 +10227,7 @@
 </a:t>
             </a:r>
             <a:r>
-              <a:rPr lang="en-US" sz="1750" dirty="0">
+              <a:rPr lang="en-US" sz="1700" dirty="0">
                 <a:solidFill>
                   <a:srgbClr val="E6E6E6"/>
                 </a:solidFill>
@@ -10235,11 +10235,11 @@
                 <a:ea typeface="Red Hat Mono" pitchFamily="34" charset="-122"/>
                 <a:cs typeface="Red Hat Mono" pitchFamily="34" charset="-120"/>
               </a:rPr>
-              <a:t>helm package charts/shipping-service --version 1.1.0-rc.1 -d .work/repo
+              <a:t>[host]$ helm package charts/shipping-service --version 1.1.0-rc.1 -d .work/repo
 </a:t>
             </a:r>
             <a:r>
-              <a:rPr lang="en-US" sz="1750" dirty="0">
+              <a:rPr lang="en-US" sz="1700" dirty="0">
                 <a:solidFill>
                   <a:srgbClr val="E6E6E6"/>
                 </a:solidFill>
@@ -10247,10 +10247,10 @@
                 <a:ea typeface="Red Hat Mono" pitchFamily="34" charset="-122"/>
                 <a:cs typeface="Red Hat Mono" pitchFamily="34" charset="-120"/>
               </a:rPr>
-              <a:t>helm search repo hfd-local --devel
+              <a:t>[host]$ helm search repo hfd-local --devel
 </a:t>
             </a:r>
-            <a:endParaRPr lang="en-US" sz="1750" dirty="0"/>
+            <a:endParaRPr lang="en-US" sz="1700" dirty="0"/>
           </a:p>
         </p:txBody>
       </p:sp>
@@ -10262,7 +10262,7 @@
         </p:nvSpPr>
         <p:spPr>
           <a:xfrm>
-            <a:off x="566928" y="4538567"/>
+            <a:off x="566928" y="4463758"/>
             <a:ext cx="11055096" cy="310896"/>
           </a:xfrm>
           <a:prstGeom prst="rect">
@@ -11917,7 +11917,7 @@
         <p:spPr>
           <a:xfrm>
             <a:off x="566928" y="1417320"/>
-            <a:ext cx="11055096" cy="3403854"/>
+            <a:ext cx="11055096" cy="3179426"/>
           </a:xfrm>
           <a:prstGeom prst="rect">
             <a:avLst/>
@@ -11942,7 +11942,7 @@
         <p:spPr>
           <a:xfrm>
             <a:off x="749808" y="1508760"/>
-            <a:ext cx="10689336" cy="3220974"/>
+            <a:ext cx="10689336" cy="2996546"/>
           </a:xfrm>
           <a:prstGeom prst="rect">
             <a:avLst/>
@@ -11961,7 +11961,7 @@
               <a:buNone/>
             </a:pPr>
             <a:r>
-              <a:rPr lang="en-US" sz="2000" dirty="0">
+              <a:rPr lang="en-US" sz="1850" dirty="0">
                 <a:solidFill>
                   <a:srgbClr val="8FB98F"/>
                 </a:solidFill>
@@ -11973,7 +11973,7 @@
 </a:t>
             </a:r>
             <a:r>
-              <a:rPr lang="en-US" sz="2000" dirty="0">
+              <a:rPr lang="en-US" sz="1850" dirty="0">
                 <a:solidFill>
                   <a:srgbClr val="E6E6E6"/>
                 </a:solidFill>
@@ -11981,11 +11981,11 @@
                 <a:ea typeface="Red Hat Mono" pitchFamily="34" charset="-122"/>
                 <a:cs typeface="Red Hat Mono" pitchFamily="34" charset="-120"/>
               </a:rPr>
-              <a:t>helm package charts/shipping-service --dependency-update --sign \
+              <a:t>[host]$ helm package charts/shipping-service --dependency-update --sign \
 </a:t>
             </a:r>
             <a:r>
-              <a:rPr lang="en-US" sz="2000" dirty="0">
+              <a:rPr lang="en-US" sz="1850" dirty="0">
                 <a:solidFill>
                   <a:srgbClr val="E6E6E6"/>
                 </a:solidFill>
@@ -11993,11 +11993,11 @@
                 <a:ea typeface="Red Hat Mono" pitchFamily="34" charset="-122"/>
                 <a:cs typeface="Red Hat Mono" pitchFamily="34" charset="-120"/>
               </a:rPr>
-              <a:t>  --key "HFD Throwaway Signer" --keyring .work/keys/secring.gpg \
+              <a:t>          --key "HFD Throwaway Signer" --keyring .work/keys/secring.gpg \
 </a:t>
             </a:r>
             <a:r>
-              <a:rPr lang="en-US" sz="2000" dirty="0">
+              <a:rPr lang="en-US" sz="1850" dirty="0">
                 <a:solidFill>
                   <a:srgbClr val="E6E6E6"/>
                 </a:solidFill>
@@ -12005,11 +12005,11 @@
                 <a:ea typeface="Red Hat Mono" pitchFamily="34" charset="-122"/>
                 <a:cs typeface="Red Hat Mono" pitchFamily="34" charset="-120"/>
               </a:rPr>
-              <a:t>  -d .work/signed
+              <a:t>          -d .work/signed
 </a:t>
             </a:r>
             <a:r>
-              <a:rPr lang="en-US" sz="2000" dirty="0">
+              <a:rPr lang="en-US" sz="1850" dirty="0">
                 <a:solidFill>
                   <a:srgbClr val="8FB98F"/>
                 </a:solidFill>
@@ -12021,7 +12021,7 @@
 </a:t>
             </a:r>
             <a:r>
-              <a:rPr lang="en-US" sz="2000" dirty="0">
+              <a:rPr lang="en-US" sz="1850" dirty="0">
                 <a:solidFill>
                   <a:srgbClr val="E6E6E6"/>
                 </a:solidFill>
@@ -12029,11 +12029,11 @@
                 <a:ea typeface="Red Hat Mono" pitchFamily="34" charset="-122"/>
                 <a:cs typeface="Red Hat Mono" pitchFamily="34" charset="-120"/>
               </a:rPr>
-              <a:t>helm verify .work/signed/shipping-service-1.0.0.tgz
+              <a:t>[host]$ helm verify .work/signed/shipping-service-1.0.0.tgz
 </a:t>
             </a:r>
             <a:r>
-              <a:rPr lang="en-US" sz="2000" dirty="0">
+              <a:rPr lang="en-US" sz="1850" dirty="0">
                 <a:solidFill>
                   <a:srgbClr val="8FB98F"/>
                 </a:solidFill>
@@ -12045,7 +12045,7 @@
 </a:t>
             </a:r>
             <a:r>
-              <a:rPr lang="en-US" sz="2000" dirty="0">
+              <a:rPr lang="en-US" sz="1850" dirty="0">
                 <a:solidFill>
                   <a:srgbClr val="E6E6E6"/>
                 </a:solidFill>
@@ -12053,11 +12053,11 @@
                 <a:ea typeface="Red Hat Mono" pitchFamily="34" charset="-122"/>
                 <a:cs typeface="Red Hat Mono" pitchFamily="34" charset="-120"/>
               </a:rPr>
-              <a:t>helm pull oci://127.0.0.1:5001/signed/shipping-service \
+              <a:t>[host]$ helm pull oci://127.0.0.1:5001/signed/shipping-service \
 </a:t>
             </a:r>
             <a:r>
-              <a:rPr lang="en-US" sz="2000" dirty="0">
+              <a:rPr lang="en-US" sz="1850" dirty="0">
                 <a:solidFill>
                   <a:srgbClr val="E6E6E6"/>
                 </a:solidFill>
@@ -12065,10 +12065,10 @@
                 <a:ea typeface="Red Hat Mono" pitchFamily="34" charset="-122"/>
                 <a:cs typeface="Red Hat Mono" pitchFamily="34" charset="-120"/>
               </a:rPr>
-              <a:t>  --version 1.0.0 --plain-http --verify -d .work/pull
+              <a:t>          --version 1.0.0 --plain-http --verify -d .work/pull
 </a:t>
             </a:r>
-            <a:endParaRPr lang="en-US" sz="2000" dirty="0"/>
+            <a:endParaRPr lang="en-US" sz="1850" dirty="0"/>
           </a:p>
         </p:txBody>
       </p:sp>
@@ -12080,7 +12080,7 @@
         </p:nvSpPr>
         <p:spPr>
           <a:xfrm>
-            <a:off x="566928" y="4912614"/>
+            <a:off x="566928" y="4688186"/>
             <a:ext cx="11055096" cy="310896"/>
           </a:xfrm>
           <a:prstGeom prst="rect">
@@ -12325,7 +12325,7 @@
         <p:spPr>
           <a:xfrm>
             <a:off x="566928" y="1417320"/>
-            <a:ext cx="11055096" cy="3179426"/>
+            <a:ext cx="11055096" cy="2954998"/>
           </a:xfrm>
           <a:prstGeom prst="rect">
             <a:avLst/>
@@ -12350,7 +12350,7 @@
         <p:spPr>
           <a:xfrm>
             <a:off x="749808" y="1508760"/>
-            <a:ext cx="10689336" cy="2996546"/>
+            <a:ext cx="10689336" cy="2772118"/>
           </a:xfrm>
           <a:prstGeom prst="rect">
             <a:avLst/>
@@ -12369,7 +12369,7 @@
               <a:buNone/>
             </a:pPr>
             <a:r>
-              <a:rPr lang="en-US" sz="1850" dirty="0">
+              <a:rPr lang="en-US" sz="1700" dirty="0">
                 <a:solidFill>
                   <a:srgbClr val="8FB98F"/>
                 </a:solidFill>
@@ -12381,7 +12381,7 @@
 </a:t>
             </a:r>
             <a:r>
-              <a:rPr lang="en-US" sz="1850" dirty="0">
+              <a:rPr lang="en-US" sz="1700" dirty="0">
                 <a:solidFill>
                   <a:srgbClr val="E6E6E6"/>
                 </a:solidFill>
@@ -12389,11 +12389,11 @@
                 <a:ea typeface="Red Hat Mono" pitchFamily="34" charset="-122"/>
                 <a:cs typeface="Red Hat Mono" pitchFamily="34" charset="-120"/>
               </a:rPr>
-              <a:t>cosign sign --key .work/cosign/cosign.key --yes --allow-http-registry \
+              <a:t>[host]$ cosign sign --key .work/cosign/cosign.key --yes --allow-http-registry \
 </a:t>
             </a:r>
             <a:r>
-              <a:rPr lang="en-US" sz="1850" dirty="0">
+              <a:rPr lang="en-US" sz="1700" dirty="0">
                 <a:solidFill>
                   <a:srgbClr val="E6E6E6"/>
                 </a:solidFill>
@@ -12401,11 +12401,11 @@
                 <a:ea typeface="Red Hat Mono" pitchFamily="34" charset="-122"/>
                 <a:cs typeface="Red Hat Mono" pitchFamily="34" charset="-120"/>
               </a:rPr>
-              <a:t>  --use-signing-config=false --tlog-upload=false \
+              <a:t>          --use-signing-config=false --tlog-upload=false \
 </a:t>
             </a:r>
             <a:r>
-              <a:rPr lang="en-US" sz="1850" dirty="0">
+              <a:rPr lang="en-US" sz="1700" dirty="0">
                 <a:solidFill>
                   <a:srgbClr val="E6E6E6"/>
                 </a:solidFill>
@@ -12413,11 +12413,11 @@
                 <a:ea typeface="Red Hat Mono" pitchFamily="34" charset="-122"/>
                 <a:cs typeface="Red Hat Mono" pitchFamily="34" charset="-120"/>
               </a:rPr>
-              <a:t>  127.0.0.1:5001/signed/shipping-service@sha256:&lt;digest&gt;
+              <a:t>          127.0.0.1:5001/signed/shipping-service@sha256:&lt;digest&gt;
 </a:t>
             </a:r>
             <a:r>
-              <a:rPr lang="en-US" sz="1850" dirty="0">
+              <a:rPr lang="en-US" sz="1700" dirty="0">
                 <a:solidFill>
                   <a:srgbClr val="E6E6E6"/>
                 </a:solidFill>
@@ -12425,11 +12425,11 @@
                 <a:ea typeface="Red Hat Mono" pitchFamily="34" charset="-122"/>
                 <a:cs typeface="Red Hat Mono" pitchFamily="34" charset="-120"/>
               </a:rPr>
-              <a:t>cosign verify --key .work/cosign/cosign.pub --allow-http-registry \
+              <a:t>[host]$ cosign verify --key .work/cosign/cosign.pub --allow-http-registry \
 </a:t>
             </a:r>
             <a:r>
-              <a:rPr lang="en-US" sz="1850" dirty="0">
+              <a:rPr lang="en-US" sz="1700" dirty="0">
                 <a:solidFill>
                   <a:srgbClr val="E6E6E6"/>
                 </a:solidFill>
@@ -12437,11 +12437,11 @@
                 <a:ea typeface="Red Hat Mono" pitchFamily="34" charset="-122"/>
                 <a:cs typeface="Red Hat Mono" pitchFamily="34" charset="-120"/>
               </a:rPr>
-              <a:t>  --insecure-ignore-tlog \
+              <a:t>          --insecure-ignore-tlog \
 </a:t>
             </a:r>
             <a:r>
-              <a:rPr lang="en-US" sz="1850" dirty="0">
+              <a:rPr lang="en-US" sz="1700" dirty="0">
                 <a:solidFill>
                   <a:srgbClr val="E6E6E6"/>
                 </a:solidFill>
@@ -12449,11 +12449,11 @@
                 <a:ea typeface="Red Hat Mono" pitchFamily="34" charset="-122"/>
                 <a:cs typeface="Red Hat Mono" pitchFamily="34" charset="-120"/>
               </a:rPr>
-              <a:t>  127.0.0.1:5001/signed/shipping-service@sha256:&lt;digest&gt;
+              <a:t>          127.0.0.1:5001/signed/shipping-service@sha256:&lt;digest&gt;
 </a:t>
             </a:r>
             <a:r>
-              <a:rPr lang="en-US" sz="1850" dirty="0">
+              <a:rPr lang="en-US" sz="1700" dirty="0">
                 <a:solidFill>
                   <a:srgbClr val="8FB98F"/>
                 </a:solidFill>
@@ -12465,7 +12465,7 @@
 </a:t>
             </a:r>
             <a:r>
-              <a:rPr lang="en-US" sz="1850" dirty="0">
+              <a:rPr lang="en-US" sz="1700" dirty="0">
                 <a:solidFill>
                   <a:srgbClr val="8FB98F"/>
                 </a:solidFill>
@@ -12476,7 +12476,7 @@
               <a:t># omit --key, --use-signing-config=false and --tlog-upload=false
 </a:t>
             </a:r>
-            <a:endParaRPr lang="en-US" sz="1850" dirty="0"/>
+            <a:endParaRPr lang="en-US" sz="1700" dirty="0"/>
           </a:p>
         </p:txBody>
       </p:sp>
@@ -12488,7 +12488,7 @@
         </p:nvSpPr>
         <p:spPr>
           <a:xfrm>
-            <a:off x="566928" y="4688186"/>
+            <a:off x="566928" y="4463758"/>
             <a:ext cx="11055096" cy="310896"/>
           </a:xfrm>
           <a:prstGeom prst="rect">
@@ -14664,7 +14664,7 @@
                 <a:ea typeface="Red Hat Mono" pitchFamily="34" charset="-122"/>
                 <a:cs typeface="Red Hat Mono" pitchFamily="34" charset="-120"/>
               </a:rPr>
-              <a:t>GOOS=wasip1 GOARCH=wasm go build \
+              <a:t>[host]$ GOOS=wasip1 GOARCH=wasm go build \
 </a:t>
             </a:r>
             <a:r>
@@ -14676,7 +14676,7 @@
                 <a:ea typeface="Red Hat Mono" pitchFamily="34" charset="-122"/>
                 <a:cs typeface="Red Hat Mono" pitchFamily="34" charset="-120"/>
               </a:rPr>
-              <a:t>  -buildmode=c-shared -o plugin.wasm .
+              <a:t>          -buildmode=c-shared -o plugin.wasm .
 </a:t>
             </a:r>
             <a:r>
@@ -19425,7 +19425,7 @@
         <p:spPr>
           <a:xfrm>
             <a:off x="566928" y="1417320"/>
-            <a:ext cx="11055096" cy="3794525"/>
+            <a:ext cx="11055096" cy="3428790"/>
           </a:xfrm>
           <a:prstGeom prst="rect">
             <a:avLst/>
@@ -19450,7 +19450,7 @@
         <p:spPr>
           <a:xfrm>
             <a:off x="749808" y="1508760"/>
-            <a:ext cx="10689336" cy="3611645"/>
+            <a:ext cx="10689336" cy="3245910"/>
           </a:xfrm>
           <a:prstGeom prst="rect">
             <a:avLst/>
@@ -19469,7 +19469,7 @@
               <a:buNone/>
             </a:pPr>
             <a:r>
-              <a:rPr lang="en-US" sz="1850" dirty="0">
+              <a:rPr lang="en-US" sz="1650" dirty="0">
                 <a:solidFill>
                   <a:srgbClr val="8FB98F"/>
                 </a:solidFill>
@@ -19481,7 +19481,7 @@
 </a:t>
             </a:r>
             <a:r>
-              <a:rPr lang="en-US" sz="1850" dirty="0">
+              <a:rPr lang="en-US" sz="1650" dirty="0">
                 <a:solidFill>
                   <a:srgbClr val="E6E6E6"/>
                 </a:solidFill>
@@ -19489,11 +19489,11 @@
                 <a:ea typeface="Red Hat Mono" pitchFamily="34" charset="-122"/>
                 <a:cs typeface="Red Hat Mono" pitchFamily="34" charset="-120"/>
               </a:rPr>
-              <a:t>helm upgrade --install platform charts/shipping-platform -n hfd-ocp \
+              <a:t>[crc-host]$ helm upgrade --install platform charts/shipping-platform -n hfd-ocp \
 </a:t>
             </a:r>
             <a:r>
-              <a:rPr lang="en-US" sz="1850" dirty="0">
+              <a:rPr lang="en-US" sz="1650" dirty="0">
                 <a:solidFill>
                   <a:srgbClr val="E6E6E6"/>
                 </a:solidFill>
@@ -19501,11 +19501,11 @@
                 <a:ea typeface="Red Hat Mono" pitchFamily="34" charset="-122"/>
                 <a:cs typeface="Red Hat Mono" pitchFamily="34" charset="-120"/>
               </a:rPr>
-              <a:t>  -f values-openshift.yaml -f values-openshift-minimal.yaml \
+              <a:t>          -f values-openshift.yaml -f values-openshift-minimal.yaml \
 </a:t>
             </a:r>
             <a:r>
-              <a:rPr lang="en-US" sz="1850" dirty="0">
+              <a:rPr lang="en-US" sz="1650" dirty="0">
                 <a:solidFill>
                   <a:srgbClr val="E6E6E6"/>
                 </a:solidFill>
@@ -19513,11 +19513,11 @@
                 <a:ea typeface="Red Hat Mono" pitchFamily="34" charset="-122"/>
                 <a:cs typeface="Red Hat Mono" pitchFamily="34" charset="-120"/>
               </a:rPr>
-              <a:t>  --wait --rollback-on-failure
+              <a:t>          --wait --rollback-on-failure
 </a:t>
             </a:r>
             <a:r>
-              <a:rPr lang="en-US" sz="1850" dirty="0">
+              <a:rPr lang="en-US" sz="1650" dirty="0">
                 <a:solidFill>
                   <a:srgbClr val="8FB98F"/>
                 </a:solidFill>
@@ -19529,7 +19529,7 @@
 </a:t>
             </a:r>
             <a:r>
-              <a:rPr lang="en-US" sz="1850" dirty="0">
+              <a:rPr lang="en-US" sz="1650" dirty="0">
                 <a:solidFill>
                   <a:srgbClr val="E6E6E6"/>
                 </a:solidFill>
@@ -19541,7 +19541,7 @@
 </a:t>
             </a:r>
             <a:r>
-              <a:rPr lang="en-US" sz="1850" dirty="0">
+              <a:rPr lang="en-US" sz="1650" dirty="0">
                 <a:solidFill>
                   <a:srgbClr val="E6E6E6"/>
                 </a:solidFill>
@@ -19553,7 +19553,7 @@
 </a:t>
             </a:r>
             <a:r>
-              <a:rPr lang="en-US" sz="1850" dirty="0">
+              <a:rPr lang="en-US" sz="1650" dirty="0">
                 <a:solidFill>
                   <a:srgbClr val="E6E6E6"/>
                 </a:solidFill>
@@ -19565,7 +19565,7 @@
 </a:t>
             </a:r>
             <a:r>
-              <a:rPr lang="en-US" sz="1850" dirty="0">
+              <a:rPr lang="en-US" sz="1650" dirty="0">
                 <a:solidFill>
                   <a:srgbClr val="E6E6E6"/>
                 </a:solidFill>
@@ -19577,7 +19577,7 @@
 </a:t>
             </a:r>
             <a:r>
-              <a:rPr lang="en-US" sz="1850" dirty="0">
+              <a:rPr lang="en-US" sz="1650" dirty="0">
                 <a:solidFill>
                   <a:srgbClr val="E6E6E6"/>
                 </a:solidFill>
@@ -19589,7 +19589,7 @@
 </a:t>
             </a:r>
             <a:r>
-              <a:rPr lang="en-US" sz="1850" dirty="0">
+              <a:rPr lang="en-US" sz="1650" dirty="0">
                 <a:solidFill>
                   <a:srgbClr val="E6E6E6"/>
                 </a:solidFill>
@@ -19600,7 +19600,7 @@
               <a:t>    type: ClusterIP
 </a:t>
             </a:r>
-            <a:endParaRPr lang="en-US" sz="1850" dirty="0"/>
+            <a:endParaRPr lang="en-US" sz="1650" dirty="0"/>
           </a:p>
         </p:txBody>
       </p:sp>
@@ -19612,7 +19612,7 @@
         </p:nvSpPr>
         <p:spPr>
           <a:xfrm>
-            <a:off x="566928" y="5303285"/>
+            <a:off x="566928" y="4937550"/>
             <a:ext cx="11055096" cy="310896"/>
           </a:xfrm>
           <a:prstGeom prst="rect">
@@ -20005,7 +20005,7 @@
                 <a:ea typeface="Red Hat Mono" pitchFamily="34" charset="-122"/>
                 <a:cs typeface="Red Hat Mono" pitchFamily="34" charset="-120"/>
               </a:rPr>
-              <a:t>    url: https://patterncatalyst.github.io/helm-for-developers
+              <a:t>    url: https://&lt;your-chart-repo-host&gt;/charts
 </a:t>
             </a:r>
             <a:endParaRPr lang="en-US" sz="2000" dirty="0"/>
@@ -20045,7 +20045,7 @@
                 <a:ea typeface="Red Hat Text" pitchFamily="34" charset="-122"/>
                 <a:cs typeface="Red Hat Text" pitchFamily="34" charset="-120"/>
               </a:rPr>
-              <a:t>The console installs charts from a repository registered per project; the index must be published at that URL.</a:t>
+              <a:t>The console installs charts from a repository registered per project; replace the placeholder URL with a repository that publishes an index.yaml.</a:t>
             </a:r>
             <a:endParaRPr lang="en-US" sz="1300" dirty="0"/>
           </a:p>
@@ -23284,7 +23284,7 @@
         <p:spPr>
           <a:xfrm>
             <a:off x="566928" y="1417320"/>
-            <a:ext cx="11055096" cy="3736340"/>
+            <a:ext cx="11055096" cy="3403854"/>
           </a:xfrm>
           <a:prstGeom prst="rect">
             <a:avLst/>
@@ -23309,7 +23309,7 @@
         <p:spPr>
           <a:xfrm>
             <a:off x="749808" y="1508760"/>
-            <a:ext cx="10689336" cy="3553460"/>
+            <a:ext cx="10689336" cy="3220974"/>
           </a:xfrm>
           <a:prstGeom prst="rect">
             <a:avLst/>
@@ -23328,7 +23328,7 @@
               <a:buNone/>
             </a:pPr>
             <a:r>
-              <a:rPr lang="en-US" sz="2000" dirty="0">
+              <a:rPr lang="en-US" sz="1800" dirty="0">
                 <a:solidFill>
                   <a:srgbClr val="8FB98F"/>
                 </a:solidFill>
@@ -23340,7 +23340,7 @@
 </a:t>
             </a:r>
             <a:r>
-              <a:rPr lang="en-US" sz="2000" dirty="0">
+              <a:rPr lang="en-US" sz="1800" dirty="0">
                 <a:solidFill>
                   <a:srgbClr val="E6E6E6"/>
                 </a:solidFill>
@@ -23348,11 +23348,11 @@
                 <a:ea typeface="Red Hat Mono" pitchFamily="34" charset="-122"/>
                 <a:cs typeface="Red Hat Mono" pitchFamily="34" charset="-120"/>
               </a:rPr>
-              <a:t>helm diff local charts/shipping-service /tmp/changed
+              <a:t>[host]$ helm diff local charts/shipping-service /tmp/changed
 </a:t>
             </a:r>
             <a:r>
-              <a:rPr lang="en-US" sz="2000" dirty="0">
+              <a:rPr lang="en-US" sz="1800" dirty="0">
                 <a:solidFill>
                   <a:srgbClr val="8FB98F"/>
                 </a:solidFill>
@@ -23364,7 +23364,7 @@
 </a:t>
             </a:r>
             <a:r>
-              <a:rPr lang="en-US" sz="2000" dirty="0">
+              <a:rPr lang="en-US" sz="1800" dirty="0">
                 <a:solidFill>
                   <a:srgbClr val="E6E6E6"/>
                 </a:solidFill>
@@ -23372,11 +23372,11 @@
                 <a:ea typeface="Red Hat Mono" pitchFamily="34" charset="-122"/>
                 <a:cs typeface="Red Hat Mono" pitchFamily="34" charset="-120"/>
               </a:rPr>
-              <a:t>helm upgrade shipping charts/shipping-service -n hfd-13 \
+              <a:t>[host]$ helm upgrade shipping charts/shipping-service -n hfd-13 \
 </a:t>
             </a:r>
             <a:r>
-              <a:rPr lang="en-US" sz="2000" dirty="0">
+              <a:rPr lang="en-US" sz="1800" dirty="0">
                 <a:solidFill>
                   <a:srgbClr val="E6E6E6"/>
                 </a:solidFill>
@@ -23384,11 +23384,11 @@
                 <a:ea typeface="Red Hat Mono" pitchFamily="34" charset="-122"/>
                 <a:cs typeface="Red Hat Mono" pitchFamily="34" charset="-120"/>
               </a:rPr>
-              <a:t>  --dry-run=server
+              <a:t>          --dry-run=server
 </a:t>
             </a:r>
             <a:r>
-              <a:rPr lang="en-US" sz="2000" dirty="0">
+              <a:rPr lang="en-US" sz="1800" dirty="0">
                 <a:solidFill>
                   <a:srgbClr val="8FB98F"/>
                 </a:solidFill>
@@ -23400,7 +23400,7 @@
 </a:t>
             </a:r>
             <a:r>
-              <a:rPr lang="en-US" sz="2000" dirty="0">
+              <a:rPr lang="en-US" sz="1800" dirty="0">
                 <a:solidFill>
                   <a:srgbClr val="E6E6E6"/>
                 </a:solidFill>
@@ -23408,11 +23408,11 @@
                 <a:ea typeface="Red Hat Mono" pitchFamily="34" charset="-122"/>
                 <a:cs typeface="Red Hat Mono" pitchFamily="34" charset="-120"/>
               </a:rPr>
-              <a:t>helm diff upgrade shipping charts/shipping-service -n hfd-13 \
+              <a:t>[host]$ helm diff upgrade shipping charts/shipping-service -n hfd-13 \
 </a:t>
             </a:r>
             <a:r>
-              <a:rPr lang="en-US" sz="2000" dirty="0">
+              <a:rPr lang="en-US" sz="1800" dirty="0">
                 <a:solidFill>
                   <a:srgbClr val="E6E6E6"/>
                 </a:solidFill>
@@ -23420,11 +23420,11 @@
                 <a:ea typeface="Red Hat Mono" pitchFamily="34" charset="-122"/>
                 <a:cs typeface="Red Hat Mono" pitchFamily="34" charset="-120"/>
               </a:rPr>
-              <a:t>  --set replicaCount=2
+              <a:t>          --set replicaCount=2
 </a:t>
             </a:r>
             <a:r>
-              <a:rPr lang="en-US" sz="2000" dirty="0">
+              <a:rPr lang="en-US" sz="1800" dirty="0">
                 <a:solidFill>
                   <a:srgbClr val="8FB98F"/>
                 </a:solidFill>
@@ -23436,7 +23436,7 @@
 </a:t>
             </a:r>
             <a:r>
-              <a:rPr lang="en-US" sz="2000" dirty="0">
+              <a:rPr lang="en-US" sz="1800" dirty="0">
                 <a:solidFill>
                   <a:srgbClr val="E6E6E6"/>
                 </a:solidFill>
@@ -23444,10 +23444,10 @@
                 <a:ea typeface="Red Hat Mono" pitchFamily="34" charset="-122"/>
                 <a:cs typeface="Red Hat Mono" pitchFamily="34" charset="-120"/>
               </a:rPr>
-              <a:t>helm get manifest shipping -n hfd-13 | kubeconform -strict -summary
+              <a:t>[host]$ helm get manifest shipping -n hfd-13 | kubeconform -strict -summary
 </a:t>
             </a:r>
-            <a:endParaRPr lang="en-US" sz="2000" dirty="0"/>
+            <a:endParaRPr lang="en-US" sz="1800" dirty="0"/>
           </a:p>
         </p:txBody>
       </p:sp>
@@ -23459,7 +23459,7 @@
         </p:nvSpPr>
         <p:spPr>
           <a:xfrm>
-            <a:off x="566928" y="5245100"/>
+            <a:off x="566928" y="4912614"/>
             <a:ext cx="11055096" cy="310896"/>
           </a:xfrm>
           <a:prstGeom prst="rect">

</xml_diff>

<commit_message>
feat(ci): publish Helm chart repository on GitHub Pages
Add scripts/publish-charts.sh (package the six reference charts and pc-lib,
write index.yaml with Pages URLs), a --helm-only flag for install-tools.sh,
and workflow steps that run it into _site/charts after the Jekyll build.
Replace the ch27 and Helm 201 placeholder chart-repo URL with the real one
and add a Published chart repository section to ch19 (unverified until the
r1.1 deploy).
</commit_message>
<xml_diff>
--- a/presentation/helm-201/Helm-201-r1.0.pptx
+++ b/presentation/helm-201/Helm-201-r1.0.pptx
@@ -3695,8 +3695,8 @@
           <a:p>
             <a:r>
               <a:rPr lang="en-US" dirty="0"/>
-              <a:t>What it shows: A `ProjectHelmChartRepository` makes a chart repository visible in the Developer console's Helm catalog for one project. On OpenShift Local 2.64.0 the resource was accepted and listed by `oc get`. The console view was not opened, and the URL tried returned 404 because no index was published there, so the listing could not populate. The URL on the slide is a placeholder for your own repository.
-What to show: `oc get projecthelmchartrepository -n hfd-ocp` on a CRC host; the console view needs a published index.
+              <a:t>What it shows: A `ProjectHelmChartRepository` makes a chart repository visible in the Developer console's Helm catalog for one project. On OpenShift Local 2.64.0 the resource was accepted and listed by `oc get`, tested earlier against a placeholder URL. The console view was not opened. The URL on the slide is the repository the site publishes from r1.1; check the listing after that deploy.
+What to show: `oc get projecthelmchartrepository -n hfd-ocp` on a CRC host; the console listing needs the r1.1 site deploy.
 Fallback: the YAML on this slide and the chapter 27 section on the Developer console.</a:t>
             </a:r>
             <a:endParaRPr lang="en-US" dirty="0"/>
@@ -19857,7 +19857,7 @@
         <p:spPr>
           <a:xfrm>
             <a:off x="566928" y="1417320"/>
-            <a:ext cx="11055096" cy="3403854"/>
+            <a:ext cx="11055096" cy="3329045"/>
           </a:xfrm>
           <a:prstGeom prst="rect">
             <a:avLst/>
@@ -19882,7 +19882,7 @@
         <p:spPr>
           <a:xfrm>
             <a:off x="749808" y="1508760"/>
-            <a:ext cx="10689336" cy="3220974"/>
+            <a:ext cx="10689336" cy="3146165"/>
           </a:xfrm>
           <a:prstGeom prst="rect">
             <a:avLst/>
@@ -19901,7 +19901,7 @@
               <a:buNone/>
             </a:pPr>
             <a:r>
-              <a:rPr lang="en-US" sz="2000" dirty="0">
+              <a:rPr lang="en-US" sz="1950" dirty="0">
                 <a:solidFill>
                   <a:srgbClr val="8FB98F"/>
                 </a:solidFill>
@@ -19913,7 +19913,7 @@
 </a:t>
             </a:r>
             <a:r>
-              <a:rPr lang="en-US" sz="2000" dirty="0">
+              <a:rPr lang="en-US" sz="1950" dirty="0">
                 <a:solidFill>
                   <a:srgbClr val="E6E6E6"/>
                 </a:solidFill>
@@ -19925,7 +19925,7 @@
 </a:t>
             </a:r>
             <a:r>
-              <a:rPr lang="en-US" sz="2000" dirty="0">
+              <a:rPr lang="en-US" sz="1950" dirty="0">
                 <a:solidFill>
                   <a:srgbClr val="E6E6E6"/>
                 </a:solidFill>
@@ -19937,7 +19937,7 @@
 </a:t>
             </a:r>
             <a:r>
-              <a:rPr lang="en-US" sz="2000" dirty="0">
+              <a:rPr lang="en-US" sz="1950" dirty="0">
                 <a:solidFill>
                   <a:srgbClr val="E6E6E6"/>
                 </a:solidFill>
@@ -19949,7 +19949,7 @@
 </a:t>
             </a:r>
             <a:r>
-              <a:rPr lang="en-US" sz="2000" dirty="0">
+              <a:rPr lang="en-US" sz="1950" dirty="0">
                 <a:solidFill>
                   <a:srgbClr val="E6E6E6"/>
                 </a:solidFill>
@@ -19961,7 +19961,7 @@
 </a:t>
             </a:r>
             <a:r>
-              <a:rPr lang="en-US" sz="2000" dirty="0">
+              <a:rPr lang="en-US" sz="1950" dirty="0">
                 <a:solidFill>
                   <a:srgbClr val="E6E6E6"/>
                 </a:solidFill>
@@ -19973,7 +19973,7 @@
 </a:t>
             </a:r>
             <a:r>
-              <a:rPr lang="en-US" sz="2000" dirty="0">
+              <a:rPr lang="en-US" sz="1950" dirty="0">
                 <a:solidFill>
                   <a:srgbClr val="E6E6E6"/>
                 </a:solidFill>
@@ -19985,7 +19985,7 @@
 </a:t>
             </a:r>
             <a:r>
-              <a:rPr lang="en-US" sz="2000" dirty="0">
+              <a:rPr lang="en-US" sz="1950" dirty="0">
                 <a:solidFill>
                   <a:srgbClr val="E6E6E6"/>
                 </a:solidFill>
@@ -19997,7 +19997,7 @@
 </a:t>
             </a:r>
             <a:r>
-              <a:rPr lang="en-US" sz="2000" dirty="0">
+              <a:rPr lang="en-US" sz="1950" dirty="0">
                 <a:solidFill>
                   <a:srgbClr val="E6E6E6"/>
                 </a:solidFill>
@@ -20005,10 +20005,10 @@
                 <a:ea typeface="Red Hat Mono" pitchFamily="34" charset="-122"/>
                 <a:cs typeface="Red Hat Mono" pitchFamily="34" charset="-120"/>
               </a:rPr>
-              <a:t>    url: https://&lt;your-chart-repo-host&gt;/charts
+              <a:t>    url: https://patterncatalyst.github.io/helm-for-developers/charts
 </a:t>
             </a:r>
-            <a:endParaRPr lang="en-US" sz="2000" dirty="0"/>
+            <a:endParaRPr lang="en-US" sz="1950" dirty="0"/>
           </a:p>
         </p:txBody>
       </p:sp>
@@ -20020,7 +20020,7 @@
         </p:nvSpPr>
         <p:spPr>
           <a:xfrm>
-            <a:off x="566928" y="4912614"/>
+            <a:off x="566928" y="4837805"/>
             <a:ext cx="11055096" cy="310896"/>
           </a:xfrm>
           <a:prstGeom prst="rect">
@@ -20045,7 +20045,7 @@
                 <a:ea typeface="Red Hat Text" pitchFamily="34" charset="-122"/>
                 <a:cs typeface="Red Hat Text" pitchFamily="34" charset="-120"/>
               </a:rPr>
-              <a:t>The console installs charts from a repository registered per project; replace the placeholder URL with a repository that publishes an index.yaml.</a:t>
+              <a:t>The console installs charts from a repository registered per project; the URL is this site's published chart repository, a classic index.yaml plus packaged archives.</a:t>
             </a:r>
             <a:endParaRPr lang="en-US" sz="1300" dirty="0"/>
           </a:p>

</xml_diff>

<commit_message>
feat(ci): publish Helm chart repository on GitHub Pages (#4)
Add scripts/publish-charts.sh (package the six reference charts and pc-lib,
write index.yaml with Pages URLs), a --helm-only flag for install-tools.sh,
and workflow steps that run it into _site/charts after the Jekyll build.
Replace the ch27 and Helm 201 placeholder chart-repo URL with the real one
and add a Published chart repository section to ch19 (unverified until the
r1.1 deploy).
</commit_message>
<xml_diff>
--- a/presentation/helm-201/Helm-201-r1.0.pptx
+++ b/presentation/helm-201/Helm-201-r1.0.pptx
@@ -3695,8 +3695,8 @@
           <a:p>
             <a:r>
               <a:rPr lang="en-US" dirty="0"/>
-              <a:t>What it shows: A `ProjectHelmChartRepository` makes a chart repository visible in the Developer console's Helm catalog for one project. On OpenShift Local 2.64.0 the resource was accepted and listed by `oc get`. The console view was not opened, and the URL tried returned 404 because no index was published there, so the listing could not populate. The URL on the slide is a placeholder for your own repository.
-What to show: `oc get projecthelmchartrepository -n hfd-ocp` on a CRC host; the console view needs a published index.
+              <a:t>What it shows: A `ProjectHelmChartRepository` makes a chart repository visible in the Developer console's Helm catalog for one project. On OpenShift Local 2.64.0 the resource was accepted and listed by `oc get`, tested earlier against a placeholder URL. The console view was not opened. The URL on the slide is the repository the site publishes from r1.1; check the listing after that deploy.
+What to show: `oc get projecthelmchartrepository -n hfd-ocp` on a CRC host; the console listing needs the r1.1 site deploy.
 Fallback: the YAML on this slide and the chapter 27 section on the Developer console.</a:t>
             </a:r>
             <a:endParaRPr lang="en-US" dirty="0"/>
@@ -19857,7 +19857,7 @@
         <p:spPr>
           <a:xfrm>
             <a:off x="566928" y="1417320"/>
-            <a:ext cx="11055096" cy="3403854"/>
+            <a:ext cx="11055096" cy="3329045"/>
           </a:xfrm>
           <a:prstGeom prst="rect">
             <a:avLst/>
@@ -19882,7 +19882,7 @@
         <p:spPr>
           <a:xfrm>
             <a:off x="749808" y="1508760"/>
-            <a:ext cx="10689336" cy="3220974"/>
+            <a:ext cx="10689336" cy="3146165"/>
           </a:xfrm>
           <a:prstGeom prst="rect">
             <a:avLst/>
@@ -19901,7 +19901,7 @@
               <a:buNone/>
             </a:pPr>
             <a:r>
-              <a:rPr lang="en-US" sz="2000" dirty="0">
+              <a:rPr lang="en-US" sz="1950" dirty="0">
                 <a:solidFill>
                   <a:srgbClr val="8FB98F"/>
                 </a:solidFill>
@@ -19913,7 +19913,7 @@
 </a:t>
             </a:r>
             <a:r>
-              <a:rPr lang="en-US" sz="2000" dirty="0">
+              <a:rPr lang="en-US" sz="1950" dirty="0">
                 <a:solidFill>
                   <a:srgbClr val="E6E6E6"/>
                 </a:solidFill>
@@ -19925,7 +19925,7 @@
 </a:t>
             </a:r>
             <a:r>
-              <a:rPr lang="en-US" sz="2000" dirty="0">
+              <a:rPr lang="en-US" sz="1950" dirty="0">
                 <a:solidFill>
                   <a:srgbClr val="E6E6E6"/>
                 </a:solidFill>
@@ -19937,7 +19937,7 @@
 </a:t>
             </a:r>
             <a:r>
-              <a:rPr lang="en-US" sz="2000" dirty="0">
+              <a:rPr lang="en-US" sz="1950" dirty="0">
                 <a:solidFill>
                   <a:srgbClr val="E6E6E6"/>
                 </a:solidFill>
@@ -19949,7 +19949,7 @@
 </a:t>
             </a:r>
             <a:r>
-              <a:rPr lang="en-US" sz="2000" dirty="0">
+              <a:rPr lang="en-US" sz="1950" dirty="0">
                 <a:solidFill>
                   <a:srgbClr val="E6E6E6"/>
                 </a:solidFill>
@@ -19961,7 +19961,7 @@
 </a:t>
             </a:r>
             <a:r>
-              <a:rPr lang="en-US" sz="2000" dirty="0">
+              <a:rPr lang="en-US" sz="1950" dirty="0">
                 <a:solidFill>
                   <a:srgbClr val="E6E6E6"/>
                 </a:solidFill>
@@ -19973,7 +19973,7 @@
 </a:t>
             </a:r>
             <a:r>
-              <a:rPr lang="en-US" sz="2000" dirty="0">
+              <a:rPr lang="en-US" sz="1950" dirty="0">
                 <a:solidFill>
                   <a:srgbClr val="E6E6E6"/>
                 </a:solidFill>
@@ -19985,7 +19985,7 @@
 </a:t>
             </a:r>
             <a:r>
-              <a:rPr lang="en-US" sz="2000" dirty="0">
+              <a:rPr lang="en-US" sz="1950" dirty="0">
                 <a:solidFill>
                   <a:srgbClr val="E6E6E6"/>
                 </a:solidFill>
@@ -19997,7 +19997,7 @@
 </a:t>
             </a:r>
             <a:r>
-              <a:rPr lang="en-US" sz="2000" dirty="0">
+              <a:rPr lang="en-US" sz="1950" dirty="0">
                 <a:solidFill>
                   <a:srgbClr val="E6E6E6"/>
                 </a:solidFill>
@@ -20005,10 +20005,10 @@
                 <a:ea typeface="Red Hat Mono" pitchFamily="34" charset="-122"/>
                 <a:cs typeface="Red Hat Mono" pitchFamily="34" charset="-120"/>
               </a:rPr>
-              <a:t>    url: https://&lt;your-chart-repo-host&gt;/charts
+              <a:t>    url: https://patterncatalyst.github.io/helm-for-developers/charts
 </a:t>
             </a:r>
-            <a:endParaRPr lang="en-US" sz="2000" dirty="0"/>
+            <a:endParaRPr lang="en-US" sz="1950" dirty="0"/>
           </a:p>
         </p:txBody>
       </p:sp>
@@ -20020,7 +20020,7 @@
         </p:nvSpPr>
         <p:spPr>
           <a:xfrm>
-            <a:off x="566928" y="4912614"/>
+            <a:off x="566928" y="4837805"/>
             <a:ext cx="11055096" cy="310896"/>
           </a:xfrm>
           <a:prstGeom prst="rect">
@@ -20045,7 +20045,7 @@
                 <a:ea typeface="Red Hat Text" pitchFamily="34" charset="-122"/>
                 <a:cs typeface="Red Hat Text" pitchFamily="34" charset="-120"/>
               </a:rPr>
-              <a:t>The console installs charts from a repository registered per project; replace the placeholder URL with a repository that publishes an index.yaml.</a:t>
+              <a:t>The console installs charts from a repository registered per project; the URL is this site's published chart repository, a classic index.yaml plus packaged archives.</a:t>
             </a:r>
             <a:endParaRPr lang="en-US" sz="1300" dirty="0"/>
           </a:p>

</xml_diff>

<commit_message>
docs(§27): verify Streams for Apache Kafka on OpenShift Local; console Helm repository checks
</commit_message>
<xml_diff>
--- a/presentation/helm-201/Helm-201-r1.0.pptx
+++ b/presentation/helm-201/Helm-201-r1.0.pptx
@@ -3335,7 +3335,7 @@
           <a:p>
             <a:r>
               <a:rPr lang="en-US" dirty="0"/>
-              <a:t>What it shows: Chapter 27. The same umbrella chart installs on OpenShift Local (CRC) with an override values file. The appendix was verified on OpenShift Local 2.64.0 (OpenShift 4.22.14) on 2026-10-08: the full profile with CloudNativePG and Strimzi from OperatorHub, and the minimal profile, both passing verify-crc.sh. The Developer console Helm view and Streams for Apache Kafka were not run.
+              <a:t>What it shows: Chapter 27. The same umbrella chart installs on OpenShift Local (CRC) with an override values file. The appendix was verified on OpenShift Local 2.64.0 (OpenShift 4.22.14) on 2026-10-08: the full profile with CloudNativePG and either Strimzi 1.2.0 or Streams for Apache Kafka 3.2.1 from OperatorHub, and the minimal profile, all passing verify-crc.sh. The two Kafka operators own the same CRDs, so a cluster runs one of them. The Developer console Helm view was set up against the published repository; the console's own catalog listing was not opened.
 What to show: `cd examples/27-openshift-crc &amp;&amp; ./demo.sh offline` anywhere; `PROFILE=full ./verify-crc.sh` on a CRC host.
 Fallback: the offline render plus the chapter text; the verify-crc.sh PASS lines from the 2026-10-08 CRC run in the chapter.</a:t>
             </a:r>
@@ -3695,8 +3695,8 @@
           <a:p>
             <a:r>
               <a:rPr lang="en-US" dirty="0"/>
-              <a:t>What it shows: A `ProjectHelmChartRepository` makes a chart repository visible in the Developer console's Helm catalog for one project. On OpenShift Local 2.64.0 the resource was accepted and listed by `oc get`, tested earlier against a placeholder URL. The console view was not opened. The URL on the slide is the repository the site publishes from r1.1; check the listing after that deploy.
-What to show: `oc get projecthelmchartrepository -n hfd-ocp` on a CRC host; the console listing needs the r1.1 site deploy.
+              <a:t>What it shows: A `ProjectHelmChartRepository` makes a chart repository visible in the Developer console's Helm catalog for one project. On OpenShift Local 2.64.0 the resource was accepted with the published URL, the console pod read the index (HTTP 200) and `helm search repo` listed all six charts. The console's catalog listing needs a browser login and was not opened.
+What to show: `oc get projecthelmchartrepository -n hfd-ocp` on a CRC host; open Developer, Helm, Create to see the catalog.
 Fallback: the YAML on this slide and the chapter 27 section on the Developer console.</a:t>
             </a:r>
             <a:endParaRPr lang="en-US" dirty="0"/>

</xml_diff>